<commit_message>
Migrate from Next.js to Astro with React
Replace Next.js framework with Astro + @astrojs/react for static site
generation. Add language pages, text alternatives pages, Canvas/PDF/
PowerPoint content, audio demos, and supporting assets. Update .gitignore
for Astro build artifacts.

Co-authored-by: Cursor <cursoragent@cursor.com>
</commit_message>
<xml_diff>
--- a/Test files/images/Image-PowerPoint.pptx
+++ b/Test files/images/Image-PowerPoint.pptx
@@ -4,12 +4,18 @@
   <p:sldMasterIdLst>
     <p:sldMasterId id="2147483648" r:id="rId1"/>
   </p:sldMasterIdLst>
+  <p:notesMasterIdLst>
+    <p:notesMasterId r:id="rId10"/>
+  </p:notesMasterIdLst>
   <p:sldIdLst>
     <p:sldId id="257" r:id="rId2"/>
     <p:sldId id="258" r:id="rId3"/>
     <p:sldId id="259" r:id="rId4"/>
     <p:sldId id="260" r:id="rId5"/>
-    <p:sldId id="261" r:id="rId6"/>
+    <p:sldId id="264" r:id="rId6"/>
+    <p:sldId id="261" r:id="rId7"/>
+    <p:sldId id="262" r:id="rId8"/>
+    <p:sldId id="263" r:id="rId9"/>
   </p:sldIdLst>
   <p:sldSz cx="12192000" cy="6858000"/>
   <p:notesSz cx="6858000" cy="9144000"/>
@@ -108,1037 +114,553 @@
       </a:defRPr>
     </a:lvl9pPr>
   </p:defaultTextStyle>
+  <p:extLst>
+    <p:ext uri="{EFAFB233-063F-42B5-8137-9DF3F51BA10A}">
+      <p15:sldGuideLst xmlns:p15="http://schemas.microsoft.com/office/powerpoint/2012/main"/>
+    </p:ext>
+  </p:extLst>
 </p:presentation>
 </file>
 
-<file path=ppt/charts/chart1.xml><?xml version="1.0" encoding="utf-8"?>
-<c:chartSpace xmlns:c="http://schemas.openxmlformats.org/drawingml/2006/chart" xmlns:a="http://schemas.openxmlformats.org/drawingml/2006/main" xmlns:r="http://schemas.openxmlformats.org/officeDocument/2006/relationships" xmlns:c16r2="http://schemas.microsoft.com/office/drawing/2015/06/chart">
-  <c:date1904 val="0"/>
-  <c:lang val="en-US"/>
-  <c:roundedCorners val="0"/>
-  <mc:AlternateContent xmlns:mc="http://schemas.openxmlformats.org/markup-compatibility/2006">
-    <mc:Choice xmlns:c14="http://schemas.microsoft.com/office/drawing/2007/8/2/chart" Requires="c14">
-      <c14:style val="102"/>
-    </mc:Choice>
-    <mc:Fallback>
-      <c:style val="2"/>
-    </mc:Fallback>
-  </mc:AlternateContent>
-  <c:chart>
-    <c:title>
-      <c:tx>
-        <c:rich>
-          <a:bodyPr rot="0" spcFirstLastPara="1" vertOverflow="ellipsis" vert="horz" wrap="square" anchor="ctr" anchorCtr="1"/>
+<file path=ppt/notesMasters/notesMaster1.xml><?xml version="1.0" encoding="utf-8"?>
+<p:notesMaster xmlns:a="http://schemas.openxmlformats.org/drawingml/2006/main" xmlns:r="http://schemas.openxmlformats.org/officeDocument/2006/relationships" xmlns:p="http://schemas.openxmlformats.org/presentationml/2006/main">
+  <p:cSld>
+    <p:bg>
+      <p:bgRef idx="1001">
+        <a:schemeClr val="bg1"/>
+      </p:bgRef>
+    </p:bg>
+    <p:spTree>
+      <p:nvGrpSpPr>
+        <p:cNvPr id="1" name=""/>
+        <p:cNvGrpSpPr/>
+        <p:nvPr/>
+      </p:nvGrpSpPr>
+      <p:grpSpPr>
+        <a:xfrm>
+          <a:off x="0" y="0"/>
+          <a:ext cx="0" cy="0"/>
+          <a:chOff x="0" y="0"/>
+          <a:chExt cx="0" cy="0"/>
+        </a:xfrm>
+      </p:grpSpPr>
+      <p:sp>
+        <p:nvSpPr>
+          <p:cNvPr id="2" name="Header Placeholder 1"/>
+          <p:cNvSpPr>
+            <a:spLocks noGrp="1"/>
+          </p:cNvSpPr>
+          <p:nvPr>
+            <p:ph type="hdr" sz="quarter"/>
+          </p:nvPr>
+        </p:nvSpPr>
+        <p:spPr>
+          <a:xfrm>
+            <a:off x="0" y="0"/>
+            <a:ext cx="2971800" cy="458788"/>
+          </a:xfrm>
+          <a:prstGeom prst="rect">
+            <a:avLst/>
+          </a:prstGeom>
+        </p:spPr>
+        <p:txBody>
+          <a:bodyPr vert="horz" lIns="91440" tIns="45720" rIns="91440" bIns="45720" rtlCol="0"/>
+          <a:lstStyle>
+            <a:lvl1pPr algn="l">
+              <a:defRPr sz="1200"/>
+            </a:lvl1pPr>
+          </a:lstStyle>
+          <a:p>
+            <a:endParaRPr lang="en-US"/>
+          </a:p>
+        </p:txBody>
+      </p:sp>
+      <p:sp>
+        <p:nvSpPr>
+          <p:cNvPr id="3" name="Date Placeholder 2"/>
+          <p:cNvSpPr>
+            <a:spLocks noGrp="1"/>
+          </p:cNvSpPr>
+          <p:nvPr>
+            <p:ph type="dt" idx="1"/>
+          </p:nvPr>
+        </p:nvSpPr>
+        <p:spPr>
+          <a:xfrm>
+            <a:off x="3884613" y="0"/>
+            <a:ext cx="2971800" cy="458788"/>
+          </a:xfrm>
+          <a:prstGeom prst="rect">
+            <a:avLst/>
+          </a:prstGeom>
+        </p:spPr>
+        <p:txBody>
+          <a:bodyPr vert="horz" lIns="91440" tIns="45720" rIns="91440" bIns="45720" rtlCol="0"/>
+          <a:lstStyle>
+            <a:lvl1pPr algn="r">
+              <a:defRPr sz="1200"/>
+            </a:lvl1pPr>
+          </a:lstStyle>
+          <a:p>
+            <a:fld id="{12790E82-B582-0F4E-B2B3-2D64CFCFBDC7}" type="datetimeFigureOut">
+              <a:rPr lang="en-US" smtClean="0"/>
+              <a:t>2/16/26</a:t>
+            </a:fld>
+            <a:endParaRPr lang="en-US"/>
+          </a:p>
+        </p:txBody>
+      </p:sp>
+      <p:sp>
+        <p:nvSpPr>
+          <p:cNvPr id="4" name="Slide Image Placeholder 3"/>
+          <p:cNvSpPr>
+            <a:spLocks noGrp="1" noRot="1" noChangeAspect="1"/>
+          </p:cNvSpPr>
+          <p:nvPr>
+            <p:ph type="sldImg" idx="2"/>
+          </p:nvPr>
+        </p:nvSpPr>
+        <p:spPr>
+          <a:xfrm>
+            <a:off x="685800" y="1143000"/>
+            <a:ext cx="5486400" cy="3086100"/>
+          </a:xfrm>
+          <a:prstGeom prst="rect">
+            <a:avLst/>
+          </a:prstGeom>
+          <a:noFill/>
+          <a:ln w="12700">
+            <a:solidFill>
+              <a:prstClr val="black"/>
+            </a:solidFill>
+          </a:ln>
+        </p:spPr>
+        <p:txBody>
+          <a:bodyPr vert="horz" lIns="91440" tIns="45720" rIns="91440" bIns="45720" rtlCol="0" anchor="ctr"/>
           <a:lstStyle/>
           <a:p>
-            <a:pPr>
-              <a:defRPr sz="1400" b="0" i="0" u="none" strike="noStrike" kern="1200" spc="0" baseline="0">
-                <a:solidFill>
-                  <a:schemeClr val="tx1">
-                    <a:lumMod val="65000"/>
-                    <a:lumOff val="35000"/>
-                  </a:schemeClr>
-                </a:solidFill>
-                <a:latin typeface="+mn-lt"/>
-                <a:ea typeface="+mn-ea"/>
-                <a:cs typeface="+mn-cs"/>
-              </a:defRPr>
-            </a:pPr>
+            <a:endParaRPr lang="en-US"/>
+          </a:p>
+        </p:txBody>
+      </p:sp>
+      <p:sp>
+        <p:nvSpPr>
+          <p:cNvPr id="5" name="Notes Placeholder 4"/>
+          <p:cNvSpPr>
+            <a:spLocks noGrp="1"/>
+          </p:cNvSpPr>
+          <p:nvPr>
+            <p:ph type="body" sz="quarter" idx="3"/>
+          </p:nvPr>
+        </p:nvSpPr>
+        <p:spPr>
+          <a:xfrm>
+            <a:off x="685800" y="4400550"/>
+            <a:ext cx="5486400" cy="3600450"/>
+          </a:xfrm>
+          <a:prstGeom prst="rect">
+            <a:avLst/>
+          </a:prstGeom>
+        </p:spPr>
+        <p:txBody>
+          <a:bodyPr vert="horz" lIns="91440" tIns="45720" rIns="91440" bIns="45720" rtlCol="0"/>
+          <a:lstStyle/>
+          <a:p>
+            <a:pPr lvl="0"/>
             <a:r>
               <a:rPr lang="en-US"/>
-              <a:t>Quiz</a:t>
-            </a:r>
-            <a:r>
-              <a:rPr lang="en-US" baseline="0"/>
-              <a:t> averages</a:t>
-            </a:r>
+              <a:t>Click to edit Master text styles</a:t>
+            </a:r>
+          </a:p>
+          <a:p>
+            <a:pPr lvl="1"/>
+            <a:r>
+              <a:rPr lang="en-US"/>
+              <a:t>Second level</a:t>
+            </a:r>
+          </a:p>
+          <a:p>
+            <a:pPr lvl="2"/>
+            <a:r>
+              <a:rPr lang="en-US"/>
+              <a:t>Third level</a:t>
+            </a:r>
+          </a:p>
+          <a:p>
+            <a:pPr lvl="3"/>
+            <a:r>
+              <a:rPr lang="en-US"/>
+              <a:t>Fourth level</a:t>
+            </a:r>
+          </a:p>
+          <a:p>
+            <a:pPr lvl="4"/>
+            <a:r>
+              <a:rPr lang="en-US"/>
+              <a:t>Fifth level</a:t>
+            </a:r>
+          </a:p>
+        </p:txBody>
+      </p:sp>
+      <p:sp>
+        <p:nvSpPr>
+          <p:cNvPr id="6" name="Footer Placeholder 5"/>
+          <p:cNvSpPr>
+            <a:spLocks noGrp="1"/>
+          </p:cNvSpPr>
+          <p:nvPr>
+            <p:ph type="ftr" sz="quarter" idx="4"/>
+          </p:nvPr>
+        </p:nvSpPr>
+        <p:spPr>
+          <a:xfrm>
+            <a:off x="0" y="8685213"/>
+            <a:ext cx="2971800" cy="458787"/>
+          </a:xfrm>
+          <a:prstGeom prst="rect">
+            <a:avLst/>
+          </a:prstGeom>
+        </p:spPr>
+        <p:txBody>
+          <a:bodyPr vert="horz" lIns="91440" tIns="45720" rIns="91440" bIns="45720" rtlCol="0" anchor="b"/>
+          <a:lstStyle>
+            <a:lvl1pPr algn="l">
+              <a:defRPr sz="1200"/>
+            </a:lvl1pPr>
+          </a:lstStyle>
+          <a:p>
             <a:endParaRPr lang="en-US"/>
           </a:p>
-        </c:rich>
-      </c:tx>
-      <c:overlay val="0"/>
-      <c:spPr>
-        <a:noFill/>
-        <a:ln>
-          <a:noFill/>
-        </a:ln>
-        <a:effectLst/>
-      </c:spPr>
-      <c:txPr>
-        <a:bodyPr rot="0" spcFirstLastPara="1" vertOverflow="ellipsis" vert="horz" wrap="square" anchor="ctr" anchorCtr="1"/>
-        <a:lstStyle/>
-        <a:p>
-          <a:pPr>
-            <a:defRPr sz="1400" b="0" i="0" u="none" strike="noStrike" kern="1200" spc="0" baseline="0">
-              <a:solidFill>
-                <a:schemeClr val="tx1">
-                  <a:lumMod val="65000"/>
-                  <a:lumOff val="35000"/>
-                </a:schemeClr>
-              </a:solidFill>
-              <a:latin typeface="+mn-lt"/>
-              <a:ea typeface="+mn-ea"/>
-              <a:cs typeface="+mn-cs"/>
-            </a:defRPr>
-          </a:pPr>
-          <a:endParaRPr lang="en-US"/>
-        </a:p>
-      </c:txPr>
-    </c:title>
-    <c:autoTitleDeleted val="0"/>
-    <c:plotArea>
-      <c:layout/>
-      <c:barChart>
-        <c:barDir val="col"/>
-        <c:grouping val="clustered"/>
-        <c:varyColors val="0"/>
-        <c:ser>
-          <c:idx val="0"/>
-          <c:order val="0"/>
-          <c:tx>
-            <c:strRef>
-              <c:f>Sheet1!$B$1</c:f>
-              <c:strCache>
-                <c:ptCount val="1"/>
-                <c:pt idx="0">
-                  <c:v>Quiz 1 Average</c:v>
-                </c:pt>
-              </c:strCache>
-            </c:strRef>
-          </c:tx>
-          <c:spPr>
-            <a:solidFill>
-              <a:schemeClr val="accent1"/>
-            </a:solidFill>
-            <a:ln>
-              <a:noFill/>
-            </a:ln>
-            <a:effectLst/>
-          </c:spPr>
-          <c:invertIfNegative val="0"/>
-          <c:cat>
-            <c:strRef>
-              <c:f>Sheet1!$A$2:$A$5</c:f>
-              <c:strCache>
-                <c:ptCount val="4"/>
-                <c:pt idx="0">
-                  <c:v>Section 1</c:v>
-                </c:pt>
-                <c:pt idx="1">
-                  <c:v>Section 2</c:v>
-                </c:pt>
-                <c:pt idx="2">
-                  <c:v>Section 3</c:v>
-                </c:pt>
-                <c:pt idx="3">
-                  <c:v>Section 4</c:v>
-                </c:pt>
-              </c:strCache>
-            </c:strRef>
-          </c:cat>
-          <c:val>
-            <c:numRef>
-              <c:f>Sheet1!$B$2:$B$5</c:f>
-              <c:numCache>
-                <c:formatCode>0%</c:formatCode>
-                <c:ptCount val="4"/>
-                <c:pt idx="0">
-                  <c:v>0.85</c:v>
-                </c:pt>
-                <c:pt idx="1">
-                  <c:v>0.83</c:v>
-                </c:pt>
-                <c:pt idx="2">
-                  <c:v>0.85</c:v>
-                </c:pt>
-                <c:pt idx="3">
-                  <c:v>0.87</c:v>
-                </c:pt>
-              </c:numCache>
-            </c:numRef>
-          </c:val>
-          <c:extLst>
-            <c:ext xmlns:c16="http://schemas.microsoft.com/office/drawing/2014/chart" uri="{C3380CC4-5D6E-409C-BE32-E72D297353CC}">
-              <c16:uniqueId val="{00000000-49BE-1D45-83C4-CF7C11F11BB0}"/>
-            </c:ext>
-          </c:extLst>
-        </c:ser>
-        <c:ser>
-          <c:idx val="1"/>
-          <c:order val="1"/>
-          <c:tx>
-            <c:strRef>
-              <c:f>Sheet1!$C$1</c:f>
-              <c:strCache>
-                <c:ptCount val="1"/>
-                <c:pt idx="0">
-                  <c:v>Quiz 2 Average</c:v>
-                </c:pt>
-              </c:strCache>
-            </c:strRef>
-          </c:tx>
-          <c:spPr>
-            <a:solidFill>
-              <a:schemeClr val="accent2"/>
-            </a:solidFill>
-            <a:ln>
-              <a:noFill/>
-            </a:ln>
-            <a:effectLst/>
-          </c:spPr>
-          <c:invertIfNegative val="0"/>
-          <c:cat>
-            <c:strRef>
-              <c:f>Sheet1!$A$2:$A$5</c:f>
-              <c:strCache>
-                <c:ptCount val="4"/>
-                <c:pt idx="0">
-                  <c:v>Section 1</c:v>
-                </c:pt>
-                <c:pt idx="1">
-                  <c:v>Section 2</c:v>
-                </c:pt>
-                <c:pt idx="2">
-                  <c:v>Section 3</c:v>
-                </c:pt>
-                <c:pt idx="3">
-                  <c:v>Section 4</c:v>
-                </c:pt>
-              </c:strCache>
-            </c:strRef>
-          </c:cat>
-          <c:val>
-            <c:numRef>
-              <c:f>Sheet1!$C$2:$C$5</c:f>
-              <c:numCache>
-                <c:formatCode>0%</c:formatCode>
-                <c:ptCount val="4"/>
-                <c:pt idx="0">
-                  <c:v>0.82</c:v>
-                </c:pt>
-                <c:pt idx="1">
-                  <c:v>0.81</c:v>
-                </c:pt>
-                <c:pt idx="2">
-                  <c:v>0.82</c:v>
-                </c:pt>
-                <c:pt idx="3">
-                  <c:v>0.79</c:v>
-                </c:pt>
-              </c:numCache>
-            </c:numRef>
-          </c:val>
-          <c:extLst>
-            <c:ext xmlns:c16="http://schemas.microsoft.com/office/drawing/2014/chart" uri="{C3380CC4-5D6E-409C-BE32-E72D297353CC}">
-              <c16:uniqueId val="{00000001-49BE-1D45-83C4-CF7C11F11BB0}"/>
-            </c:ext>
-          </c:extLst>
-        </c:ser>
-        <c:ser>
-          <c:idx val="2"/>
-          <c:order val="2"/>
-          <c:tx>
-            <c:strRef>
-              <c:f>Sheet1!$D$1</c:f>
-              <c:strCache>
-                <c:ptCount val="1"/>
-                <c:pt idx="0">
-                  <c:v>Quiz 3 Average</c:v>
-                </c:pt>
-              </c:strCache>
-            </c:strRef>
-          </c:tx>
-          <c:spPr>
-            <a:solidFill>
-              <a:schemeClr val="accent3"/>
-            </a:solidFill>
-            <a:ln>
-              <a:noFill/>
-            </a:ln>
-            <a:effectLst/>
-          </c:spPr>
-          <c:invertIfNegative val="0"/>
-          <c:cat>
-            <c:strRef>
-              <c:f>Sheet1!$A$2:$A$5</c:f>
-              <c:strCache>
-                <c:ptCount val="4"/>
-                <c:pt idx="0">
-                  <c:v>Section 1</c:v>
-                </c:pt>
-                <c:pt idx="1">
-                  <c:v>Section 2</c:v>
-                </c:pt>
-                <c:pt idx="2">
-                  <c:v>Section 3</c:v>
-                </c:pt>
-                <c:pt idx="3">
-                  <c:v>Section 4</c:v>
-                </c:pt>
-              </c:strCache>
-            </c:strRef>
-          </c:cat>
-          <c:val>
-            <c:numRef>
-              <c:f>Sheet1!$D$2:$D$5</c:f>
-              <c:numCache>
-                <c:formatCode>0%</c:formatCode>
-                <c:ptCount val="4"/>
-                <c:pt idx="0">
-                  <c:v>0.91</c:v>
-                </c:pt>
-                <c:pt idx="1">
-                  <c:v>0.9</c:v>
-                </c:pt>
-                <c:pt idx="2">
-                  <c:v>0.9</c:v>
-                </c:pt>
-                <c:pt idx="3">
-                  <c:v>0.93</c:v>
-                </c:pt>
-              </c:numCache>
-            </c:numRef>
-          </c:val>
-          <c:extLst>
-            <c:ext xmlns:c16="http://schemas.microsoft.com/office/drawing/2014/chart" uri="{C3380CC4-5D6E-409C-BE32-E72D297353CC}">
-              <c16:uniqueId val="{00000002-49BE-1D45-83C4-CF7C11F11BB0}"/>
-            </c:ext>
-          </c:extLst>
-        </c:ser>
-        <c:dLbls>
-          <c:showLegendKey val="0"/>
-          <c:showVal val="0"/>
-          <c:showCatName val="0"/>
-          <c:showSerName val="0"/>
-          <c:showPercent val="0"/>
-          <c:showBubbleSize val="0"/>
-        </c:dLbls>
-        <c:gapWidth val="219"/>
-        <c:overlap val="-27"/>
-        <c:axId val="1408948224"/>
-        <c:axId val="1409147776"/>
-      </c:barChart>
-      <c:catAx>
-        <c:axId val="1408948224"/>
-        <c:scaling>
-          <c:orientation val="minMax"/>
-        </c:scaling>
-        <c:delete val="0"/>
-        <c:axPos val="b"/>
-        <c:numFmt formatCode="General" sourceLinked="1"/>
-        <c:majorTickMark val="none"/>
-        <c:minorTickMark val="none"/>
-        <c:tickLblPos val="nextTo"/>
-        <c:spPr>
-          <a:noFill/>
-          <a:ln w="9525" cap="flat" cmpd="sng" algn="ctr">
-            <a:solidFill>
-              <a:schemeClr val="tx1">
-                <a:lumMod val="15000"/>
-                <a:lumOff val="85000"/>
-              </a:schemeClr>
-            </a:solidFill>
-            <a:round/>
-          </a:ln>
-          <a:effectLst/>
-        </c:spPr>
-        <c:txPr>
-          <a:bodyPr rot="-60000000" spcFirstLastPara="1" vertOverflow="ellipsis" vert="horz" wrap="square" anchor="ctr" anchorCtr="1"/>
-          <a:lstStyle/>
-          <a:p>
-            <a:pPr>
-              <a:defRPr sz="900" b="0" i="0" u="none" strike="noStrike" kern="1200" baseline="0">
-                <a:solidFill>
-                  <a:schemeClr val="tx1">
-                    <a:lumMod val="65000"/>
-                    <a:lumOff val="35000"/>
-                  </a:schemeClr>
-                </a:solidFill>
-                <a:latin typeface="+mn-lt"/>
-                <a:ea typeface="+mn-ea"/>
-                <a:cs typeface="+mn-cs"/>
-              </a:defRPr>
-            </a:pPr>
+        </p:txBody>
+      </p:sp>
+      <p:sp>
+        <p:nvSpPr>
+          <p:cNvPr id="7" name="Slide Number Placeholder 6"/>
+          <p:cNvSpPr>
+            <a:spLocks noGrp="1"/>
+          </p:cNvSpPr>
+          <p:nvPr>
+            <p:ph type="sldNum" sz="quarter" idx="5"/>
+          </p:nvPr>
+        </p:nvSpPr>
+        <p:spPr>
+          <a:xfrm>
+            <a:off x="3884613" y="8685213"/>
+            <a:ext cx="2971800" cy="458787"/>
+          </a:xfrm>
+          <a:prstGeom prst="rect">
+            <a:avLst/>
+          </a:prstGeom>
+        </p:spPr>
+        <p:txBody>
+          <a:bodyPr vert="horz" lIns="91440" tIns="45720" rIns="91440" bIns="45720" rtlCol="0" anchor="b"/>
+          <a:lstStyle>
+            <a:lvl1pPr algn="r">
+              <a:defRPr sz="1200"/>
+            </a:lvl1pPr>
+          </a:lstStyle>
+          <a:p>
+            <a:fld id="{7104191A-9A8A-8845-9F9D-290305B59B8B}" type="slidenum">
+              <a:rPr lang="en-US" smtClean="0"/>
+              <a:t>‹#›</a:t>
+            </a:fld>
             <a:endParaRPr lang="en-US"/>
           </a:p>
-        </c:txPr>
-        <c:crossAx val="1409147776"/>
-        <c:crosses val="autoZero"/>
-        <c:auto val="1"/>
-        <c:lblAlgn val="ctr"/>
-        <c:lblOffset val="100"/>
-        <c:noMultiLvlLbl val="0"/>
-      </c:catAx>
-      <c:valAx>
-        <c:axId val="1409147776"/>
-        <c:scaling>
-          <c:orientation val="minMax"/>
-        </c:scaling>
-        <c:delete val="0"/>
-        <c:axPos val="l"/>
-        <c:majorGridlines>
-          <c:spPr>
-            <a:ln w="9525" cap="flat" cmpd="sng" algn="ctr">
-              <a:solidFill>
-                <a:schemeClr val="tx1">
-                  <a:lumMod val="15000"/>
-                  <a:lumOff val="85000"/>
-                </a:schemeClr>
-              </a:solidFill>
-              <a:round/>
-            </a:ln>
-            <a:effectLst/>
-          </c:spPr>
-        </c:majorGridlines>
-        <c:numFmt formatCode="0%" sourceLinked="1"/>
-        <c:majorTickMark val="none"/>
-        <c:minorTickMark val="none"/>
-        <c:tickLblPos val="nextTo"/>
-        <c:spPr>
-          <a:noFill/>
-          <a:ln>
-            <a:noFill/>
-          </a:ln>
-          <a:effectLst/>
-        </c:spPr>
-        <c:txPr>
-          <a:bodyPr rot="-60000000" spcFirstLastPara="1" vertOverflow="ellipsis" vert="horz" wrap="square" anchor="ctr" anchorCtr="1"/>
-          <a:lstStyle/>
-          <a:p>
-            <a:pPr>
-              <a:defRPr sz="900" b="0" i="0" u="none" strike="noStrike" kern="1200" baseline="0">
-                <a:solidFill>
-                  <a:schemeClr val="tx1">
-                    <a:lumMod val="65000"/>
-                    <a:lumOff val="35000"/>
-                  </a:schemeClr>
-                </a:solidFill>
-                <a:latin typeface="+mn-lt"/>
-                <a:ea typeface="+mn-ea"/>
-                <a:cs typeface="+mn-cs"/>
-              </a:defRPr>
-            </a:pPr>
-            <a:endParaRPr lang="en-US"/>
-          </a:p>
-        </c:txPr>
-        <c:crossAx val="1408948224"/>
-        <c:crosses val="autoZero"/>
-        <c:crossBetween val="between"/>
-      </c:valAx>
-      <c:spPr>
-        <a:noFill/>
-        <a:ln>
-          <a:noFill/>
-        </a:ln>
-        <a:effectLst/>
-      </c:spPr>
-    </c:plotArea>
-    <c:legend>
-      <c:legendPos val="b"/>
-      <c:overlay val="0"/>
-      <c:spPr>
-        <a:noFill/>
-        <a:ln>
-          <a:noFill/>
-        </a:ln>
-        <a:effectLst/>
-      </c:spPr>
-      <c:txPr>
-        <a:bodyPr rot="0" spcFirstLastPara="1" vertOverflow="ellipsis" vert="horz" wrap="square" anchor="ctr" anchorCtr="1"/>
-        <a:lstStyle/>
-        <a:p>
-          <a:pPr>
-            <a:defRPr sz="900" b="0" i="0" u="none" strike="noStrike" kern="1200" baseline="0">
-              <a:solidFill>
-                <a:schemeClr val="tx1">
-                  <a:lumMod val="65000"/>
-                  <a:lumOff val="35000"/>
-                </a:schemeClr>
-              </a:solidFill>
-              <a:latin typeface="+mn-lt"/>
-              <a:ea typeface="+mn-ea"/>
-              <a:cs typeface="+mn-cs"/>
-            </a:defRPr>
-          </a:pPr>
-          <a:endParaRPr lang="en-US"/>
-        </a:p>
-      </c:txPr>
-    </c:legend>
-    <c:plotVisOnly val="1"/>
-    <c:dispBlanksAs val="gap"/>
-    <c:showDLblsOverMax val="0"/>
-    <c:extLst>
-      <c:ext xmlns:c16r3="http://schemas.microsoft.com/office/drawing/2017/03/chart" uri="{56B9EC1D-385E-4148-901F-78D8002777C0}">
-        <c16r3:dataDisplayOptions16>
-          <c16r3:dispNaAsBlank val="1"/>
-        </c16r3:dataDisplayOptions16>
-      </c:ext>
-    </c:extLst>
-  </c:chart>
-  <c:spPr>
-    <a:noFill/>
-    <a:ln>
-      <a:noFill/>
-    </a:ln>
-    <a:effectLst/>
-  </c:spPr>
-  <c:txPr>
-    <a:bodyPr/>
-    <a:lstStyle/>
-    <a:p>
-      <a:pPr>
-        <a:defRPr/>
-      </a:pPr>
-      <a:endParaRPr lang="en-US"/>
-    </a:p>
-  </c:txPr>
-  <c:externalData r:id="rId3">
-    <c:autoUpdate val="0"/>
-  </c:externalData>
-</c:chartSpace>
+        </p:txBody>
+      </p:sp>
+    </p:spTree>
+    <p:extLst>
+      <p:ext uri="{BB962C8B-B14F-4D97-AF65-F5344CB8AC3E}">
+        <p14:creationId xmlns:p14="http://schemas.microsoft.com/office/powerpoint/2010/main" val="3922559854"/>
+      </p:ext>
+    </p:extLst>
+  </p:cSld>
+  <p:clrMap bg1="lt1" tx1="dk1" bg2="lt2" tx2="dk2" accent1="accent1" accent2="accent2" accent3="accent3" accent4="accent4" accent5="accent5" accent6="accent6" hlink="hlink" folHlink="folHlink"/>
+  <p:notesStyle>
+    <a:lvl1pPr marL="0" algn="l" defTabSz="914400" rtl="0" eaLnBrk="1" latinLnBrk="0" hangingPunct="1">
+      <a:defRPr sz="1200" kern="1200">
+        <a:solidFill>
+          <a:schemeClr val="tx1"/>
+        </a:solidFill>
+        <a:latin typeface="+mn-lt"/>
+        <a:ea typeface="+mn-ea"/>
+        <a:cs typeface="+mn-cs"/>
+      </a:defRPr>
+    </a:lvl1pPr>
+    <a:lvl2pPr marL="457200" algn="l" defTabSz="914400" rtl="0" eaLnBrk="1" latinLnBrk="0" hangingPunct="1">
+      <a:defRPr sz="1200" kern="1200">
+        <a:solidFill>
+          <a:schemeClr val="tx1"/>
+        </a:solidFill>
+        <a:latin typeface="+mn-lt"/>
+        <a:ea typeface="+mn-ea"/>
+        <a:cs typeface="+mn-cs"/>
+      </a:defRPr>
+    </a:lvl2pPr>
+    <a:lvl3pPr marL="914400" algn="l" defTabSz="914400" rtl="0" eaLnBrk="1" latinLnBrk="0" hangingPunct="1">
+      <a:defRPr sz="1200" kern="1200">
+        <a:solidFill>
+          <a:schemeClr val="tx1"/>
+        </a:solidFill>
+        <a:latin typeface="+mn-lt"/>
+        <a:ea typeface="+mn-ea"/>
+        <a:cs typeface="+mn-cs"/>
+      </a:defRPr>
+    </a:lvl3pPr>
+    <a:lvl4pPr marL="1371600" algn="l" defTabSz="914400" rtl="0" eaLnBrk="1" latinLnBrk="0" hangingPunct="1">
+      <a:defRPr sz="1200" kern="1200">
+        <a:solidFill>
+          <a:schemeClr val="tx1"/>
+        </a:solidFill>
+        <a:latin typeface="+mn-lt"/>
+        <a:ea typeface="+mn-ea"/>
+        <a:cs typeface="+mn-cs"/>
+      </a:defRPr>
+    </a:lvl4pPr>
+    <a:lvl5pPr marL="1828800" algn="l" defTabSz="914400" rtl="0" eaLnBrk="1" latinLnBrk="0" hangingPunct="1">
+      <a:defRPr sz="1200" kern="1200">
+        <a:solidFill>
+          <a:schemeClr val="tx1"/>
+        </a:solidFill>
+        <a:latin typeface="+mn-lt"/>
+        <a:ea typeface="+mn-ea"/>
+        <a:cs typeface="+mn-cs"/>
+      </a:defRPr>
+    </a:lvl5pPr>
+    <a:lvl6pPr marL="2286000" algn="l" defTabSz="914400" rtl="0" eaLnBrk="1" latinLnBrk="0" hangingPunct="1">
+      <a:defRPr sz="1200" kern="1200">
+        <a:solidFill>
+          <a:schemeClr val="tx1"/>
+        </a:solidFill>
+        <a:latin typeface="+mn-lt"/>
+        <a:ea typeface="+mn-ea"/>
+        <a:cs typeface="+mn-cs"/>
+      </a:defRPr>
+    </a:lvl6pPr>
+    <a:lvl7pPr marL="2743200" algn="l" defTabSz="914400" rtl="0" eaLnBrk="1" latinLnBrk="0" hangingPunct="1">
+      <a:defRPr sz="1200" kern="1200">
+        <a:solidFill>
+          <a:schemeClr val="tx1"/>
+        </a:solidFill>
+        <a:latin typeface="+mn-lt"/>
+        <a:ea typeface="+mn-ea"/>
+        <a:cs typeface="+mn-cs"/>
+      </a:defRPr>
+    </a:lvl7pPr>
+    <a:lvl8pPr marL="3200400" algn="l" defTabSz="914400" rtl="0" eaLnBrk="1" latinLnBrk="0" hangingPunct="1">
+      <a:defRPr sz="1200" kern="1200">
+        <a:solidFill>
+          <a:schemeClr val="tx1"/>
+        </a:solidFill>
+        <a:latin typeface="+mn-lt"/>
+        <a:ea typeface="+mn-ea"/>
+        <a:cs typeface="+mn-cs"/>
+      </a:defRPr>
+    </a:lvl8pPr>
+    <a:lvl9pPr marL="3657600" algn="l" defTabSz="914400" rtl="0" eaLnBrk="1" latinLnBrk="0" hangingPunct="1">
+      <a:defRPr sz="1200" kern="1200">
+        <a:solidFill>
+          <a:schemeClr val="tx1"/>
+        </a:solidFill>
+        <a:latin typeface="+mn-lt"/>
+        <a:ea typeface="+mn-ea"/>
+        <a:cs typeface="+mn-cs"/>
+      </a:defRPr>
+    </a:lvl9pPr>
+  </p:notesStyle>
+</p:notesMaster>
 </file>
 
-<file path=ppt/charts/colors1.xml><?xml version="1.0" encoding="utf-8"?>
-<cs:colorStyle xmlns:cs="http://schemas.microsoft.com/office/drawing/2012/chartStyle" xmlns:a="http://schemas.openxmlformats.org/drawingml/2006/main" meth="cycle" id="10">
-  <a:schemeClr val="accent1"/>
-  <a:schemeClr val="accent2"/>
-  <a:schemeClr val="accent3"/>
-  <a:schemeClr val="accent4"/>
-  <a:schemeClr val="accent5"/>
-  <a:schemeClr val="accent6"/>
-  <cs:variation/>
-  <cs:variation>
-    <a:lumMod val="60000"/>
-  </cs:variation>
-  <cs:variation>
-    <a:lumMod val="80000"/>
-    <a:lumOff val="20000"/>
-  </cs:variation>
-  <cs:variation>
-    <a:lumMod val="80000"/>
-  </cs:variation>
-  <cs:variation>
-    <a:lumMod val="60000"/>
-    <a:lumOff val="40000"/>
-  </cs:variation>
-  <cs:variation>
-    <a:lumMod val="50000"/>
-  </cs:variation>
-  <cs:variation>
-    <a:lumMod val="70000"/>
-    <a:lumOff val="30000"/>
-  </cs:variation>
-  <cs:variation>
-    <a:lumMod val="70000"/>
-  </cs:variation>
-  <cs:variation>
-    <a:lumMod val="50000"/>
-    <a:lumOff val="50000"/>
-  </cs:variation>
-</cs:colorStyle>
+<file path=ppt/notesSlides/notesSlide1.xml><?xml version="1.0" encoding="utf-8"?>
+<p:notes xmlns:a="http://schemas.openxmlformats.org/drawingml/2006/main" xmlns:r="http://schemas.openxmlformats.org/officeDocument/2006/relationships" xmlns:p="http://schemas.openxmlformats.org/presentationml/2006/main">
+  <p:cSld>
+    <p:spTree>
+      <p:nvGrpSpPr>
+        <p:cNvPr id="1" name=""/>
+        <p:cNvGrpSpPr/>
+        <p:nvPr/>
+      </p:nvGrpSpPr>
+      <p:grpSpPr>
+        <a:xfrm>
+          <a:off x="0" y="0"/>
+          <a:ext cx="0" cy="0"/>
+          <a:chOff x="0" y="0"/>
+          <a:chExt cx="0" cy="0"/>
+        </a:xfrm>
+      </p:grpSpPr>
+      <p:sp>
+        <p:nvSpPr>
+          <p:cNvPr id="2" name="Slide Image Placeholder 1"/>
+          <p:cNvSpPr>
+            <a:spLocks noGrp="1" noRot="1" noChangeAspect="1"/>
+          </p:cNvSpPr>
+          <p:nvPr>
+            <p:ph type="sldImg"/>
+          </p:nvPr>
+        </p:nvSpPr>
+        <p:spPr/>
+      </p:sp>
+      <p:sp>
+        <p:nvSpPr>
+          <p:cNvPr id="3" name="Notes Placeholder 2"/>
+          <p:cNvSpPr>
+            <a:spLocks noGrp="1"/>
+          </p:cNvSpPr>
+          <p:nvPr>
+            <p:ph type="body" idx="1"/>
+          </p:nvPr>
+        </p:nvSpPr>
+        <p:spPr/>
+        <p:txBody>
+          <a:bodyPr/>
+          <a:lstStyle/>
+          <a:p>
+            <a:endParaRPr lang="en-US" dirty="0"/>
+          </a:p>
+        </p:txBody>
+      </p:sp>
+      <p:sp>
+        <p:nvSpPr>
+          <p:cNvPr id="4" name="Slide Number Placeholder 3"/>
+          <p:cNvSpPr>
+            <a:spLocks noGrp="1"/>
+          </p:cNvSpPr>
+          <p:nvPr>
+            <p:ph type="sldNum" sz="quarter" idx="5"/>
+          </p:nvPr>
+        </p:nvSpPr>
+        <p:spPr/>
+        <p:txBody>
+          <a:bodyPr/>
+          <a:lstStyle/>
+          <a:p>
+            <a:fld id="{7104191A-9A8A-8845-9F9D-290305B59B8B}" type="slidenum">
+              <a:rPr lang="en-US" smtClean="0"/>
+              <a:t>4</a:t>
+            </a:fld>
+            <a:endParaRPr lang="en-US"/>
+          </a:p>
+        </p:txBody>
+      </p:sp>
+    </p:spTree>
+    <p:extLst>
+      <p:ext uri="{BB962C8B-B14F-4D97-AF65-F5344CB8AC3E}">
+        <p14:creationId xmlns:p14="http://schemas.microsoft.com/office/powerpoint/2010/main" val="4139298559"/>
+      </p:ext>
+    </p:extLst>
+  </p:cSld>
+  <p:clrMapOvr>
+    <a:masterClrMapping/>
+  </p:clrMapOvr>
+</p:notes>
 </file>
 
-<file path=ppt/charts/style1.xml><?xml version="1.0" encoding="utf-8"?>
-<cs:chartStyle xmlns:cs="http://schemas.microsoft.com/office/drawing/2012/chartStyle" xmlns:a="http://schemas.openxmlformats.org/drawingml/2006/main" id="201">
-  <cs:axisTitle>
-    <cs:lnRef idx="0"/>
-    <cs:fillRef idx="0"/>
-    <cs:effectRef idx="0"/>
-    <cs:fontRef idx="minor">
-      <a:schemeClr val="tx1">
-        <a:lumMod val="65000"/>
-        <a:lumOff val="35000"/>
-      </a:schemeClr>
-    </cs:fontRef>
-    <cs:defRPr sz="1000" kern="1200"/>
-  </cs:axisTitle>
-  <cs:categoryAxis>
-    <cs:lnRef idx="0"/>
-    <cs:fillRef idx="0"/>
-    <cs:effectRef idx="0"/>
-    <cs:fontRef idx="minor">
-      <a:schemeClr val="tx1">
-        <a:lumMod val="65000"/>
-        <a:lumOff val="35000"/>
-      </a:schemeClr>
-    </cs:fontRef>
-    <cs:spPr>
-      <a:ln w="9525" cap="flat" cmpd="sng" algn="ctr">
-        <a:solidFill>
-          <a:schemeClr val="tx1">
-            <a:lumMod val="15000"/>
-            <a:lumOff val="85000"/>
-          </a:schemeClr>
-        </a:solidFill>
-        <a:round/>
-      </a:ln>
-    </cs:spPr>
-    <cs:defRPr sz="900" kern="1200"/>
-  </cs:categoryAxis>
-  <cs:chartArea mods="allowNoFillOverride allowNoLineOverride">
-    <cs:lnRef idx="0"/>
-    <cs:fillRef idx="0"/>
-    <cs:effectRef idx="0"/>
-    <cs:fontRef idx="minor">
-      <a:schemeClr val="tx1"/>
-    </cs:fontRef>
-    <cs:spPr>
-      <a:solidFill>
-        <a:schemeClr val="bg1"/>
-      </a:solidFill>
-      <a:ln w="9525" cap="flat" cmpd="sng" algn="ctr">
-        <a:solidFill>
-          <a:schemeClr val="tx1">
-            <a:lumMod val="15000"/>
-            <a:lumOff val="85000"/>
-          </a:schemeClr>
-        </a:solidFill>
-        <a:round/>
-      </a:ln>
-    </cs:spPr>
-    <cs:defRPr sz="1000" kern="1200"/>
-  </cs:chartArea>
-  <cs:dataLabel>
-    <cs:lnRef idx="0"/>
-    <cs:fillRef idx="0"/>
-    <cs:effectRef idx="0"/>
-    <cs:fontRef idx="minor">
-      <a:schemeClr val="tx1">
-        <a:lumMod val="75000"/>
-        <a:lumOff val="25000"/>
-      </a:schemeClr>
-    </cs:fontRef>
-    <cs:defRPr sz="900" kern="1200"/>
-  </cs:dataLabel>
-  <cs:dataLabelCallout>
-    <cs:lnRef idx="0"/>
-    <cs:fillRef idx="0"/>
-    <cs:effectRef idx="0"/>
-    <cs:fontRef idx="minor">
-      <a:schemeClr val="dk1">
-        <a:lumMod val="65000"/>
-        <a:lumOff val="35000"/>
-      </a:schemeClr>
-    </cs:fontRef>
-    <cs:spPr>
-      <a:solidFill>
-        <a:schemeClr val="lt1"/>
-      </a:solidFill>
-      <a:ln>
-        <a:solidFill>
-          <a:schemeClr val="dk1">
-            <a:lumMod val="25000"/>
-            <a:lumOff val="75000"/>
-          </a:schemeClr>
-        </a:solidFill>
-      </a:ln>
-    </cs:spPr>
-    <cs:defRPr sz="900" kern="1200"/>
-    <cs:bodyPr rot="0" spcFirstLastPara="1" vertOverflow="clip" horzOverflow="clip" vert="horz" wrap="square" lIns="36576" tIns="18288" rIns="36576" bIns="18288" anchor="ctr" anchorCtr="1">
-      <a:spAutoFit/>
-    </cs:bodyPr>
-  </cs:dataLabelCallout>
-  <cs:dataPoint>
-    <cs:lnRef idx="0"/>
-    <cs:fillRef idx="1">
-      <cs:styleClr val="auto"/>
-    </cs:fillRef>
-    <cs:effectRef idx="0"/>
-    <cs:fontRef idx="minor">
-      <a:schemeClr val="tx1"/>
-    </cs:fontRef>
-  </cs:dataPoint>
-  <cs:dataPoint3D>
-    <cs:lnRef idx="0"/>
-    <cs:fillRef idx="1">
-      <cs:styleClr val="auto"/>
-    </cs:fillRef>
-    <cs:effectRef idx="0"/>
-    <cs:fontRef idx="minor">
-      <a:schemeClr val="tx1"/>
-    </cs:fontRef>
-  </cs:dataPoint3D>
-  <cs:dataPointLine>
-    <cs:lnRef idx="0">
-      <cs:styleClr val="auto"/>
-    </cs:lnRef>
-    <cs:fillRef idx="1"/>
-    <cs:effectRef idx="0"/>
-    <cs:fontRef idx="minor">
-      <a:schemeClr val="tx1"/>
-    </cs:fontRef>
-    <cs:spPr>
-      <a:ln w="28575" cap="rnd">
-        <a:solidFill>
-          <a:schemeClr val="phClr"/>
-        </a:solidFill>
-        <a:round/>
-      </a:ln>
-    </cs:spPr>
-  </cs:dataPointLine>
-  <cs:dataPointMarker>
-    <cs:lnRef idx="0">
-      <cs:styleClr val="auto"/>
-    </cs:lnRef>
-    <cs:fillRef idx="1">
-      <cs:styleClr val="auto"/>
-    </cs:fillRef>
-    <cs:effectRef idx="0"/>
-    <cs:fontRef idx="minor">
-      <a:schemeClr val="tx1"/>
-    </cs:fontRef>
-    <cs:spPr>
-      <a:ln w="9525">
-        <a:solidFill>
-          <a:schemeClr val="phClr"/>
-        </a:solidFill>
-      </a:ln>
-    </cs:spPr>
-  </cs:dataPointMarker>
-  <cs:dataPointMarkerLayout symbol="circle" size="5"/>
-  <cs:dataPointWireframe>
-    <cs:lnRef idx="0">
-      <cs:styleClr val="auto"/>
-    </cs:lnRef>
-    <cs:fillRef idx="1"/>
-    <cs:effectRef idx="0"/>
-    <cs:fontRef idx="minor">
-      <a:schemeClr val="tx1"/>
-    </cs:fontRef>
-    <cs:spPr>
-      <a:ln w="9525" cap="rnd">
-        <a:solidFill>
-          <a:schemeClr val="phClr"/>
-        </a:solidFill>
-        <a:round/>
-      </a:ln>
-    </cs:spPr>
-  </cs:dataPointWireframe>
-  <cs:dataTable>
-    <cs:lnRef idx="0"/>
-    <cs:fillRef idx="0"/>
-    <cs:effectRef idx="0"/>
-    <cs:fontRef idx="minor">
-      <a:schemeClr val="tx1">
-        <a:lumMod val="65000"/>
-        <a:lumOff val="35000"/>
-      </a:schemeClr>
-    </cs:fontRef>
-    <cs:spPr>
-      <a:noFill/>
-      <a:ln w="9525" cap="flat" cmpd="sng" algn="ctr">
-        <a:solidFill>
-          <a:schemeClr val="tx1">
-            <a:lumMod val="15000"/>
-            <a:lumOff val="85000"/>
-          </a:schemeClr>
-        </a:solidFill>
-        <a:round/>
-      </a:ln>
-    </cs:spPr>
-    <cs:defRPr sz="900" kern="1200"/>
-  </cs:dataTable>
-  <cs:downBar>
-    <cs:lnRef idx="0"/>
-    <cs:fillRef idx="0"/>
-    <cs:effectRef idx="0"/>
-    <cs:fontRef idx="minor">
-      <a:schemeClr val="dk1"/>
-    </cs:fontRef>
-    <cs:spPr>
-      <a:solidFill>
-        <a:schemeClr val="dk1">
-          <a:lumMod val="65000"/>
-          <a:lumOff val="35000"/>
-        </a:schemeClr>
-      </a:solidFill>
-      <a:ln w="9525">
-        <a:solidFill>
-          <a:schemeClr val="tx1">
-            <a:lumMod val="65000"/>
-            <a:lumOff val="35000"/>
-          </a:schemeClr>
-        </a:solidFill>
-      </a:ln>
-    </cs:spPr>
-  </cs:downBar>
-  <cs:dropLine>
-    <cs:lnRef idx="0"/>
-    <cs:fillRef idx="0"/>
-    <cs:effectRef idx="0"/>
-    <cs:fontRef idx="minor">
-      <a:schemeClr val="tx1"/>
-    </cs:fontRef>
-    <cs:spPr>
-      <a:ln w="9525" cap="flat" cmpd="sng" algn="ctr">
-        <a:solidFill>
-          <a:schemeClr val="tx1">
-            <a:lumMod val="35000"/>
-            <a:lumOff val="65000"/>
-          </a:schemeClr>
-        </a:solidFill>
-        <a:round/>
-      </a:ln>
-    </cs:spPr>
-  </cs:dropLine>
-  <cs:errorBar>
-    <cs:lnRef idx="0"/>
-    <cs:fillRef idx="0"/>
-    <cs:effectRef idx="0"/>
-    <cs:fontRef idx="minor">
-      <a:schemeClr val="tx1"/>
-    </cs:fontRef>
-    <cs:spPr>
-      <a:ln w="9525" cap="flat" cmpd="sng" algn="ctr">
-        <a:solidFill>
-          <a:schemeClr val="tx1">
-            <a:lumMod val="65000"/>
-            <a:lumOff val="35000"/>
-          </a:schemeClr>
-        </a:solidFill>
-        <a:round/>
-      </a:ln>
-    </cs:spPr>
-  </cs:errorBar>
-  <cs:floor>
-    <cs:lnRef idx="0"/>
-    <cs:fillRef idx="0"/>
-    <cs:effectRef idx="0"/>
-    <cs:fontRef idx="minor">
-      <a:schemeClr val="tx1"/>
-    </cs:fontRef>
-    <cs:spPr>
-      <a:noFill/>
-      <a:ln>
-        <a:noFill/>
-      </a:ln>
-    </cs:spPr>
-  </cs:floor>
-  <cs:gridlineMajor>
-    <cs:lnRef idx="0"/>
-    <cs:fillRef idx="0"/>
-    <cs:effectRef idx="0"/>
-    <cs:fontRef idx="minor">
-      <a:schemeClr val="tx1"/>
-    </cs:fontRef>
-    <cs:spPr>
-      <a:ln w="9525" cap="flat" cmpd="sng" algn="ctr">
-        <a:solidFill>
-          <a:schemeClr val="tx1">
-            <a:lumMod val="15000"/>
-            <a:lumOff val="85000"/>
-          </a:schemeClr>
-        </a:solidFill>
-        <a:round/>
-      </a:ln>
-    </cs:spPr>
-  </cs:gridlineMajor>
-  <cs:gridlineMinor>
-    <cs:lnRef idx="0"/>
-    <cs:fillRef idx="0"/>
-    <cs:effectRef idx="0"/>
-    <cs:fontRef idx="minor">
-      <a:schemeClr val="tx1"/>
-    </cs:fontRef>
-    <cs:spPr>
-      <a:ln w="9525" cap="flat" cmpd="sng" algn="ctr">
-        <a:solidFill>
-          <a:schemeClr val="tx1">
-            <a:lumMod val="5000"/>
-            <a:lumOff val="95000"/>
-          </a:schemeClr>
-        </a:solidFill>
-        <a:round/>
-      </a:ln>
-    </cs:spPr>
-  </cs:gridlineMinor>
-  <cs:hiLoLine>
-    <cs:lnRef idx="0"/>
-    <cs:fillRef idx="0"/>
-    <cs:effectRef idx="0"/>
-    <cs:fontRef idx="minor">
-      <a:schemeClr val="tx1"/>
-    </cs:fontRef>
-    <cs:spPr>
-      <a:ln w="9525" cap="flat" cmpd="sng" algn="ctr">
-        <a:solidFill>
-          <a:schemeClr val="tx1">
-            <a:lumMod val="75000"/>
-            <a:lumOff val="25000"/>
-          </a:schemeClr>
-        </a:solidFill>
-        <a:round/>
-      </a:ln>
-    </cs:spPr>
-  </cs:hiLoLine>
-  <cs:leaderLine>
-    <cs:lnRef idx="0"/>
-    <cs:fillRef idx="0"/>
-    <cs:effectRef idx="0"/>
-    <cs:fontRef idx="minor">
-      <a:schemeClr val="tx1"/>
-    </cs:fontRef>
-    <cs:spPr>
-      <a:ln w="9525" cap="flat" cmpd="sng" algn="ctr">
-        <a:solidFill>
-          <a:schemeClr val="tx1">
-            <a:lumMod val="35000"/>
-            <a:lumOff val="65000"/>
-          </a:schemeClr>
-        </a:solidFill>
-        <a:round/>
-      </a:ln>
-    </cs:spPr>
-  </cs:leaderLine>
-  <cs:legend>
-    <cs:lnRef idx="0"/>
-    <cs:fillRef idx="0"/>
-    <cs:effectRef idx="0"/>
-    <cs:fontRef idx="minor">
-      <a:schemeClr val="tx1">
-        <a:lumMod val="65000"/>
-        <a:lumOff val="35000"/>
-      </a:schemeClr>
-    </cs:fontRef>
-    <cs:defRPr sz="900" kern="1200"/>
-  </cs:legend>
-  <cs:plotArea mods="allowNoFillOverride allowNoLineOverride">
-    <cs:lnRef idx="0"/>
-    <cs:fillRef idx="0"/>
-    <cs:effectRef idx="0"/>
-    <cs:fontRef idx="minor">
-      <a:schemeClr val="tx1"/>
-    </cs:fontRef>
-  </cs:plotArea>
-  <cs:plotArea3D mods="allowNoFillOverride allowNoLineOverride">
-    <cs:lnRef idx="0"/>
-    <cs:fillRef idx="0"/>
-    <cs:effectRef idx="0"/>
-    <cs:fontRef idx="minor">
-      <a:schemeClr val="tx1"/>
-    </cs:fontRef>
-  </cs:plotArea3D>
-  <cs:seriesAxis>
-    <cs:lnRef idx="0"/>
-    <cs:fillRef idx="0"/>
-    <cs:effectRef idx="0"/>
-    <cs:fontRef idx="minor">
-      <a:schemeClr val="tx1">
-        <a:lumMod val="65000"/>
-        <a:lumOff val="35000"/>
-      </a:schemeClr>
-    </cs:fontRef>
-    <cs:defRPr sz="900" kern="1200"/>
-  </cs:seriesAxis>
-  <cs:seriesLine>
-    <cs:lnRef idx="0"/>
-    <cs:fillRef idx="0"/>
-    <cs:effectRef idx="0"/>
-    <cs:fontRef idx="minor">
-      <a:schemeClr val="tx1"/>
-    </cs:fontRef>
-    <cs:spPr>
-      <a:ln w="9525" cap="flat" cmpd="sng" algn="ctr">
-        <a:solidFill>
-          <a:schemeClr val="tx1">
-            <a:lumMod val="35000"/>
-            <a:lumOff val="65000"/>
-          </a:schemeClr>
-        </a:solidFill>
-        <a:round/>
-      </a:ln>
-    </cs:spPr>
-  </cs:seriesLine>
-  <cs:title>
-    <cs:lnRef idx="0"/>
-    <cs:fillRef idx="0"/>
-    <cs:effectRef idx="0"/>
-    <cs:fontRef idx="minor">
-      <a:schemeClr val="tx1">
-        <a:lumMod val="65000"/>
-        <a:lumOff val="35000"/>
-      </a:schemeClr>
-    </cs:fontRef>
-    <cs:defRPr sz="1400" b="0" kern="1200" spc="0" baseline="0"/>
-  </cs:title>
-  <cs:trendline>
-    <cs:lnRef idx="0">
-      <cs:styleClr val="auto"/>
-    </cs:lnRef>
-    <cs:fillRef idx="0"/>
-    <cs:effectRef idx="0"/>
-    <cs:fontRef idx="minor">
-      <a:schemeClr val="tx1"/>
-    </cs:fontRef>
-    <cs:spPr>
-      <a:ln w="19050" cap="rnd">
-        <a:solidFill>
-          <a:schemeClr val="phClr"/>
-        </a:solidFill>
-        <a:prstDash val="sysDot"/>
-      </a:ln>
-    </cs:spPr>
-  </cs:trendline>
-  <cs:trendlineLabel>
-    <cs:lnRef idx="0"/>
-    <cs:fillRef idx="0"/>
-    <cs:effectRef idx="0"/>
-    <cs:fontRef idx="minor">
-      <a:schemeClr val="tx1">
-        <a:lumMod val="65000"/>
-        <a:lumOff val="35000"/>
-      </a:schemeClr>
-    </cs:fontRef>
-    <cs:defRPr sz="900" kern="1200"/>
-  </cs:trendlineLabel>
-  <cs:upBar>
-    <cs:lnRef idx="0"/>
-    <cs:fillRef idx="0"/>
-    <cs:effectRef idx="0"/>
-    <cs:fontRef idx="minor">
-      <a:schemeClr val="dk1"/>
-    </cs:fontRef>
-    <cs:spPr>
-      <a:solidFill>
-        <a:schemeClr val="lt1"/>
-      </a:solidFill>
-      <a:ln w="9525">
-        <a:solidFill>
-          <a:schemeClr val="tx1">
-            <a:lumMod val="15000"/>
-            <a:lumOff val="85000"/>
-          </a:schemeClr>
-        </a:solidFill>
-      </a:ln>
-    </cs:spPr>
-  </cs:upBar>
-  <cs:valueAxis>
-    <cs:lnRef idx="0"/>
-    <cs:fillRef idx="0"/>
-    <cs:effectRef idx="0"/>
-    <cs:fontRef idx="minor">
-      <a:schemeClr val="tx1">
-        <a:lumMod val="65000"/>
-        <a:lumOff val="35000"/>
-      </a:schemeClr>
-    </cs:fontRef>
-    <cs:defRPr sz="900" kern="1200"/>
-  </cs:valueAxis>
-  <cs:wall>
-    <cs:lnRef idx="0"/>
-    <cs:fillRef idx="0"/>
-    <cs:effectRef idx="0"/>
-    <cs:fontRef idx="minor">
-      <a:schemeClr val="tx1"/>
-    </cs:fontRef>
-    <cs:spPr>
-      <a:noFill/>
-      <a:ln>
-        <a:noFill/>
-      </a:ln>
-    </cs:spPr>
-  </cs:wall>
-</cs:chartStyle>
+<file path=ppt/notesSlides/notesSlide2.xml><?xml version="1.0" encoding="utf-8"?>
+<p:notes xmlns:a="http://schemas.openxmlformats.org/drawingml/2006/main" xmlns:r="http://schemas.openxmlformats.org/officeDocument/2006/relationships" xmlns:p="http://schemas.openxmlformats.org/presentationml/2006/main">
+  <p:cSld>
+    <p:spTree>
+      <p:nvGrpSpPr>
+        <p:cNvPr id="1" name="">
+          <a:extLst>
+            <a:ext uri="{FF2B5EF4-FFF2-40B4-BE49-F238E27FC236}">
+              <a16:creationId xmlns:a16="http://schemas.microsoft.com/office/drawing/2014/main" id="{BA942ED2-9738-A010-2718-E197FE3990E8}"/>
+            </a:ext>
+          </a:extLst>
+        </p:cNvPr>
+        <p:cNvGrpSpPr/>
+        <p:nvPr/>
+      </p:nvGrpSpPr>
+      <p:grpSpPr>
+        <a:xfrm>
+          <a:off x="0" y="0"/>
+          <a:ext cx="0" cy="0"/>
+          <a:chOff x="0" y="0"/>
+          <a:chExt cx="0" cy="0"/>
+        </a:xfrm>
+      </p:grpSpPr>
+      <p:sp>
+        <p:nvSpPr>
+          <p:cNvPr id="2" name="Slide Image Placeholder 1">
+            <a:extLst>
+              <a:ext uri="{FF2B5EF4-FFF2-40B4-BE49-F238E27FC236}">
+                <a16:creationId xmlns:a16="http://schemas.microsoft.com/office/drawing/2014/main" id="{7BD5CC7B-106A-F3A4-63C8-7C66DFB3847B}"/>
+              </a:ext>
+            </a:extLst>
+          </p:cNvPr>
+          <p:cNvSpPr>
+            <a:spLocks noGrp="1" noRot="1" noChangeAspect="1"/>
+          </p:cNvSpPr>
+          <p:nvPr>
+            <p:ph type="sldImg"/>
+          </p:nvPr>
+        </p:nvSpPr>
+        <p:spPr/>
+      </p:sp>
+      <p:sp>
+        <p:nvSpPr>
+          <p:cNvPr id="3" name="Notes Placeholder 2">
+            <a:extLst>
+              <a:ext uri="{FF2B5EF4-FFF2-40B4-BE49-F238E27FC236}">
+                <a16:creationId xmlns:a16="http://schemas.microsoft.com/office/drawing/2014/main" id="{EB95A59F-FA75-FAF6-A02E-F9421D6DD3B7}"/>
+              </a:ext>
+            </a:extLst>
+          </p:cNvPr>
+          <p:cNvSpPr>
+            <a:spLocks noGrp="1"/>
+          </p:cNvSpPr>
+          <p:nvPr>
+            <p:ph type="body" idx="1"/>
+          </p:nvPr>
+        </p:nvSpPr>
+        <p:spPr/>
+        <p:txBody>
+          <a:bodyPr/>
+          <a:lstStyle/>
+          <a:p>
+            <a:endParaRPr lang="en-US" dirty="0"/>
+          </a:p>
+        </p:txBody>
+      </p:sp>
+      <p:sp>
+        <p:nvSpPr>
+          <p:cNvPr id="4" name="Slide Number Placeholder 3">
+            <a:extLst>
+              <a:ext uri="{FF2B5EF4-FFF2-40B4-BE49-F238E27FC236}">
+                <a16:creationId xmlns:a16="http://schemas.microsoft.com/office/drawing/2014/main" id="{831FC0E5-78E8-46B6-A9E3-8F0A3B22AA95}"/>
+              </a:ext>
+            </a:extLst>
+          </p:cNvPr>
+          <p:cNvSpPr>
+            <a:spLocks noGrp="1"/>
+          </p:cNvSpPr>
+          <p:nvPr>
+            <p:ph type="sldNum" sz="quarter" idx="5"/>
+          </p:nvPr>
+        </p:nvSpPr>
+        <p:spPr/>
+        <p:txBody>
+          <a:bodyPr/>
+          <a:lstStyle/>
+          <a:p>
+            <a:fld id="{7104191A-9A8A-8845-9F9D-290305B59B8B}" type="slidenum">
+              <a:rPr lang="en-US" smtClean="0"/>
+              <a:t>5</a:t>
+            </a:fld>
+            <a:endParaRPr lang="en-US"/>
+          </a:p>
+        </p:txBody>
+      </p:sp>
+    </p:spTree>
+    <p:extLst>
+      <p:ext uri="{BB962C8B-B14F-4D97-AF65-F5344CB8AC3E}">
+        <p14:creationId xmlns:p14="http://schemas.microsoft.com/office/powerpoint/2010/main" val="3666731827"/>
+      </p:ext>
+    </p:extLst>
+  </p:cSld>
+  <p:clrMapOvr>
+    <a:masterClrMapping/>
+  </p:clrMapOvr>
+</p:notes>
 </file>
 
 <file path=ppt/slideLayouts/slideLayout1.xml><?xml version="1.0" encoding="utf-8"?>
@@ -1288,7 +810,7 @@
           <a:p>
             <a:fld id="{A84DC69A-EA2F-A746-8DAA-A22638E842CE}" type="datetimeFigureOut">
               <a:rPr lang="en-US" smtClean="0"/>
-              <a:t>2/14/26</a:t>
+              <a:t>2/16/26</a:t>
             </a:fld>
             <a:endParaRPr lang="en-US"/>
           </a:p>
@@ -1486,7 +1008,7 @@
           <a:p>
             <a:fld id="{A84DC69A-EA2F-A746-8DAA-A22638E842CE}" type="datetimeFigureOut">
               <a:rPr lang="en-US" smtClean="0"/>
-              <a:t>2/14/26</a:t>
+              <a:t>2/16/26</a:t>
             </a:fld>
             <a:endParaRPr lang="en-US"/>
           </a:p>
@@ -1694,7 +1216,7 @@
           <a:p>
             <a:fld id="{A84DC69A-EA2F-A746-8DAA-A22638E842CE}" type="datetimeFigureOut">
               <a:rPr lang="en-US" smtClean="0"/>
-              <a:t>2/14/26</a:t>
+              <a:t>2/16/26</a:t>
             </a:fld>
             <a:endParaRPr lang="en-US"/>
           </a:p>
@@ -1892,7 +1414,7 @@
           <a:p>
             <a:fld id="{A84DC69A-EA2F-A746-8DAA-A22638E842CE}" type="datetimeFigureOut">
               <a:rPr lang="en-US" smtClean="0"/>
-              <a:t>2/14/26</a:t>
+              <a:t>2/16/26</a:t>
             </a:fld>
             <a:endParaRPr lang="en-US"/>
           </a:p>
@@ -2167,7 +1689,7 @@
           <a:p>
             <a:fld id="{A84DC69A-EA2F-A746-8DAA-A22638E842CE}" type="datetimeFigureOut">
               <a:rPr lang="en-US" smtClean="0"/>
-              <a:t>2/14/26</a:t>
+              <a:t>2/16/26</a:t>
             </a:fld>
             <a:endParaRPr lang="en-US"/>
           </a:p>
@@ -2432,7 +1954,7 @@
           <a:p>
             <a:fld id="{A84DC69A-EA2F-A746-8DAA-A22638E842CE}" type="datetimeFigureOut">
               <a:rPr lang="en-US" smtClean="0"/>
-              <a:t>2/14/26</a:t>
+              <a:t>2/16/26</a:t>
             </a:fld>
             <a:endParaRPr lang="en-US"/>
           </a:p>
@@ -2844,7 +2366,7 @@
           <a:p>
             <a:fld id="{A84DC69A-EA2F-A746-8DAA-A22638E842CE}" type="datetimeFigureOut">
               <a:rPr lang="en-US" smtClean="0"/>
-              <a:t>2/14/26</a:t>
+              <a:t>2/16/26</a:t>
             </a:fld>
             <a:endParaRPr lang="en-US"/>
           </a:p>
@@ -2985,7 +2507,7 @@
           <a:p>
             <a:fld id="{A84DC69A-EA2F-A746-8DAA-A22638E842CE}" type="datetimeFigureOut">
               <a:rPr lang="en-US" smtClean="0"/>
-              <a:t>2/14/26</a:t>
+              <a:t>2/16/26</a:t>
             </a:fld>
             <a:endParaRPr lang="en-US"/>
           </a:p>
@@ -3098,7 +2620,7 @@
           <a:p>
             <a:fld id="{A84DC69A-EA2F-A746-8DAA-A22638E842CE}" type="datetimeFigureOut">
               <a:rPr lang="en-US" smtClean="0"/>
-              <a:t>2/14/26</a:t>
+              <a:t>2/16/26</a:t>
             </a:fld>
             <a:endParaRPr lang="en-US"/>
           </a:p>
@@ -3409,7 +2931,7 @@
           <a:p>
             <a:fld id="{A84DC69A-EA2F-A746-8DAA-A22638E842CE}" type="datetimeFigureOut">
               <a:rPr lang="en-US" smtClean="0"/>
-              <a:t>2/14/26</a:t>
+              <a:t>2/16/26</a:t>
             </a:fld>
             <a:endParaRPr lang="en-US"/>
           </a:p>
@@ -3697,7 +3219,7 @@
           <a:p>
             <a:fld id="{A84DC69A-EA2F-A746-8DAA-A22638E842CE}" type="datetimeFigureOut">
               <a:rPr lang="en-US" smtClean="0"/>
-              <a:t>2/14/26</a:t>
+              <a:t>2/16/26</a:t>
             </a:fld>
             <a:endParaRPr lang="en-US"/>
           </a:p>
@@ -3938,7 +3460,7 @@
           <a:p>
             <a:fld id="{A84DC69A-EA2F-A746-8DAA-A22638E842CE}" type="datetimeFigureOut">
               <a:rPr lang="en-US" smtClean="0"/>
-              <a:t>2/14/26</a:t>
+              <a:t>2/16/26</a:t>
             </a:fld>
             <a:endParaRPr lang="en-US"/>
           </a:p>
@@ -4474,399 +3996,7 @@
           <p:nvPr>
             <p:extLst>
               <p:ext uri="{D42A27DB-BD31-4B8C-83A1-F6EECF244321}">
-                <p14:modId xmlns:p14="http://schemas.microsoft.com/office/powerpoint/2010/main" val="2308287501"/>
-              </p:ext>
-            </p:extLst>
-          </p:nvPr>
-        </p:nvGraphicFramePr>
-        <p:xfrm>
-          <a:off x="810440" y="5354380"/>
-          <a:ext cx="7518573" cy="1169544"/>
-        </p:xfrm>
-        <a:graphic>
-          <a:graphicData uri="http://schemas.openxmlformats.org/drawingml/2006/table">
-            <a:tbl>
-              <a:tblPr firstRow="1" firstCol="1" bandRow="1">
-                <a:tableStyleId>{5C22544A-7EE6-4342-B048-85BDC9FD1C3A}</a:tableStyleId>
-              </a:tblPr>
-              <a:tblGrid>
-                <a:gridCol w="1713924">
-                  <a:extLst>
-                    <a:ext uri="{9D8B030D-6E8A-4147-A177-3AD203B41FA5}">
-                      <a16:colId xmlns:a16="http://schemas.microsoft.com/office/drawing/2014/main" val="2587052964"/>
-                    </a:ext>
-                  </a:extLst>
-                </a:gridCol>
-                <a:gridCol w="2794831">
-                  <a:extLst>
-                    <a:ext uri="{9D8B030D-6E8A-4147-A177-3AD203B41FA5}">
-                      <a16:colId xmlns:a16="http://schemas.microsoft.com/office/drawing/2014/main" val="1997474820"/>
-                    </a:ext>
-                  </a:extLst>
-                </a:gridCol>
-                <a:gridCol w="3009818">
-                  <a:extLst>
-                    <a:ext uri="{9D8B030D-6E8A-4147-A177-3AD203B41FA5}">
-                      <a16:colId xmlns:a16="http://schemas.microsoft.com/office/drawing/2014/main" val="123640046"/>
-                    </a:ext>
-                  </a:extLst>
-                </a:gridCol>
-              </a:tblGrid>
-              <a:tr h="771564">
-                <a:tc>
-                  <a:txBody>
-                    <a:bodyPr/>
-                    <a:lstStyle/>
-                    <a:p>
-                      <a:pPr marL="0" marR="0">
-                        <a:lnSpc>
-                          <a:spcPct val="115000"/>
-                        </a:lnSpc>
-                        <a:spcAft>
-                          <a:spcPts val="800"/>
-                        </a:spcAft>
-                        <a:buNone/>
-                      </a:pPr>
-                      <a:r>
-                        <a:rPr lang="en-US" sz="2300" kern="100">
-                          <a:effectLst/>
-                        </a:rPr>
-                        <a:t> </a:t>
-                      </a:r>
-                      <a:endParaRPr lang="en-US" sz="2300" kern="100">
-                        <a:effectLst/>
-                        <a:latin typeface="Aptos" panose="020B0004020202020204" pitchFamily="34" charset="0"/>
-                        <a:ea typeface="Aptos" panose="020B0004020202020204" pitchFamily="34" charset="0"/>
-                        <a:cs typeface="Times New Roman" panose="02020603050405020304" pitchFamily="18" charset="0"/>
-                      </a:endParaRPr>
-                    </a:p>
-                  </a:txBody>
-                  <a:tcPr marL="128992" marR="128992" marT="0" marB="0"/>
-                </a:tc>
-                <a:tc>
-                  <a:txBody>
-                    <a:bodyPr/>
-                    <a:lstStyle/>
-                    <a:p>
-                      <a:pPr marL="0" marR="0">
-                        <a:lnSpc>
-                          <a:spcPct val="115000"/>
-                        </a:lnSpc>
-                        <a:spcAft>
-                          <a:spcPts val="800"/>
-                        </a:spcAft>
-                        <a:buNone/>
-                      </a:pPr>
-                      <a:r>
-                        <a:rPr lang="en-US" sz="2300" kern="100">
-                          <a:effectLst/>
-                        </a:rPr>
-                        <a:t>A11y automated checker</a:t>
-                      </a:r>
-                      <a:endParaRPr lang="en-US" sz="2300" kern="100">
-                        <a:effectLst/>
-                        <a:latin typeface="Aptos" panose="020B0004020202020204" pitchFamily="34" charset="0"/>
-                        <a:ea typeface="Aptos" panose="020B0004020202020204" pitchFamily="34" charset="0"/>
-                        <a:cs typeface="Times New Roman" panose="02020603050405020304" pitchFamily="18" charset="0"/>
-                      </a:endParaRPr>
-                    </a:p>
-                  </a:txBody>
-                  <a:tcPr marL="128992" marR="128992" marT="0" marB="0"/>
-                </a:tc>
-                <a:tc>
-                  <a:txBody>
-                    <a:bodyPr/>
-                    <a:lstStyle/>
-                    <a:p>
-                      <a:pPr marL="0" marR="0">
-                        <a:lnSpc>
-                          <a:spcPct val="115000"/>
-                        </a:lnSpc>
-                        <a:spcAft>
-                          <a:spcPts val="800"/>
-                        </a:spcAft>
-                        <a:buNone/>
-                      </a:pPr>
-                      <a:r>
-                        <a:rPr lang="en-US" sz="2300" kern="100" dirty="0">
-                          <a:effectLst/>
-                        </a:rPr>
-                        <a:t>MS Accessibility checker</a:t>
-                      </a:r>
-                      <a:endParaRPr lang="en-US" sz="2300" kern="100" dirty="0">
-                        <a:effectLst/>
-                        <a:latin typeface="Aptos" panose="020B0004020202020204" pitchFamily="34" charset="0"/>
-                        <a:ea typeface="Aptos" panose="020B0004020202020204" pitchFamily="34" charset="0"/>
-                        <a:cs typeface="Times New Roman" panose="02020603050405020304" pitchFamily="18" charset="0"/>
-                      </a:endParaRPr>
-                    </a:p>
-                  </a:txBody>
-                  <a:tcPr marL="128992" marR="128992" marT="0" marB="0"/>
-                </a:tc>
-                <a:extLst>
-                  <a:ext uri="{0D108BD9-81ED-4DB2-BD59-A6C34878D82A}">
-                    <a16:rowId xmlns:a16="http://schemas.microsoft.com/office/drawing/2014/main" val="2904024515"/>
-                  </a:ext>
-                </a:extLst>
-              </a:tr>
-              <a:tr h="376109">
-                <a:tc>
-                  <a:txBody>
-                    <a:bodyPr/>
-                    <a:lstStyle/>
-                    <a:p>
-                      <a:pPr marL="0" marR="0">
-                        <a:lnSpc>
-                          <a:spcPct val="115000"/>
-                        </a:lnSpc>
-                        <a:spcAft>
-                          <a:spcPts val="800"/>
-                        </a:spcAft>
-                        <a:buNone/>
-                      </a:pPr>
-                      <a:r>
-                        <a:rPr lang="en-US" sz="2300" kern="100">
-                          <a:effectLst/>
-                        </a:rPr>
-                        <a:t>Result</a:t>
-                      </a:r>
-                      <a:endParaRPr lang="en-US" sz="2300" kern="100">
-                        <a:effectLst/>
-                        <a:latin typeface="Aptos" panose="020B0004020202020204" pitchFamily="34" charset="0"/>
-                        <a:ea typeface="Aptos" panose="020B0004020202020204" pitchFamily="34" charset="0"/>
-                        <a:cs typeface="Times New Roman" panose="02020603050405020304" pitchFamily="18" charset="0"/>
-                      </a:endParaRPr>
-                    </a:p>
-                  </a:txBody>
-                  <a:tcPr marL="128992" marR="128992" marT="0" marB="0"/>
-                </a:tc>
-                <a:tc>
-                  <a:txBody>
-                    <a:bodyPr/>
-                    <a:lstStyle/>
-                    <a:p>
-                      <a:pPr marL="0" marR="0">
-                        <a:lnSpc>
-                          <a:spcPct val="115000"/>
-                        </a:lnSpc>
-                        <a:spcAft>
-                          <a:spcPts val="800"/>
-                        </a:spcAft>
-                        <a:buNone/>
-                      </a:pPr>
-                      <a:r>
-                        <a:rPr lang="en-US" sz="2300" kern="100">
-                          <a:effectLst/>
-                        </a:rPr>
-                        <a:t>Yes</a:t>
-                      </a:r>
-                      <a:endParaRPr lang="en-US" sz="2300" kern="100">
-                        <a:effectLst/>
-                        <a:latin typeface="Aptos" panose="020B0004020202020204" pitchFamily="34" charset="0"/>
-                        <a:ea typeface="Aptos" panose="020B0004020202020204" pitchFamily="34" charset="0"/>
-                        <a:cs typeface="Times New Roman" panose="02020603050405020304" pitchFamily="18" charset="0"/>
-                      </a:endParaRPr>
-                    </a:p>
-                  </a:txBody>
-                  <a:tcPr marL="128992" marR="128992" marT="0" marB="0"/>
-                </a:tc>
-                <a:tc>
-                  <a:txBody>
-                    <a:bodyPr/>
-                    <a:lstStyle/>
-                    <a:p>
-                      <a:pPr marL="0" marR="0">
-                        <a:lnSpc>
-                          <a:spcPct val="115000"/>
-                        </a:lnSpc>
-                        <a:spcAft>
-                          <a:spcPts val="800"/>
-                        </a:spcAft>
-                        <a:buNone/>
-                      </a:pPr>
-                      <a:r>
-                        <a:rPr lang="en-US" sz="2300" kern="100" dirty="0">
-                          <a:effectLst/>
-                        </a:rPr>
-                        <a:t>No</a:t>
-                      </a:r>
-                      <a:endParaRPr lang="en-US" sz="2300" kern="100" dirty="0">
-                        <a:effectLst/>
-                        <a:latin typeface="Aptos" panose="020B0004020202020204" pitchFamily="34" charset="0"/>
-                        <a:ea typeface="Aptos" panose="020B0004020202020204" pitchFamily="34" charset="0"/>
-                        <a:cs typeface="Times New Roman" panose="02020603050405020304" pitchFamily="18" charset="0"/>
-                      </a:endParaRPr>
-                    </a:p>
-                  </a:txBody>
-                  <a:tcPr marL="128992" marR="128992" marT="0" marB="0"/>
-                </a:tc>
-                <a:extLst>
-                  <a:ext uri="{0D108BD9-81ED-4DB2-BD59-A6C34878D82A}">
-                    <a16:rowId xmlns:a16="http://schemas.microsoft.com/office/drawing/2014/main" val="4046348799"/>
-                  </a:ext>
-                </a:extLst>
-              </a:tr>
-            </a:tbl>
-          </a:graphicData>
-        </a:graphic>
-      </p:graphicFrame>
-    </p:spTree>
-    <p:extLst>
-      <p:ext uri="{BB962C8B-B14F-4D97-AF65-F5344CB8AC3E}">
-        <p14:creationId xmlns:p14="http://schemas.microsoft.com/office/powerpoint/2010/main" val="3796369453"/>
-      </p:ext>
-    </p:extLst>
-  </p:cSld>
-  <p:clrMapOvr>
-    <a:masterClrMapping/>
-  </p:clrMapOvr>
-</p:sld>
-</file>
-
-<file path=ppt/slides/slide2.xml><?xml version="1.0" encoding="utf-8"?>
-<p:sld xmlns:a="http://schemas.openxmlformats.org/drawingml/2006/main" xmlns:r="http://schemas.openxmlformats.org/officeDocument/2006/relationships" xmlns:p="http://schemas.openxmlformats.org/presentationml/2006/main">
-  <p:cSld>
-    <p:spTree>
-      <p:nvGrpSpPr>
-        <p:cNvPr id="1" name="">
-          <a:extLst>
-            <a:ext uri="{FF2B5EF4-FFF2-40B4-BE49-F238E27FC236}">
-              <a16:creationId xmlns:a16="http://schemas.microsoft.com/office/drawing/2014/main" id="{434A0ACE-6316-7483-4F1E-9DA88BDFC0C8}"/>
-            </a:ext>
-          </a:extLst>
-        </p:cNvPr>
-        <p:cNvGrpSpPr/>
-        <p:nvPr/>
-      </p:nvGrpSpPr>
-      <p:grpSpPr>
-        <a:xfrm>
-          <a:off x="0" y="0"/>
-          <a:ext cx="0" cy="0"/>
-          <a:chOff x="0" y="0"/>
-          <a:chExt cx="0" cy="0"/>
-        </a:xfrm>
-      </p:grpSpPr>
-      <p:sp>
-        <p:nvSpPr>
-          <p:cNvPr id="2" name="Title 1">
-            <a:extLst>
-              <a:ext uri="{FF2B5EF4-FFF2-40B4-BE49-F238E27FC236}">
-                <a16:creationId xmlns:a16="http://schemas.microsoft.com/office/drawing/2014/main" id="{060CE1CD-B8FD-A046-A589-0F2855524798}"/>
-              </a:ext>
-            </a:extLst>
-          </p:cNvPr>
-          <p:cNvSpPr>
-            <a:spLocks noGrp="1"/>
-          </p:cNvSpPr>
-          <p:nvPr>
-            <p:ph type="title"/>
-          </p:nvPr>
-        </p:nvSpPr>
-        <p:spPr/>
-        <p:txBody>
-          <a:bodyPr/>
-          <a:lstStyle/>
-          <a:p>
-            <a:r>
-              <a:rPr lang="en-US" b="1" dirty="0"/>
-              <a:t>AI-generated text alternative</a:t>
-            </a:r>
-          </a:p>
-        </p:txBody>
-      </p:sp>
-      <p:sp>
-        <p:nvSpPr>
-          <p:cNvPr id="3" name="Content Placeholder 2">
-            <a:extLst>
-              <a:ext uri="{FF2B5EF4-FFF2-40B4-BE49-F238E27FC236}">
-                <a16:creationId xmlns:a16="http://schemas.microsoft.com/office/drawing/2014/main" id="{CA289B50-2125-F969-620B-A883AA50C7A8}"/>
-              </a:ext>
-            </a:extLst>
-          </p:cNvPr>
-          <p:cNvSpPr>
-            <a:spLocks noGrp="1"/>
-          </p:cNvSpPr>
-          <p:nvPr>
-            <p:ph idx="1"/>
-          </p:nvPr>
-        </p:nvSpPr>
-        <p:spPr>
-          <a:xfrm>
-            <a:off x="838200" y="1825624"/>
-            <a:ext cx="5325094" cy="3253003"/>
-          </a:xfrm>
-        </p:spPr>
-        <p:txBody>
-          <a:bodyPr>
-            <a:normAutofit/>
-          </a:bodyPr>
-          <a:lstStyle/>
-          <a:p>
-            <a:pPr marL="0" indent="0">
-              <a:buNone/>
-            </a:pPr>
-            <a:r>
-              <a:rPr lang="en-US" dirty="0"/>
-              <a:t>MS Word guessed the text alternative as “A black background with white text. AI-generated content may be incorrect.”</a:t>
-            </a:r>
-          </a:p>
-          <a:p>
-            <a:endParaRPr lang="en-US" dirty="0"/>
-          </a:p>
-        </p:txBody>
-      </p:sp>
-      <p:pic>
-        <p:nvPicPr>
-          <p:cNvPr id="5" name="Picture 4" descr="A black background with white text&#10;&#10;AI-generated content may be incorrect.">
-            <a:extLst>
-              <a:ext uri="{FF2B5EF4-FFF2-40B4-BE49-F238E27FC236}">
-                <a16:creationId xmlns:a16="http://schemas.microsoft.com/office/drawing/2014/main" id="{C8F80D74-DDD8-0E70-86FC-F137C3EA401C}"/>
-              </a:ext>
-            </a:extLst>
-          </p:cNvPr>
-          <p:cNvPicPr>
-            <a:picLocks noChangeAspect="1"/>
-          </p:cNvPicPr>
-          <p:nvPr/>
-        </p:nvPicPr>
-        <p:blipFill>
-          <a:blip r:embed="rId2" cstate="print">
-            <a:extLst>
-              <a:ext uri="{28A0092B-C50C-407E-A947-70E740481C1C}">
-                <a14:useLocalDpi xmlns:a14="http://schemas.microsoft.com/office/drawing/2010/main" val="0"/>
-              </a:ext>
-            </a:extLst>
-          </a:blip>
-          <a:stretch>
-            <a:fillRect/>
-          </a:stretch>
-        </p:blipFill>
-        <p:spPr>
-          <a:xfrm>
-            <a:off x="6511187" y="1964328"/>
-            <a:ext cx="3458318" cy="914795"/>
-          </a:xfrm>
-          <a:prstGeom prst="rect">
-            <a:avLst/>
-          </a:prstGeom>
-        </p:spPr>
-      </p:pic>
-      <p:graphicFrame>
-        <p:nvGraphicFramePr>
-          <p:cNvPr id="20" name="Table 19">
-            <a:extLst>
-              <a:ext uri="{FF2B5EF4-FFF2-40B4-BE49-F238E27FC236}">
-                <a16:creationId xmlns:a16="http://schemas.microsoft.com/office/drawing/2014/main" id="{DD097625-E068-0759-30BD-65B8C3FB2B94}"/>
-              </a:ext>
-            </a:extLst>
-          </p:cNvPr>
-          <p:cNvGraphicFramePr>
-            <a:graphicFrameLocks noGrp="1"/>
-          </p:cNvGraphicFramePr>
-          <p:nvPr>
-            <p:extLst>
-              <p:ext uri="{D42A27DB-BD31-4B8C-83A1-F6EECF244321}">
-                <p14:modId xmlns:p14="http://schemas.microsoft.com/office/powerpoint/2010/main" val="302967264"/>
+                <p14:modId xmlns:p14="http://schemas.microsoft.com/office/powerpoint/2010/main" val="4130325249"/>
               </p:ext>
             </p:extLst>
           </p:nvPr>
@@ -5049,10 +4179,299 @@
                       <a:r>
                         <a:rPr lang="en-US" sz="2300" kern="100" dirty="0">
                           <a:effectLst/>
+                          <a:latin typeface="Aptos" panose="020B0004020202020204" pitchFamily="34" charset="0"/>
+                          <a:ea typeface="Aptos" panose="020B0004020202020204" pitchFamily="34" charset="0"/>
+                          <a:cs typeface="Times New Roman" panose="02020603050405020304" pitchFamily="18" charset="0"/>
                         </a:rPr>
-                        <a:t>No</a:t>
+                        <a:t>Detected</a:t>
                       </a:r>
-                      <a:endParaRPr lang="en-US" sz="2300" kern="100" dirty="0">
+                    </a:p>
+                  </a:txBody>
+                  <a:tcPr marL="128992" marR="128992" marT="0" marB="0"/>
+                </a:tc>
+                <a:tc>
+                  <a:txBody>
+                    <a:bodyPr/>
+                    <a:lstStyle/>
+                    <a:p>
+                      <a:pPr marL="0" marR="0">
+                        <a:lnSpc>
+                          <a:spcPct val="115000"/>
+                        </a:lnSpc>
+                        <a:spcAft>
+                          <a:spcPts val="800"/>
+                        </a:spcAft>
+                        <a:buNone/>
+                      </a:pPr>
+                      <a:r>
+                        <a:rPr lang="en-US" sz="2300" kern="100" dirty="0">
+                          <a:effectLst/>
+                          <a:latin typeface="Aptos" panose="020B0004020202020204" pitchFamily="34" charset="0"/>
+                          <a:ea typeface="Aptos" panose="020B0004020202020204" pitchFamily="34" charset="0"/>
+                          <a:cs typeface="Times New Roman" panose="02020603050405020304" pitchFamily="18" charset="0"/>
+                        </a:rPr>
+                        <a:t>Detected</a:t>
+                      </a:r>
+                    </a:p>
+                  </a:txBody>
+                  <a:tcPr marL="128992" marR="128992" marT="0" marB="0"/>
+                </a:tc>
+                <a:extLst>
+                  <a:ext uri="{0D108BD9-81ED-4DB2-BD59-A6C34878D82A}">
+                    <a16:rowId xmlns:a16="http://schemas.microsoft.com/office/drawing/2014/main" val="4046348799"/>
+                  </a:ext>
+                </a:extLst>
+              </a:tr>
+            </a:tbl>
+          </a:graphicData>
+        </a:graphic>
+      </p:graphicFrame>
+    </p:spTree>
+    <p:extLst>
+      <p:ext uri="{BB962C8B-B14F-4D97-AF65-F5344CB8AC3E}">
+        <p14:creationId xmlns:p14="http://schemas.microsoft.com/office/powerpoint/2010/main" val="3796369453"/>
+      </p:ext>
+    </p:extLst>
+  </p:cSld>
+  <p:clrMapOvr>
+    <a:masterClrMapping/>
+  </p:clrMapOvr>
+</p:sld>
+</file>
+
+<file path=ppt/slides/slide2.xml><?xml version="1.0" encoding="utf-8"?>
+<p:sld xmlns:a="http://schemas.openxmlformats.org/drawingml/2006/main" xmlns:r="http://schemas.openxmlformats.org/officeDocument/2006/relationships" xmlns:p="http://schemas.openxmlformats.org/presentationml/2006/main">
+  <p:cSld>
+    <p:spTree>
+      <p:nvGrpSpPr>
+        <p:cNvPr id="1" name="">
+          <a:extLst>
+            <a:ext uri="{FF2B5EF4-FFF2-40B4-BE49-F238E27FC236}">
+              <a16:creationId xmlns:a16="http://schemas.microsoft.com/office/drawing/2014/main" id="{434A0ACE-6316-7483-4F1E-9DA88BDFC0C8}"/>
+            </a:ext>
+          </a:extLst>
+        </p:cNvPr>
+        <p:cNvGrpSpPr/>
+        <p:nvPr/>
+      </p:nvGrpSpPr>
+      <p:grpSpPr>
+        <a:xfrm>
+          <a:off x="0" y="0"/>
+          <a:ext cx="0" cy="0"/>
+          <a:chOff x="0" y="0"/>
+          <a:chExt cx="0" cy="0"/>
+        </a:xfrm>
+      </p:grpSpPr>
+      <p:sp>
+        <p:nvSpPr>
+          <p:cNvPr id="2" name="Title 1">
+            <a:extLst>
+              <a:ext uri="{FF2B5EF4-FFF2-40B4-BE49-F238E27FC236}">
+                <a16:creationId xmlns:a16="http://schemas.microsoft.com/office/drawing/2014/main" id="{060CE1CD-B8FD-A046-A589-0F2855524798}"/>
+              </a:ext>
+            </a:extLst>
+          </p:cNvPr>
+          <p:cNvSpPr>
+            <a:spLocks noGrp="1"/>
+          </p:cNvSpPr>
+          <p:nvPr>
+            <p:ph type="title"/>
+          </p:nvPr>
+        </p:nvSpPr>
+        <p:spPr/>
+        <p:txBody>
+          <a:bodyPr/>
+          <a:lstStyle/>
+          <a:p>
+            <a:r>
+              <a:rPr lang="en-US" b="1" dirty="0"/>
+              <a:t>AI-generated text alternative</a:t>
+            </a:r>
+          </a:p>
+        </p:txBody>
+      </p:sp>
+      <p:sp>
+        <p:nvSpPr>
+          <p:cNvPr id="3" name="Content Placeholder 2">
+            <a:extLst>
+              <a:ext uri="{FF2B5EF4-FFF2-40B4-BE49-F238E27FC236}">
+                <a16:creationId xmlns:a16="http://schemas.microsoft.com/office/drawing/2014/main" id="{CA289B50-2125-F969-620B-A883AA50C7A8}"/>
+              </a:ext>
+            </a:extLst>
+          </p:cNvPr>
+          <p:cNvSpPr>
+            <a:spLocks noGrp="1"/>
+          </p:cNvSpPr>
+          <p:nvPr>
+            <p:ph idx="1"/>
+          </p:nvPr>
+        </p:nvSpPr>
+        <p:spPr>
+          <a:xfrm>
+            <a:off x="838200" y="1825624"/>
+            <a:ext cx="5325094" cy="3253003"/>
+          </a:xfrm>
+        </p:spPr>
+        <p:txBody>
+          <a:bodyPr>
+            <a:normAutofit/>
+          </a:bodyPr>
+          <a:lstStyle/>
+          <a:p>
+            <a:pPr marL="0" indent="0">
+              <a:buNone/>
+            </a:pPr>
+            <a:r>
+              <a:rPr lang="en-US" dirty="0"/>
+              <a:t>MS Word guessed the text alternative as “A black background with white text. AI-generated content may be incorrect.”</a:t>
+            </a:r>
+          </a:p>
+          <a:p>
+            <a:endParaRPr lang="en-US" dirty="0"/>
+          </a:p>
+        </p:txBody>
+      </p:sp>
+      <p:pic>
+        <p:nvPicPr>
+          <p:cNvPr id="5" name="Picture 4" descr="A black background with white text&#10;&#10;AI-generated content may be incorrect.">
+            <a:extLst>
+              <a:ext uri="{FF2B5EF4-FFF2-40B4-BE49-F238E27FC236}">
+                <a16:creationId xmlns:a16="http://schemas.microsoft.com/office/drawing/2014/main" id="{C8F80D74-DDD8-0E70-86FC-F137C3EA401C}"/>
+              </a:ext>
+            </a:extLst>
+          </p:cNvPr>
+          <p:cNvPicPr>
+            <a:picLocks noChangeAspect="1"/>
+          </p:cNvPicPr>
+          <p:nvPr/>
+        </p:nvPicPr>
+        <p:blipFill>
+          <a:blip r:embed="rId2" cstate="print">
+            <a:extLst>
+              <a:ext uri="{28A0092B-C50C-407E-A947-70E740481C1C}">
+                <a14:useLocalDpi xmlns:a14="http://schemas.microsoft.com/office/drawing/2010/main" val="0"/>
+              </a:ext>
+            </a:extLst>
+          </a:blip>
+          <a:stretch>
+            <a:fillRect/>
+          </a:stretch>
+        </p:blipFill>
+        <p:spPr>
+          <a:xfrm>
+            <a:off x="6511187" y="1964328"/>
+            <a:ext cx="3458318" cy="914795"/>
+          </a:xfrm>
+          <a:prstGeom prst="rect">
+            <a:avLst/>
+          </a:prstGeom>
+        </p:spPr>
+      </p:pic>
+      <p:graphicFrame>
+        <p:nvGraphicFramePr>
+          <p:cNvPr id="20" name="Table 19">
+            <a:extLst>
+              <a:ext uri="{FF2B5EF4-FFF2-40B4-BE49-F238E27FC236}">
+                <a16:creationId xmlns:a16="http://schemas.microsoft.com/office/drawing/2014/main" id="{DD097625-E068-0759-30BD-65B8C3FB2B94}"/>
+              </a:ext>
+            </a:extLst>
+          </p:cNvPr>
+          <p:cNvGraphicFramePr>
+            <a:graphicFrameLocks noGrp="1"/>
+          </p:cNvGraphicFramePr>
+          <p:nvPr>
+            <p:extLst>
+              <p:ext uri="{D42A27DB-BD31-4B8C-83A1-F6EECF244321}">
+                <p14:modId xmlns:p14="http://schemas.microsoft.com/office/powerpoint/2010/main" val="3265952587"/>
+              </p:ext>
+            </p:extLst>
+          </p:nvPr>
+        </p:nvGraphicFramePr>
+        <p:xfrm>
+          <a:off x="810440" y="5354380"/>
+          <a:ext cx="7518573" cy="1169544"/>
+        </p:xfrm>
+        <a:graphic>
+          <a:graphicData uri="http://schemas.openxmlformats.org/drawingml/2006/table">
+            <a:tbl>
+              <a:tblPr firstRow="1" firstCol="1" bandRow="1">
+                <a:tableStyleId>{5C22544A-7EE6-4342-B048-85BDC9FD1C3A}</a:tableStyleId>
+              </a:tblPr>
+              <a:tblGrid>
+                <a:gridCol w="1713924">
+                  <a:extLst>
+                    <a:ext uri="{9D8B030D-6E8A-4147-A177-3AD203B41FA5}">
+                      <a16:colId xmlns:a16="http://schemas.microsoft.com/office/drawing/2014/main" val="2587052964"/>
+                    </a:ext>
+                  </a:extLst>
+                </a:gridCol>
+                <a:gridCol w="2794831">
+                  <a:extLst>
+                    <a:ext uri="{9D8B030D-6E8A-4147-A177-3AD203B41FA5}">
+                      <a16:colId xmlns:a16="http://schemas.microsoft.com/office/drawing/2014/main" val="1997474820"/>
+                    </a:ext>
+                  </a:extLst>
+                </a:gridCol>
+                <a:gridCol w="3009818">
+                  <a:extLst>
+                    <a:ext uri="{9D8B030D-6E8A-4147-A177-3AD203B41FA5}">
+                      <a16:colId xmlns:a16="http://schemas.microsoft.com/office/drawing/2014/main" val="123640046"/>
+                    </a:ext>
+                  </a:extLst>
+                </a:gridCol>
+              </a:tblGrid>
+              <a:tr h="771564">
+                <a:tc>
+                  <a:txBody>
+                    <a:bodyPr/>
+                    <a:lstStyle/>
+                    <a:p>
+                      <a:pPr marL="0" marR="0">
+                        <a:lnSpc>
+                          <a:spcPct val="115000"/>
+                        </a:lnSpc>
+                        <a:spcAft>
+                          <a:spcPts val="800"/>
+                        </a:spcAft>
+                        <a:buNone/>
+                      </a:pPr>
+                      <a:r>
+                        <a:rPr lang="en-US" sz="2300" kern="100">
+                          <a:effectLst/>
+                        </a:rPr>
+                        <a:t> </a:t>
+                      </a:r>
+                      <a:endParaRPr lang="en-US" sz="2300" kern="100">
+                        <a:effectLst/>
+                        <a:latin typeface="Aptos" panose="020B0004020202020204" pitchFamily="34" charset="0"/>
+                        <a:ea typeface="Aptos" panose="020B0004020202020204" pitchFamily="34" charset="0"/>
+                        <a:cs typeface="Times New Roman" panose="02020603050405020304" pitchFamily="18" charset="0"/>
+                      </a:endParaRPr>
+                    </a:p>
+                  </a:txBody>
+                  <a:tcPr marL="128992" marR="128992" marT="0" marB="0"/>
+                </a:tc>
+                <a:tc>
+                  <a:txBody>
+                    <a:bodyPr/>
+                    <a:lstStyle/>
+                    <a:p>
+                      <a:pPr marL="0" marR="0">
+                        <a:lnSpc>
+                          <a:spcPct val="115000"/>
+                        </a:lnSpc>
+                        <a:spcAft>
+                          <a:spcPts val="800"/>
+                        </a:spcAft>
+                        <a:buNone/>
+                      </a:pPr>
+                      <a:r>
+                        <a:rPr lang="en-US" sz="2300" kern="100">
+                          <a:effectLst/>
+                        </a:rPr>
+                        <a:t>A11y automated checker</a:t>
+                      </a:r>
+                      <a:endParaRPr lang="en-US" sz="2300" kern="100">
                         <a:effectLst/>
                         <a:latin typeface="Aptos" panose="020B0004020202020204" pitchFamily="34" charset="0"/>
                         <a:ea typeface="Aptos" panose="020B0004020202020204" pitchFamily="34" charset="0"/>
@@ -5080,7 +4499,7 @@
                         <a:rPr lang="en-US" sz="2300" kern="100" dirty="0">
                           <a:effectLst/>
                         </a:rPr>
-                        <a:t>Yes</a:t>
+                        <a:t>MS Accessibility checker</a:t>
                       </a:r>
                       <a:endParaRPr lang="en-US" sz="2300" kern="100" dirty="0">
                         <a:effectLst/>
@@ -5088,6 +4507,111 @@
                         <a:ea typeface="Aptos" panose="020B0004020202020204" pitchFamily="34" charset="0"/>
                         <a:cs typeface="Times New Roman" panose="02020603050405020304" pitchFamily="18" charset="0"/>
                       </a:endParaRPr>
+                    </a:p>
+                  </a:txBody>
+                  <a:tcPr marL="128992" marR="128992" marT="0" marB="0"/>
+                </a:tc>
+                <a:extLst>
+                  <a:ext uri="{0D108BD9-81ED-4DB2-BD59-A6C34878D82A}">
+                    <a16:rowId xmlns:a16="http://schemas.microsoft.com/office/drawing/2014/main" val="2904024515"/>
+                  </a:ext>
+                </a:extLst>
+              </a:tr>
+              <a:tr h="376109">
+                <a:tc>
+                  <a:txBody>
+                    <a:bodyPr/>
+                    <a:lstStyle/>
+                    <a:p>
+                      <a:pPr marL="0" marR="0">
+                        <a:lnSpc>
+                          <a:spcPct val="115000"/>
+                        </a:lnSpc>
+                        <a:spcAft>
+                          <a:spcPts val="800"/>
+                        </a:spcAft>
+                        <a:buNone/>
+                      </a:pPr>
+                      <a:r>
+                        <a:rPr lang="en-US" sz="2300" kern="100">
+                          <a:effectLst/>
+                        </a:rPr>
+                        <a:t>Result</a:t>
+                      </a:r>
+                      <a:endParaRPr lang="en-US" sz="2300" kern="100">
+                        <a:effectLst/>
+                        <a:latin typeface="Aptos" panose="020B0004020202020204" pitchFamily="34" charset="0"/>
+                        <a:ea typeface="Aptos" panose="020B0004020202020204" pitchFamily="34" charset="0"/>
+                        <a:cs typeface="Times New Roman" panose="02020603050405020304" pitchFamily="18" charset="0"/>
+                      </a:endParaRPr>
+                    </a:p>
+                  </a:txBody>
+                  <a:tcPr marL="128992" marR="128992" marT="0" marB="0"/>
+                </a:tc>
+                <a:tc>
+                  <a:txBody>
+                    <a:bodyPr/>
+                    <a:lstStyle/>
+                    <a:p>
+                      <a:pPr marL="0" marR="0" lvl="0" indent="0" algn="l" defTabSz="914400" rtl="0" eaLnBrk="1" fontAlgn="auto" latinLnBrk="0" hangingPunct="1">
+                        <a:lnSpc>
+                          <a:spcPct val="115000"/>
+                        </a:lnSpc>
+                        <a:spcBef>
+                          <a:spcPts val="0"/>
+                        </a:spcBef>
+                        <a:spcAft>
+                          <a:spcPts val="800"/>
+                        </a:spcAft>
+                        <a:buClrTx/>
+                        <a:buSzTx/>
+                        <a:buFontTx/>
+                        <a:buNone/>
+                        <a:tabLst/>
+                        <a:defRPr/>
+                      </a:pPr>
+                      <a:r>
+                        <a:rPr lang="en-US" sz="2300" kern="100" dirty="0">
+                          <a:effectLst/>
+                        </a:rPr>
+                        <a:t>Not </a:t>
+                      </a:r>
+                      <a:r>
+                        <a:rPr lang="en-US" sz="2300" kern="100" dirty="0">
+                          <a:effectLst/>
+                          <a:latin typeface="Aptos" panose="020B0004020202020204" pitchFamily="34" charset="0"/>
+                          <a:ea typeface="Aptos" panose="020B0004020202020204" pitchFamily="34" charset="0"/>
+                          <a:cs typeface="Times New Roman" panose="02020603050405020304" pitchFamily="18" charset="0"/>
+                        </a:rPr>
+                        <a:t>Detected</a:t>
+                      </a:r>
+                    </a:p>
+                  </a:txBody>
+                  <a:tcPr marL="128992" marR="128992" marT="0" marB="0"/>
+                </a:tc>
+                <a:tc>
+                  <a:txBody>
+                    <a:bodyPr/>
+                    <a:lstStyle/>
+                    <a:p>
+                      <a:pPr marL="0" marR="0">
+                        <a:lnSpc>
+                          <a:spcPct val="115000"/>
+                        </a:lnSpc>
+                        <a:spcAft>
+                          <a:spcPts val="800"/>
+                        </a:spcAft>
+                        <a:buNone/>
+                      </a:pPr>
+                      <a:r>
+                        <a:rPr lang="en-US" sz="2300" kern="100" dirty="0">
+                          <a:effectLst/>
+                          <a:latin typeface="Aptos" panose="020B0004020202020204" pitchFamily="34" charset="0"/>
+                          <a:ea typeface="Aptos" panose="020B0004020202020204" pitchFamily="34" charset="0"/>
+                          <a:cs typeface="Times New Roman" panose="02020603050405020304" pitchFamily="18" charset="0"/>
+                        </a:rPr>
+                        <a:t>Detected</a:t>
+                      </a:r>
                     </a:p>
                   </a:txBody>
                   <a:tcPr marL="128992" marR="128992" marT="0" marB="0"/>
@@ -5210,6 +4734,890 @@
             <a:extLst>
               <a:ext uri="{FF2B5EF4-FFF2-40B4-BE49-F238E27FC236}">
                 <a16:creationId xmlns:a16="http://schemas.microsoft.com/office/drawing/2014/main" id="{0DD8AFA2-F466-1CCF-5191-1E7EAF9EFBD3}"/>
+              </a:ext>
+            </a:extLst>
+          </p:cNvPr>
+          <p:cNvGraphicFramePr>
+            <a:graphicFrameLocks noGrp="1"/>
+          </p:cNvGraphicFramePr>
+          <p:nvPr>
+            <p:extLst>
+              <p:ext uri="{D42A27DB-BD31-4B8C-83A1-F6EECF244321}">
+                <p14:modId xmlns:p14="http://schemas.microsoft.com/office/powerpoint/2010/main" val="3674814014"/>
+              </p:ext>
+            </p:extLst>
+          </p:nvPr>
+        </p:nvGraphicFramePr>
+        <p:xfrm>
+          <a:off x="810440" y="5354380"/>
+          <a:ext cx="7518573" cy="1169544"/>
+        </p:xfrm>
+        <a:graphic>
+          <a:graphicData uri="http://schemas.openxmlformats.org/drawingml/2006/table">
+            <a:tbl>
+              <a:tblPr firstRow="1" firstCol="1" bandRow="1">
+                <a:tableStyleId>{5C22544A-7EE6-4342-B048-85BDC9FD1C3A}</a:tableStyleId>
+              </a:tblPr>
+              <a:tblGrid>
+                <a:gridCol w="1713924">
+                  <a:extLst>
+                    <a:ext uri="{9D8B030D-6E8A-4147-A177-3AD203B41FA5}">
+                      <a16:colId xmlns:a16="http://schemas.microsoft.com/office/drawing/2014/main" val="2587052964"/>
+                    </a:ext>
+                  </a:extLst>
+                </a:gridCol>
+                <a:gridCol w="2794831">
+                  <a:extLst>
+                    <a:ext uri="{9D8B030D-6E8A-4147-A177-3AD203B41FA5}">
+                      <a16:colId xmlns:a16="http://schemas.microsoft.com/office/drawing/2014/main" val="1997474820"/>
+                    </a:ext>
+                  </a:extLst>
+                </a:gridCol>
+                <a:gridCol w="3009818">
+                  <a:extLst>
+                    <a:ext uri="{9D8B030D-6E8A-4147-A177-3AD203B41FA5}">
+                      <a16:colId xmlns:a16="http://schemas.microsoft.com/office/drawing/2014/main" val="123640046"/>
+                    </a:ext>
+                  </a:extLst>
+                </a:gridCol>
+              </a:tblGrid>
+              <a:tr h="771564">
+                <a:tc>
+                  <a:txBody>
+                    <a:bodyPr/>
+                    <a:lstStyle/>
+                    <a:p>
+                      <a:pPr marL="0" marR="0">
+                        <a:lnSpc>
+                          <a:spcPct val="115000"/>
+                        </a:lnSpc>
+                        <a:spcAft>
+                          <a:spcPts val="800"/>
+                        </a:spcAft>
+                        <a:buNone/>
+                      </a:pPr>
+                      <a:r>
+                        <a:rPr lang="en-US" sz="2300" kern="100">
+                          <a:effectLst/>
+                        </a:rPr>
+                        <a:t> </a:t>
+                      </a:r>
+                      <a:endParaRPr lang="en-US" sz="2300" kern="100">
+                        <a:effectLst/>
+                        <a:latin typeface="Aptos" panose="020B0004020202020204" pitchFamily="34" charset="0"/>
+                        <a:ea typeface="Aptos" panose="020B0004020202020204" pitchFamily="34" charset="0"/>
+                        <a:cs typeface="Times New Roman" panose="02020603050405020304" pitchFamily="18" charset="0"/>
+                      </a:endParaRPr>
+                    </a:p>
+                  </a:txBody>
+                  <a:tcPr marL="128992" marR="128992" marT="0" marB="0"/>
+                </a:tc>
+                <a:tc>
+                  <a:txBody>
+                    <a:bodyPr/>
+                    <a:lstStyle/>
+                    <a:p>
+                      <a:pPr marL="0" marR="0">
+                        <a:lnSpc>
+                          <a:spcPct val="115000"/>
+                        </a:lnSpc>
+                        <a:spcAft>
+                          <a:spcPts val="800"/>
+                        </a:spcAft>
+                        <a:buNone/>
+                      </a:pPr>
+                      <a:r>
+                        <a:rPr lang="en-US" sz="2300" kern="100">
+                          <a:effectLst/>
+                        </a:rPr>
+                        <a:t>A11y automated checker</a:t>
+                      </a:r>
+                      <a:endParaRPr lang="en-US" sz="2300" kern="100">
+                        <a:effectLst/>
+                        <a:latin typeface="Aptos" panose="020B0004020202020204" pitchFamily="34" charset="0"/>
+                        <a:ea typeface="Aptos" panose="020B0004020202020204" pitchFamily="34" charset="0"/>
+                        <a:cs typeface="Times New Roman" panose="02020603050405020304" pitchFamily="18" charset="0"/>
+                      </a:endParaRPr>
+                    </a:p>
+                  </a:txBody>
+                  <a:tcPr marL="128992" marR="128992" marT="0" marB="0"/>
+                </a:tc>
+                <a:tc>
+                  <a:txBody>
+                    <a:bodyPr/>
+                    <a:lstStyle/>
+                    <a:p>
+                      <a:pPr marL="0" marR="0">
+                        <a:lnSpc>
+                          <a:spcPct val="115000"/>
+                        </a:lnSpc>
+                        <a:spcAft>
+                          <a:spcPts val="800"/>
+                        </a:spcAft>
+                        <a:buNone/>
+                      </a:pPr>
+                      <a:r>
+                        <a:rPr lang="en-US" sz="2300" kern="100" dirty="0">
+                          <a:effectLst/>
+                        </a:rPr>
+                        <a:t>MS Accessibility checker</a:t>
+                      </a:r>
+                      <a:endParaRPr lang="en-US" sz="2300" kern="100" dirty="0">
+                        <a:effectLst/>
+                        <a:latin typeface="Aptos" panose="020B0004020202020204" pitchFamily="34" charset="0"/>
+                        <a:ea typeface="Aptos" panose="020B0004020202020204" pitchFamily="34" charset="0"/>
+                        <a:cs typeface="Times New Roman" panose="02020603050405020304" pitchFamily="18" charset="0"/>
+                      </a:endParaRPr>
+                    </a:p>
+                  </a:txBody>
+                  <a:tcPr marL="128992" marR="128992" marT="0" marB="0"/>
+                </a:tc>
+                <a:extLst>
+                  <a:ext uri="{0D108BD9-81ED-4DB2-BD59-A6C34878D82A}">
+                    <a16:rowId xmlns:a16="http://schemas.microsoft.com/office/drawing/2014/main" val="2904024515"/>
+                  </a:ext>
+                </a:extLst>
+              </a:tr>
+              <a:tr h="376109">
+                <a:tc>
+                  <a:txBody>
+                    <a:bodyPr/>
+                    <a:lstStyle/>
+                    <a:p>
+                      <a:pPr marL="0" marR="0">
+                        <a:lnSpc>
+                          <a:spcPct val="115000"/>
+                        </a:lnSpc>
+                        <a:spcAft>
+                          <a:spcPts val="800"/>
+                        </a:spcAft>
+                        <a:buNone/>
+                      </a:pPr>
+                      <a:r>
+                        <a:rPr lang="en-US" sz="2300" kern="100">
+                          <a:effectLst/>
+                        </a:rPr>
+                        <a:t>Result</a:t>
+                      </a:r>
+                      <a:endParaRPr lang="en-US" sz="2300" kern="100">
+                        <a:effectLst/>
+                        <a:latin typeface="Aptos" panose="020B0004020202020204" pitchFamily="34" charset="0"/>
+                        <a:ea typeface="Aptos" panose="020B0004020202020204" pitchFamily="34" charset="0"/>
+                        <a:cs typeface="Times New Roman" panose="02020603050405020304" pitchFamily="18" charset="0"/>
+                      </a:endParaRPr>
+                    </a:p>
+                  </a:txBody>
+                  <a:tcPr marL="128992" marR="128992" marT="0" marB="0"/>
+                </a:tc>
+                <a:tc>
+                  <a:txBody>
+                    <a:bodyPr/>
+                    <a:lstStyle/>
+                    <a:p>
+                      <a:pPr marL="0" marR="0" lvl="0" indent="0" algn="l" defTabSz="914400" rtl="0" eaLnBrk="1" fontAlgn="auto" latinLnBrk="0" hangingPunct="1">
+                        <a:lnSpc>
+                          <a:spcPct val="115000"/>
+                        </a:lnSpc>
+                        <a:spcBef>
+                          <a:spcPts val="0"/>
+                        </a:spcBef>
+                        <a:spcAft>
+                          <a:spcPts val="800"/>
+                        </a:spcAft>
+                        <a:buClrTx/>
+                        <a:buSzTx/>
+                        <a:buFontTx/>
+                        <a:buNone/>
+                        <a:tabLst/>
+                        <a:defRPr/>
+                      </a:pPr>
+                      <a:r>
+                        <a:rPr lang="en-US" sz="2300" kern="100" dirty="0">
+                          <a:effectLst/>
+                        </a:rPr>
+                        <a:t>Not </a:t>
+                      </a:r>
+                      <a:r>
+                        <a:rPr lang="en-US" sz="2300" kern="100" dirty="0">
+                          <a:effectLst/>
+                          <a:latin typeface="Aptos" panose="020B0004020202020204" pitchFamily="34" charset="0"/>
+                          <a:ea typeface="Aptos" panose="020B0004020202020204" pitchFamily="34" charset="0"/>
+                          <a:cs typeface="Times New Roman" panose="02020603050405020304" pitchFamily="18" charset="0"/>
+                        </a:rPr>
+                        <a:t>Detected</a:t>
+                      </a:r>
+                    </a:p>
+                  </a:txBody>
+                  <a:tcPr marL="128992" marR="128992" marT="0" marB="0"/>
+                </a:tc>
+                <a:tc>
+                  <a:txBody>
+                    <a:bodyPr/>
+                    <a:lstStyle/>
+                    <a:p>
+                      <a:pPr marL="0" marR="0" lvl="0" indent="0" algn="l" defTabSz="914400" rtl="0" eaLnBrk="1" fontAlgn="auto" latinLnBrk="0" hangingPunct="1">
+                        <a:lnSpc>
+                          <a:spcPct val="115000"/>
+                        </a:lnSpc>
+                        <a:spcBef>
+                          <a:spcPts val="0"/>
+                        </a:spcBef>
+                        <a:spcAft>
+                          <a:spcPts val="800"/>
+                        </a:spcAft>
+                        <a:buClrTx/>
+                        <a:buSzTx/>
+                        <a:buFontTx/>
+                        <a:buNone/>
+                        <a:tabLst/>
+                        <a:defRPr/>
+                      </a:pPr>
+                      <a:r>
+                        <a:rPr lang="en-US" sz="2300" kern="100" dirty="0">
+                          <a:effectLst/>
+                        </a:rPr>
+                        <a:t>Not </a:t>
+                      </a:r>
+                      <a:r>
+                        <a:rPr lang="en-US" sz="2300" kern="100" dirty="0">
+                          <a:effectLst/>
+                          <a:latin typeface="Aptos" panose="020B0004020202020204" pitchFamily="34" charset="0"/>
+                          <a:ea typeface="Aptos" panose="020B0004020202020204" pitchFamily="34" charset="0"/>
+                          <a:cs typeface="Times New Roman" panose="02020603050405020304" pitchFamily="18" charset="0"/>
+                        </a:rPr>
+                        <a:t>Detected</a:t>
+                      </a:r>
+                    </a:p>
+                  </a:txBody>
+                  <a:tcPr marL="128992" marR="128992" marT="0" marB="0"/>
+                </a:tc>
+                <a:extLst>
+                  <a:ext uri="{0D108BD9-81ED-4DB2-BD59-A6C34878D82A}">
+                    <a16:rowId xmlns:a16="http://schemas.microsoft.com/office/drawing/2014/main" val="4046348799"/>
+                  </a:ext>
+                </a:extLst>
+              </a:tr>
+            </a:tbl>
+          </a:graphicData>
+        </a:graphic>
+      </p:graphicFrame>
+      <p:sp>
+        <p:nvSpPr>
+          <p:cNvPr id="4" name="Rectangle 3" descr="Red separator bar. ">
+            <a:extLst>
+              <a:ext uri="{FF2B5EF4-FFF2-40B4-BE49-F238E27FC236}">
+                <a16:creationId xmlns:a16="http://schemas.microsoft.com/office/drawing/2014/main" id="{A0A53FB2-C801-505E-6CAE-9A829D7F8E0A}"/>
+              </a:ext>
+            </a:extLst>
+          </p:cNvPr>
+          <p:cNvSpPr/>
+          <p:nvPr/>
+        </p:nvSpPr>
+        <p:spPr>
+          <a:xfrm>
+            <a:off x="6376086" y="2056713"/>
+            <a:ext cx="5140411" cy="130433"/>
+          </a:xfrm>
+          <a:prstGeom prst="rect">
+            <a:avLst/>
+          </a:prstGeom>
+          <a:solidFill>
+            <a:srgbClr val="CC0033"/>
+          </a:solidFill>
+        </p:spPr>
+        <p:style>
+          <a:lnRef idx="2">
+            <a:schemeClr val="accent1">
+              <a:shade val="15000"/>
+            </a:schemeClr>
+          </a:lnRef>
+          <a:fillRef idx="1">
+            <a:schemeClr val="accent1"/>
+          </a:fillRef>
+          <a:effectRef idx="0">
+            <a:schemeClr val="accent1"/>
+          </a:effectRef>
+          <a:fontRef idx="minor">
+            <a:schemeClr val="lt1"/>
+          </a:fontRef>
+        </p:style>
+        <p:txBody>
+          <a:bodyPr rot="0" spcFirstLastPara="0" vert="horz" wrap="square" lIns="91440" tIns="45720" rIns="91440" bIns="45720" numCol="1" spcCol="0" rtlCol="0" fromWordArt="0" anchor="ctr" anchorCtr="0" forceAA="0" compatLnSpc="1">
+            <a:prstTxWarp prst="textNoShape">
+              <a:avLst/>
+            </a:prstTxWarp>
+            <a:noAutofit/>
+          </a:bodyPr>
+          <a:lstStyle/>
+          <a:p>
+            <a:endParaRPr lang="en-US"/>
+          </a:p>
+        </p:txBody>
+      </p:sp>
+    </p:spTree>
+    <p:extLst>
+      <p:ext uri="{BB962C8B-B14F-4D97-AF65-F5344CB8AC3E}">
+        <p14:creationId xmlns:p14="http://schemas.microsoft.com/office/powerpoint/2010/main" val="135463311"/>
+      </p:ext>
+    </p:extLst>
+  </p:cSld>
+  <p:clrMapOvr>
+    <a:masterClrMapping/>
+  </p:clrMapOvr>
+</p:sld>
+</file>
+
+<file path=ppt/slides/slide4.xml><?xml version="1.0" encoding="utf-8"?>
+<p:sld xmlns:a="http://schemas.openxmlformats.org/drawingml/2006/main" xmlns:r="http://schemas.openxmlformats.org/officeDocument/2006/relationships" xmlns:p="http://schemas.openxmlformats.org/presentationml/2006/main">
+  <p:cSld>
+    <p:spTree>
+      <p:nvGrpSpPr>
+        <p:cNvPr id="1" name="">
+          <a:extLst>
+            <a:ext uri="{FF2B5EF4-FFF2-40B4-BE49-F238E27FC236}">
+              <a16:creationId xmlns:a16="http://schemas.microsoft.com/office/drawing/2014/main" id="{2CF0BA1A-A634-B41B-DFF1-50AC1E41A4DC}"/>
+            </a:ext>
+          </a:extLst>
+        </p:cNvPr>
+        <p:cNvGrpSpPr/>
+        <p:nvPr/>
+      </p:nvGrpSpPr>
+      <p:grpSpPr>
+        <a:xfrm>
+          <a:off x="0" y="0"/>
+          <a:ext cx="0" cy="0"/>
+          <a:chOff x="0" y="0"/>
+          <a:chExt cx="0" cy="0"/>
+        </a:xfrm>
+      </p:grpSpPr>
+      <p:sp>
+        <p:nvSpPr>
+          <p:cNvPr id="2" name="Title 1">
+            <a:extLst>
+              <a:ext uri="{FF2B5EF4-FFF2-40B4-BE49-F238E27FC236}">
+                <a16:creationId xmlns:a16="http://schemas.microsoft.com/office/drawing/2014/main" id="{B09FA19B-E128-B951-DE71-8E4FE9065E66}"/>
+              </a:ext>
+            </a:extLst>
+          </p:cNvPr>
+          <p:cNvSpPr>
+            <a:spLocks noGrp="1"/>
+          </p:cNvSpPr>
+          <p:nvPr>
+            <p:ph type="title"/>
+          </p:nvPr>
+        </p:nvSpPr>
+        <p:spPr/>
+        <p:txBody>
+          <a:bodyPr/>
+          <a:lstStyle/>
+          <a:p>
+            <a:r>
+              <a:rPr lang="en-US" b="1" dirty="0"/>
+              <a:t>Poorly constructed text alternative: vague</a:t>
+            </a:r>
+          </a:p>
+        </p:txBody>
+      </p:sp>
+      <p:sp>
+        <p:nvSpPr>
+          <p:cNvPr id="3" name="Content Placeholder 2">
+            <a:extLst>
+              <a:ext uri="{FF2B5EF4-FFF2-40B4-BE49-F238E27FC236}">
+                <a16:creationId xmlns:a16="http://schemas.microsoft.com/office/drawing/2014/main" id="{BEFB9504-759E-3497-2FC1-A592FFB304CD}"/>
+              </a:ext>
+            </a:extLst>
+          </p:cNvPr>
+          <p:cNvSpPr>
+            <a:spLocks noGrp="1"/>
+          </p:cNvSpPr>
+          <p:nvPr>
+            <p:ph idx="1"/>
+          </p:nvPr>
+        </p:nvSpPr>
+        <p:spPr>
+          <a:xfrm>
+            <a:off x="838200" y="1825624"/>
+            <a:ext cx="4154214" cy="3253003"/>
+          </a:xfrm>
+        </p:spPr>
+        <p:txBody>
+          <a:bodyPr>
+            <a:normAutofit/>
+          </a:bodyPr>
+          <a:lstStyle/>
+          <a:p>
+            <a:pPr marL="0" indent="0">
+              <a:buNone/>
+            </a:pPr>
+            <a:r>
+              <a:rPr lang="en-US" dirty="0"/>
+              <a:t>The text alternative here just reads “quiz averages.”</a:t>
+            </a:r>
+          </a:p>
+        </p:txBody>
+      </p:sp>
+      <p:graphicFrame>
+        <p:nvGraphicFramePr>
+          <p:cNvPr id="20" name="Table 19">
+            <a:extLst>
+              <a:ext uri="{FF2B5EF4-FFF2-40B4-BE49-F238E27FC236}">
+                <a16:creationId xmlns:a16="http://schemas.microsoft.com/office/drawing/2014/main" id="{4F7D5C41-4403-F8E6-36E8-934F09575587}"/>
+              </a:ext>
+            </a:extLst>
+          </p:cNvPr>
+          <p:cNvGraphicFramePr>
+            <a:graphicFrameLocks noGrp="1"/>
+          </p:cNvGraphicFramePr>
+          <p:nvPr>
+            <p:extLst>
+              <p:ext uri="{D42A27DB-BD31-4B8C-83A1-F6EECF244321}">
+                <p14:modId xmlns:p14="http://schemas.microsoft.com/office/powerpoint/2010/main" val="3559670945"/>
+              </p:ext>
+            </p:extLst>
+          </p:nvPr>
+        </p:nvGraphicFramePr>
+        <p:xfrm>
+          <a:off x="810440" y="5354380"/>
+          <a:ext cx="7518573" cy="1169544"/>
+        </p:xfrm>
+        <a:graphic>
+          <a:graphicData uri="http://schemas.openxmlformats.org/drawingml/2006/table">
+            <a:tbl>
+              <a:tblPr firstRow="1" firstCol="1" bandRow="1">
+                <a:tableStyleId>{5C22544A-7EE6-4342-B048-85BDC9FD1C3A}</a:tableStyleId>
+              </a:tblPr>
+              <a:tblGrid>
+                <a:gridCol w="1713924">
+                  <a:extLst>
+                    <a:ext uri="{9D8B030D-6E8A-4147-A177-3AD203B41FA5}">
+                      <a16:colId xmlns:a16="http://schemas.microsoft.com/office/drawing/2014/main" val="2587052964"/>
+                    </a:ext>
+                  </a:extLst>
+                </a:gridCol>
+                <a:gridCol w="2794831">
+                  <a:extLst>
+                    <a:ext uri="{9D8B030D-6E8A-4147-A177-3AD203B41FA5}">
+                      <a16:colId xmlns:a16="http://schemas.microsoft.com/office/drawing/2014/main" val="1997474820"/>
+                    </a:ext>
+                  </a:extLst>
+                </a:gridCol>
+                <a:gridCol w="3009818">
+                  <a:extLst>
+                    <a:ext uri="{9D8B030D-6E8A-4147-A177-3AD203B41FA5}">
+                      <a16:colId xmlns:a16="http://schemas.microsoft.com/office/drawing/2014/main" val="123640046"/>
+                    </a:ext>
+                  </a:extLst>
+                </a:gridCol>
+              </a:tblGrid>
+              <a:tr h="771564">
+                <a:tc>
+                  <a:txBody>
+                    <a:bodyPr/>
+                    <a:lstStyle/>
+                    <a:p>
+                      <a:pPr marL="0" marR="0">
+                        <a:lnSpc>
+                          <a:spcPct val="115000"/>
+                        </a:lnSpc>
+                        <a:spcAft>
+                          <a:spcPts val="800"/>
+                        </a:spcAft>
+                        <a:buNone/>
+                      </a:pPr>
+                      <a:r>
+                        <a:rPr lang="en-US" sz="2300" kern="100">
+                          <a:effectLst/>
+                        </a:rPr>
+                        <a:t> </a:t>
+                      </a:r>
+                      <a:endParaRPr lang="en-US" sz="2300" kern="100">
+                        <a:effectLst/>
+                        <a:latin typeface="Aptos" panose="020B0004020202020204" pitchFamily="34" charset="0"/>
+                        <a:ea typeface="Aptos" panose="020B0004020202020204" pitchFamily="34" charset="0"/>
+                        <a:cs typeface="Times New Roman" panose="02020603050405020304" pitchFamily="18" charset="0"/>
+                      </a:endParaRPr>
+                    </a:p>
+                  </a:txBody>
+                  <a:tcPr marL="128992" marR="128992" marT="0" marB="0"/>
+                </a:tc>
+                <a:tc>
+                  <a:txBody>
+                    <a:bodyPr/>
+                    <a:lstStyle/>
+                    <a:p>
+                      <a:pPr marL="0" marR="0">
+                        <a:lnSpc>
+                          <a:spcPct val="115000"/>
+                        </a:lnSpc>
+                        <a:spcAft>
+                          <a:spcPts val="800"/>
+                        </a:spcAft>
+                        <a:buNone/>
+                      </a:pPr>
+                      <a:r>
+                        <a:rPr lang="en-US" sz="2300" kern="100">
+                          <a:effectLst/>
+                        </a:rPr>
+                        <a:t>A11y automated checker</a:t>
+                      </a:r>
+                      <a:endParaRPr lang="en-US" sz="2300" kern="100">
+                        <a:effectLst/>
+                        <a:latin typeface="Aptos" panose="020B0004020202020204" pitchFamily="34" charset="0"/>
+                        <a:ea typeface="Aptos" panose="020B0004020202020204" pitchFamily="34" charset="0"/>
+                        <a:cs typeface="Times New Roman" panose="02020603050405020304" pitchFamily="18" charset="0"/>
+                      </a:endParaRPr>
+                    </a:p>
+                  </a:txBody>
+                  <a:tcPr marL="128992" marR="128992" marT="0" marB="0"/>
+                </a:tc>
+                <a:tc>
+                  <a:txBody>
+                    <a:bodyPr/>
+                    <a:lstStyle/>
+                    <a:p>
+                      <a:pPr marL="0" marR="0">
+                        <a:lnSpc>
+                          <a:spcPct val="115000"/>
+                        </a:lnSpc>
+                        <a:spcAft>
+                          <a:spcPts val="800"/>
+                        </a:spcAft>
+                        <a:buNone/>
+                      </a:pPr>
+                      <a:r>
+                        <a:rPr lang="en-US" sz="2300" kern="100" dirty="0">
+                          <a:effectLst/>
+                        </a:rPr>
+                        <a:t>MS Accessibility checker</a:t>
+                      </a:r>
+                      <a:endParaRPr lang="en-US" sz="2300" kern="100" dirty="0">
+                        <a:effectLst/>
+                        <a:latin typeface="Aptos" panose="020B0004020202020204" pitchFamily="34" charset="0"/>
+                        <a:ea typeface="Aptos" panose="020B0004020202020204" pitchFamily="34" charset="0"/>
+                        <a:cs typeface="Times New Roman" panose="02020603050405020304" pitchFamily="18" charset="0"/>
+                      </a:endParaRPr>
+                    </a:p>
+                  </a:txBody>
+                  <a:tcPr marL="128992" marR="128992" marT="0" marB="0"/>
+                </a:tc>
+                <a:extLst>
+                  <a:ext uri="{0D108BD9-81ED-4DB2-BD59-A6C34878D82A}">
+                    <a16:rowId xmlns:a16="http://schemas.microsoft.com/office/drawing/2014/main" val="2904024515"/>
+                  </a:ext>
+                </a:extLst>
+              </a:tr>
+              <a:tr h="376109">
+                <a:tc>
+                  <a:txBody>
+                    <a:bodyPr/>
+                    <a:lstStyle/>
+                    <a:p>
+                      <a:pPr marL="0" marR="0">
+                        <a:lnSpc>
+                          <a:spcPct val="115000"/>
+                        </a:lnSpc>
+                        <a:spcAft>
+                          <a:spcPts val="800"/>
+                        </a:spcAft>
+                        <a:buNone/>
+                      </a:pPr>
+                      <a:r>
+                        <a:rPr lang="en-US" sz="2300" kern="100">
+                          <a:effectLst/>
+                        </a:rPr>
+                        <a:t>Result</a:t>
+                      </a:r>
+                      <a:endParaRPr lang="en-US" sz="2300" kern="100">
+                        <a:effectLst/>
+                        <a:latin typeface="Aptos" panose="020B0004020202020204" pitchFamily="34" charset="0"/>
+                        <a:ea typeface="Aptos" panose="020B0004020202020204" pitchFamily="34" charset="0"/>
+                        <a:cs typeface="Times New Roman" panose="02020603050405020304" pitchFamily="18" charset="0"/>
+                      </a:endParaRPr>
+                    </a:p>
+                  </a:txBody>
+                  <a:tcPr marL="128992" marR="128992" marT="0" marB="0"/>
+                </a:tc>
+                <a:tc>
+                  <a:txBody>
+                    <a:bodyPr/>
+                    <a:lstStyle/>
+                    <a:p>
+                      <a:pPr marL="0" marR="0" lvl="0" indent="0" algn="l" defTabSz="914400" rtl="0" eaLnBrk="1" fontAlgn="auto" latinLnBrk="0" hangingPunct="1">
+                        <a:lnSpc>
+                          <a:spcPct val="115000"/>
+                        </a:lnSpc>
+                        <a:spcBef>
+                          <a:spcPts val="0"/>
+                        </a:spcBef>
+                        <a:spcAft>
+                          <a:spcPts val="800"/>
+                        </a:spcAft>
+                        <a:buClrTx/>
+                        <a:buSzTx/>
+                        <a:buFontTx/>
+                        <a:buNone/>
+                        <a:tabLst/>
+                        <a:defRPr/>
+                      </a:pPr>
+                      <a:r>
+                        <a:rPr kumimoji="0" lang="en-US" sz="2300" b="0" i="0" u="none" strike="noStrike" kern="100" cap="none" spc="0" normalizeH="0" baseline="0" noProof="0">
+                          <a:ln>
+                            <a:noFill/>
+                          </a:ln>
+                          <a:solidFill>
+                            <a:prstClr val="black"/>
+                          </a:solidFill>
+                          <a:effectLst/>
+                          <a:uLnTx/>
+                          <a:uFillTx/>
+                          <a:latin typeface="Aptos" panose="02110004020202020204"/>
+                          <a:ea typeface="+mn-ea"/>
+                          <a:cs typeface="+mn-cs"/>
+                        </a:rPr>
+                        <a:t>Not </a:t>
+                      </a:r>
+                      <a:r>
+                        <a:rPr kumimoji="0" lang="en-US" sz="2300" b="0" i="0" u="none" strike="noStrike" kern="100" cap="none" spc="0" normalizeH="0" baseline="0" noProof="0">
+                          <a:ln>
+                            <a:noFill/>
+                          </a:ln>
+                          <a:solidFill>
+                            <a:prstClr val="black"/>
+                          </a:solidFill>
+                          <a:effectLst/>
+                          <a:uLnTx/>
+                          <a:uFillTx/>
+                          <a:latin typeface="Aptos" panose="020B0004020202020204" pitchFamily="34" charset="0"/>
+                          <a:ea typeface="Aptos" panose="020B0004020202020204" pitchFamily="34" charset="0"/>
+                          <a:cs typeface="Times New Roman" panose="02020603050405020304" pitchFamily="18" charset="0"/>
+                        </a:rPr>
+                        <a:t>Detected</a:t>
+                      </a:r>
+                      <a:endParaRPr kumimoji="0" lang="en-US" sz="2300" b="0" i="0" u="none" strike="noStrike" kern="100" cap="none" spc="0" normalizeH="0" baseline="0" noProof="0" dirty="0">
+                        <a:ln>
+                          <a:noFill/>
+                        </a:ln>
+                        <a:solidFill>
+                          <a:prstClr val="black"/>
+                        </a:solidFill>
+                        <a:effectLst/>
+                        <a:uLnTx/>
+                        <a:uFillTx/>
+                        <a:latin typeface="Aptos" panose="020B0004020202020204" pitchFamily="34" charset="0"/>
+                        <a:ea typeface="Aptos" panose="020B0004020202020204" pitchFamily="34" charset="0"/>
+                        <a:cs typeface="Times New Roman" panose="02020603050405020304" pitchFamily="18" charset="0"/>
+                      </a:endParaRPr>
+                    </a:p>
+                  </a:txBody>
+                  <a:tcPr marL="128992" marR="128992" marT="0" marB="0"/>
+                </a:tc>
+                <a:tc>
+                  <a:txBody>
+                    <a:bodyPr/>
+                    <a:lstStyle/>
+                    <a:p>
+                      <a:pPr marL="0" marR="0" lvl="0" indent="0" algn="l" defTabSz="914400" rtl="0" eaLnBrk="1" fontAlgn="auto" latinLnBrk="0" hangingPunct="1">
+                        <a:lnSpc>
+                          <a:spcPct val="115000"/>
+                        </a:lnSpc>
+                        <a:spcBef>
+                          <a:spcPts val="0"/>
+                        </a:spcBef>
+                        <a:spcAft>
+                          <a:spcPts val="800"/>
+                        </a:spcAft>
+                        <a:buClrTx/>
+                        <a:buSzTx/>
+                        <a:buFontTx/>
+                        <a:buNone/>
+                        <a:tabLst/>
+                        <a:defRPr/>
+                      </a:pPr>
+                      <a:r>
+                        <a:rPr kumimoji="0" lang="en-US" sz="2300" b="0" i="0" u="none" strike="noStrike" kern="100" cap="none" spc="0" normalizeH="0" baseline="0" noProof="0" dirty="0">
+                          <a:ln>
+                            <a:noFill/>
+                          </a:ln>
+                          <a:solidFill>
+                            <a:prstClr val="black"/>
+                          </a:solidFill>
+                          <a:effectLst/>
+                          <a:uLnTx/>
+                          <a:uFillTx/>
+                          <a:latin typeface="Aptos" panose="02110004020202020204"/>
+                          <a:ea typeface="+mn-ea"/>
+                          <a:cs typeface="+mn-cs"/>
+                        </a:rPr>
+                        <a:t>Not </a:t>
+                      </a:r>
+                      <a:r>
+                        <a:rPr kumimoji="0" lang="en-US" sz="2300" b="0" i="0" u="none" strike="noStrike" kern="100" cap="none" spc="0" normalizeH="0" baseline="0" noProof="0" dirty="0">
+                          <a:ln>
+                            <a:noFill/>
+                          </a:ln>
+                          <a:solidFill>
+                            <a:prstClr val="black"/>
+                          </a:solidFill>
+                          <a:effectLst/>
+                          <a:uLnTx/>
+                          <a:uFillTx/>
+                          <a:latin typeface="Aptos" panose="020B0004020202020204" pitchFamily="34" charset="0"/>
+                          <a:ea typeface="Aptos" panose="020B0004020202020204" pitchFamily="34" charset="0"/>
+                          <a:cs typeface="Times New Roman" panose="02020603050405020304" pitchFamily="18" charset="0"/>
+                        </a:rPr>
+                        <a:t>Detected</a:t>
+                      </a:r>
+                    </a:p>
+                  </a:txBody>
+                  <a:tcPr marL="128992" marR="128992" marT="0" marB="0"/>
+                </a:tc>
+                <a:extLst>
+                  <a:ext uri="{0D108BD9-81ED-4DB2-BD59-A6C34878D82A}">
+                    <a16:rowId xmlns:a16="http://schemas.microsoft.com/office/drawing/2014/main" val="4046348799"/>
+                  </a:ext>
+                </a:extLst>
+              </a:tr>
+            </a:tbl>
+          </a:graphicData>
+        </a:graphic>
+      </p:graphicFrame>
+      <p:pic>
+        <p:nvPicPr>
+          <p:cNvPr id="6" name="Picture 5">
+            <a:extLst>
+              <a:ext uri="{FF2B5EF4-FFF2-40B4-BE49-F238E27FC236}">
+                <a16:creationId xmlns:a16="http://schemas.microsoft.com/office/drawing/2014/main" id="{693D75F0-3072-772C-6496-08995178996B}"/>
+              </a:ext>
+            </a:extLst>
+          </p:cNvPr>
+          <p:cNvPicPr>
+            <a:picLocks noChangeAspect="1"/>
+          </p:cNvPicPr>
+          <p:nvPr/>
+        </p:nvPicPr>
+        <p:blipFill>
+          <a:blip r:embed="rId3"/>
+          <a:srcRect/>
+          <a:stretch/>
+        </p:blipFill>
+        <p:spPr>
+          <a:xfrm>
+            <a:off x="5340569" y="1626914"/>
+            <a:ext cx="6324600" cy="3225800"/>
+          </a:xfrm>
+          <a:prstGeom prst="rect">
+            <a:avLst/>
+          </a:prstGeom>
+        </p:spPr>
+      </p:pic>
+    </p:spTree>
+    <p:extLst>
+      <p:ext uri="{BB962C8B-B14F-4D97-AF65-F5344CB8AC3E}">
+        <p14:creationId xmlns:p14="http://schemas.microsoft.com/office/powerpoint/2010/main" val="2892249461"/>
+      </p:ext>
+    </p:extLst>
+  </p:cSld>
+  <p:clrMapOvr>
+    <a:masterClrMapping/>
+  </p:clrMapOvr>
+</p:sld>
+</file>
+
+<file path=ppt/slides/slide5.xml><?xml version="1.0" encoding="utf-8"?>
+<p:sld xmlns:a="http://schemas.openxmlformats.org/drawingml/2006/main" xmlns:r="http://schemas.openxmlformats.org/officeDocument/2006/relationships" xmlns:p="http://schemas.openxmlformats.org/presentationml/2006/main">
+  <p:cSld>
+    <p:spTree>
+      <p:nvGrpSpPr>
+        <p:cNvPr id="1" name="">
+          <a:extLst>
+            <a:ext uri="{FF2B5EF4-FFF2-40B4-BE49-F238E27FC236}">
+              <a16:creationId xmlns:a16="http://schemas.microsoft.com/office/drawing/2014/main" id="{7722FF75-02E8-69FC-28A5-B5D8230B99D8}"/>
+            </a:ext>
+          </a:extLst>
+        </p:cNvPr>
+        <p:cNvGrpSpPr/>
+        <p:nvPr/>
+      </p:nvGrpSpPr>
+      <p:grpSpPr>
+        <a:xfrm>
+          <a:off x="0" y="0"/>
+          <a:ext cx="0" cy="0"/>
+          <a:chOff x="0" y="0"/>
+          <a:chExt cx="0" cy="0"/>
+        </a:xfrm>
+      </p:grpSpPr>
+      <p:sp>
+        <p:nvSpPr>
+          <p:cNvPr id="2" name="Title 1">
+            <a:extLst>
+              <a:ext uri="{FF2B5EF4-FFF2-40B4-BE49-F238E27FC236}">
+                <a16:creationId xmlns:a16="http://schemas.microsoft.com/office/drawing/2014/main" id="{91606803-05E0-C017-CA86-9F43A6697A9F}"/>
+              </a:ext>
+            </a:extLst>
+          </p:cNvPr>
+          <p:cNvSpPr>
+            <a:spLocks noGrp="1"/>
+          </p:cNvSpPr>
+          <p:nvPr>
+            <p:ph type="title"/>
+          </p:nvPr>
+        </p:nvSpPr>
+        <p:spPr/>
+        <p:txBody>
+          <a:bodyPr/>
+          <a:lstStyle/>
+          <a:p>
+            <a:r>
+              <a:rPr lang="en-US" b="1" dirty="0"/>
+              <a:t>Dense alt text</a:t>
+            </a:r>
+          </a:p>
+        </p:txBody>
+      </p:sp>
+      <p:sp>
+        <p:nvSpPr>
+          <p:cNvPr id="3" name="Content Placeholder 2">
+            <a:extLst>
+              <a:ext uri="{FF2B5EF4-FFF2-40B4-BE49-F238E27FC236}">
+                <a16:creationId xmlns:a16="http://schemas.microsoft.com/office/drawing/2014/main" id="{D2E59D68-451B-DAA3-CEC5-E50C7FC038D6}"/>
+              </a:ext>
+            </a:extLst>
+          </p:cNvPr>
+          <p:cNvSpPr>
+            <a:spLocks noGrp="1"/>
+          </p:cNvSpPr>
+          <p:nvPr>
+            <p:ph idx="1"/>
+          </p:nvPr>
+        </p:nvSpPr>
+        <p:spPr>
+          <a:xfrm>
+            <a:off x="838200" y="1825624"/>
+            <a:ext cx="4154214" cy="3253003"/>
+          </a:xfrm>
+        </p:spPr>
+        <p:txBody>
+          <a:bodyPr>
+            <a:normAutofit/>
+          </a:bodyPr>
+          <a:lstStyle/>
+          <a:p>
+            <a:pPr marL="0" indent="0">
+              <a:buNone/>
+            </a:pPr>
+            <a:r>
+              <a:rPr lang="en-US" dirty="0"/>
+              <a:t>The text alternative here just reads “Grouped bar graph comparing Quiz 1 and Quiz 2 averages across three sections. Section 1: 85% and 82%. Section 2: 83% and 81%. Section 3: 85% and 82%.”</a:t>
+            </a:r>
+          </a:p>
+        </p:txBody>
+      </p:sp>
+      <p:graphicFrame>
+        <p:nvGraphicFramePr>
+          <p:cNvPr id="20" name="Table 19">
+            <a:extLst>
+              <a:ext uri="{FF2B5EF4-FFF2-40B4-BE49-F238E27FC236}">
+                <a16:creationId xmlns:a16="http://schemas.microsoft.com/office/drawing/2014/main" id="{CB4F201A-A69F-9839-947D-9D38E4CBA3D7}"/>
               </a:ext>
             </a:extLst>
           </p:cNvPr>
@@ -5384,23 +5792,67 @@
                     <a:bodyPr/>
                     <a:lstStyle/>
                     <a:p>
-                      <a:pPr marL="0" marR="0">
+                      <a:pPr marL="0" marR="0" lvl="0" indent="0" algn="l" defTabSz="914400" rtl="0" eaLnBrk="1" fontAlgn="auto" latinLnBrk="0" hangingPunct="1">
                         <a:lnSpc>
                           <a:spcPct val="115000"/>
                         </a:lnSpc>
+                        <a:spcBef>
+                          <a:spcPts val="0"/>
+                        </a:spcBef>
                         <a:spcAft>
                           <a:spcPts val="800"/>
                         </a:spcAft>
+                        <a:buClrTx/>
+                        <a:buSzTx/>
+                        <a:buFontTx/>
                         <a:buNone/>
+                        <a:tabLst/>
+                        <a:defRPr/>
                       </a:pPr>
                       <a:r>
-                        <a:rPr lang="en-US" sz="2300" kern="100" dirty="0">
+                        <a:rPr kumimoji="0" lang="en-US" sz="2300" b="0" i="0" u="none" strike="noStrike" kern="100" cap="none" spc="0" normalizeH="0" baseline="0" noProof="0">
+                          <a:ln>
+                            <a:noFill/>
+                          </a:ln>
+                          <a:solidFill>
+                            <a:prstClr val="black"/>
+                          </a:solidFill>
                           <a:effectLst/>
+                          <a:uLnTx/>
+                          <a:uFillTx/>
+                          <a:latin typeface="Aptos" panose="02110004020202020204"/>
+                          <a:ea typeface="+mn-ea"/>
+                          <a:cs typeface="+mn-cs"/>
                         </a:rPr>
-                        <a:t>No</a:t>
+                        <a:t>Not </a:t>
                       </a:r>
-                      <a:endParaRPr lang="en-US" sz="2300" kern="100" dirty="0">
+                      <a:r>
+                        <a:rPr kumimoji="0" lang="en-US" sz="2300" b="0" i="0" u="none" strike="noStrike" kern="100" cap="none" spc="0" normalizeH="0" baseline="0" noProof="0">
+                          <a:ln>
+                            <a:noFill/>
+                          </a:ln>
+                          <a:solidFill>
+                            <a:prstClr val="black"/>
+                          </a:solidFill>
+                          <a:effectLst/>
+                          <a:uLnTx/>
+                          <a:uFillTx/>
+                          <a:latin typeface="Aptos" panose="020B0004020202020204" pitchFamily="34" charset="0"/>
+                          <a:ea typeface="Aptos" panose="020B0004020202020204" pitchFamily="34" charset="0"/>
+                          <a:cs typeface="Times New Roman" panose="02020603050405020304" pitchFamily="18" charset="0"/>
+                        </a:rPr>
+                        <a:t>Detected</a:t>
+                      </a:r>
+                      <a:endParaRPr kumimoji="0" lang="en-US" sz="2300" b="0" i="0" u="none" strike="noStrike" kern="100" cap="none" spc="0" normalizeH="0" baseline="0" noProof="0" dirty="0">
+                        <a:ln>
+                          <a:noFill/>
+                        </a:ln>
+                        <a:solidFill>
+                          <a:prstClr val="black"/>
+                        </a:solidFill>
                         <a:effectLst/>
+                        <a:uLnTx/>
+                        <a:uFillTx/>
                         <a:latin typeface="Aptos" panose="020B0004020202020204" pitchFamily="34" charset="0"/>
                         <a:ea typeface="Aptos" panose="020B0004020202020204" pitchFamily="34" charset="0"/>
                         <a:cs typeface="Times New Roman" panose="02020603050405020304" pitchFamily="18" charset="0"/>
@@ -5414,27 +5866,57 @@
                     <a:bodyPr/>
                     <a:lstStyle/>
                     <a:p>
-                      <a:pPr marL="0" marR="0">
+                      <a:pPr marL="0" marR="0" lvl="0" indent="0" algn="l" defTabSz="914400" rtl="0" eaLnBrk="1" fontAlgn="auto" latinLnBrk="0" hangingPunct="1">
                         <a:lnSpc>
                           <a:spcPct val="115000"/>
                         </a:lnSpc>
+                        <a:spcBef>
+                          <a:spcPts val="0"/>
+                        </a:spcBef>
                         <a:spcAft>
                           <a:spcPts val="800"/>
                         </a:spcAft>
+                        <a:buClrTx/>
+                        <a:buSzTx/>
+                        <a:buFontTx/>
                         <a:buNone/>
+                        <a:tabLst/>
+                        <a:defRPr/>
                       </a:pPr>
                       <a:r>
-                        <a:rPr lang="en-US" sz="2300" kern="100" dirty="0">
+                        <a:rPr kumimoji="0" lang="en-US" sz="2300" b="0" i="0" u="none" strike="noStrike" kern="100" cap="none" spc="0" normalizeH="0" baseline="0" noProof="0" dirty="0">
+                          <a:ln>
+                            <a:noFill/>
+                          </a:ln>
+                          <a:solidFill>
+                            <a:prstClr val="black"/>
+                          </a:solidFill>
                           <a:effectLst/>
+                          <a:uLnTx/>
+                          <a:uFillTx/>
+                          <a:latin typeface="Aptos" panose="02110004020202020204"/>
+                          <a:ea typeface="+mn-ea"/>
+                          <a:cs typeface="+mn-cs"/>
                         </a:rPr>
-                        <a:t>Yes</a:t>
+                        <a:t>Not </a:t>
                       </a:r>
-                      <a:endParaRPr lang="en-US" sz="2300" kern="100" dirty="0">
-                        <a:effectLst/>
-                        <a:latin typeface="Aptos" panose="020B0004020202020204" pitchFamily="34" charset="0"/>
-                        <a:ea typeface="Aptos" panose="020B0004020202020204" pitchFamily="34" charset="0"/>
-                        <a:cs typeface="Times New Roman" panose="02020603050405020304" pitchFamily="18" charset="0"/>
-                      </a:endParaRPr>
+                      <a:r>
+                        <a:rPr kumimoji="0" lang="en-US" sz="2300" b="0" i="0" u="none" strike="noStrike" kern="100" cap="none" spc="0" normalizeH="0" baseline="0" noProof="0" dirty="0">
+                          <a:ln>
+                            <a:noFill/>
+                          </a:ln>
+                          <a:solidFill>
+                            <a:prstClr val="black"/>
+                          </a:solidFill>
+                          <a:effectLst/>
+                          <a:uLnTx/>
+                          <a:uFillTx/>
+                          <a:latin typeface="Aptos" panose="020B0004020202020204" pitchFamily="34" charset="0"/>
+                          <a:ea typeface="Aptos" panose="020B0004020202020204" pitchFamily="34" charset="0"/>
+                          <a:cs typeface="Times New Roman" panose="02020603050405020304" pitchFamily="18" charset="0"/>
+                        </a:rPr>
+                        <a:t>Detected</a:t>
+                      </a:r>
                     </a:p>
                   </a:txBody>
                   <a:tcPr marL="128992" marR="128992" marT="0" marB="0"/>
@@ -5449,63 +5931,39 @@
           </a:graphicData>
         </a:graphic>
       </p:graphicFrame>
-      <p:sp>
-        <p:nvSpPr>
-          <p:cNvPr id="4" name="Rectangle 3" descr="Red separator bar. ">
-            <a:extLst>
-              <a:ext uri="{FF2B5EF4-FFF2-40B4-BE49-F238E27FC236}">
-                <a16:creationId xmlns:a16="http://schemas.microsoft.com/office/drawing/2014/main" id="{A0A53FB2-C801-505E-6CAE-9A829D7F8E0A}"/>
-              </a:ext>
-            </a:extLst>
-          </p:cNvPr>
-          <p:cNvSpPr/>
+      <p:pic>
+        <p:nvPicPr>
+          <p:cNvPr id="6" name="Picture 5" descr="Grouped bar graph comparing Quiz 1 and Quiz 2 averages across three sections. Section 1: 85% and 82%. Section 2: 83% and 81%. Section 3: 85% and 82%.">
+            <a:extLst>
+              <a:ext uri="{FF2B5EF4-FFF2-40B4-BE49-F238E27FC236}">
+                <a16:creationId xmlns:a16="http://schemas.microsoft.com/office/drawing/2014/main" id="{4E3C914D-C4DF-6B7F-D88F-1C8F5541EE3A}"/>
+              </a:ext>
+            </a:extLst>
+          </p:cNvPr>
+          <p:cNvPicPr>
+            <a:picLocks noChangeAspect="1"/>
+          </p:cNvPicPr>
           <p:nvPr/>
-        </p:nvSpPr>
+        </p:nvPicPr>
+        <p:blipFill>
+          <a:blip r:embed="rId3"/>
+          <a:srcRect/>
+          <a:stretch/>
+        </p:blipFill>
         <p:spPr>
           <a:xfrm>
-            <a:off x="6376086" y="2056713"/>
-            <a:ext cx="5140411" cy="130433"/>
+            <a:off x="5340569" y="1626914"/>
+            <a:ext cx="6324600" cy="3225800"/>
           </a:xfrm>
           <a:prstGeom prst="rect">
             <a:avLst/>
           </a:prstGeom>
-          <a:solidFill>
-            <a:srgbClr val="CC0033"/>
-          </a:solidFill>
         </p:spPr>
-        <p:style>
-          <a:lnRef idx="2">
-            <a:schemeClr val="accent1">
-              <a:shade val="15000"/>
-            </a:schemeClr>
-          </a:lnRef>
-          <a:fillRef idx="1">
-            <a:schemeClr val="accent1"/>
-          </a:fillRef>
-          <a:effectRef idx="0">
-            <a:schemeClr val="accent1"/>
-          </a:effectRef>
-          <a:fontRef idx="minor">
-            <a:schemeClr val="lt1"/>
-          </a:fontRef>
-        </p:style>
-        <p:txBody>
-          <a:bodyPr rot="0" spcFirstLastPara="0" vert="horz" wrap="square" lIns="91440" tIns="45720" rIns="91440" bIns="45720" numCol="1" spcCol="0" rtlCol="0" fromWordArt="0" anchor="ctr" anchorCtr="0" forceAA="0" compatLnSpc="1">
-            <a:prstTxWarp prst="textNoShape">
-              <a:avLst/>
-            </a:prstTxWarp>
-            <a:noAutofit/>
-          </a:bodyPr>
-          <a:lstStyle/>
-          <a:p>
-            <a:endParaRPr lang="en-US"/>
-          </a:p>
-        </p:txBody>
-      </p:sp>
+      </p:pic>
     </p:spTree>
     <p:extLst>
       <p:ext uri="{BB962C8B-B14F-4D97-AF65-F5344CB8AC3E}">
-        <p14:creationId xmlns:p14="http://schemas.microsoft.com/office/powerpoint/2010/main" val="135463311"/>
+        <p14:creationId xmlns:p14="http://schemas.microsoft.com/office/powerpoint/2010/main" val="3071139240"/>
       </p:ext>
     </p:extLst>
   </p:cSld>
@@ -5515,7 +5973,7 @@
 </p:sld>
 </file>
 
-<file path=ppt/slides/slide4.xml><?xml version="1.0" encoding="utf-8"?>
+<file path=ppt/slides/slide6.xml><?xml version="1.0" encoding="utf-8"?>
 <p:sld xmlns:a="http://schemas.openxmlformats.org/drawingml/2006/main" xmlns:r="http://schemas.openxmlformats.org/officeDocument/2006/relationships" xmlns:p="http://schemas.openxmlformats.org/presentationml/2006/main">
   <p:cSld>
     <p:spTree>
@@ -5523,7 +5981,7 @@
         <p:cNvPr id="1" name="">
           <a:extLst>
             <a:ext uri="{FF2B5EF4-FFF2-40B4-BE49-F238E27FC236}">
-              <a16:creationId xmlns:a16="http://schemas.microsoft.com/office/drawing/2014/main" id="{2CF0BA1A-A634-B41B-DFF1-50AC1E41A4DC}"/>
+              <a16:creationId xmlns:a16="http://schemas.microsoft.com/office/drawing/2014/main" id="{94D8EC60-BCC6-F229-D4D8-417BAFC4B3BF}"/>
             </a:ext>
           </a:extLst>
         </p:cNvPr>
@@ -5543,7 +6001,7 @@
           <p:cNvPr id="2" name="Title 1">
             <a:extLst>
               <a:ext uri="{FF2B5EF4-FFF2-40B4-BE49-F238E27FC236}">
-                <a16:creationId xmlns:a16="http://schemas.microsoft.com/office/drawing/2014/main" id="{B09FA19B-E128-B951-DE71-8E4FE9065E66}"/>
+                <a16:creationId xmlns:a16="http://schemas.microsoft.com/office/drawing/2014/main" id="{56D95EC3-0380-0BE8-2D67-B206ED8E7869}"/>
               </a:ext>
             </a:extLst>
           </p:cNvPr>
@@ -5556,12 +6014,14 @@
         </p:nvSpPr>
         <p:spPr/>
         <p:txBody>
-          <a:bodyPr/>
+          <a:bodyPr>
+            <a:normAutofit/>
+          </a:bodyPr>
           <a:lstStyle/>
           <a:p>
             <a:r>
               <a:rPr lang="en-US" b="1" dirty="0"/>
-              <a:t>Poorly constructed text alternative: vague</a:t>
+              <a:t>Poorly constructed text alternative: inaccurate</a:t>
             </a:r>
           </a:p>
         </p:txBody>
@@ -5571,7 +6031,7 @@
           <p:cNvPr id="3" name="Content Placeholder 2">
             <a:extLst>
               <a:ext uri="{FF2B5EF4-FFF2-40B4-BE49-F238E27FC236}">
-                <a16:creationId xmlns:a16="http://schemas.microsoft.com/office/drawing/2014/main" id="{BEFB9504-759E-3497-2FC1-A592FFB304CD}"/>
+                <a16:creationId xmlns:a16="http://schemas.microsoft.com/office/drawing/2014/main" id="{49B57FA9-A70D-BF22-D514-3E507CC9E212}"/>
               </a:ext>
             </a:extLst>
           </p:cNvPr>
@@ -5599,7 +6059,15 @@
             </a:pPr>
             <a:r>
               <a:rPr lang="en-US" dirty="0"/>
-              <a:t>The text alternative here just reads “quiz averages.”</a:t>
+              <a:t>The text alternative here is just the file name “</a:t>
+            </a:r>
+            <a:r>
+              <a:rPr lang="en-US" sz="2400" dirty="0" err="1"/>
+              <a:t>RSUNJ_H_RED_BLACK_RGB.png</a:t>
+            </a:r>
+            <a:r>
+              <a:rPr lang="en-US" dirty="0"/>
+              <a:t>.” </a:t>
             </a:r>
           </a:p>
         </p:txBody>
@@ -5609,14 +6077,20 @@
           <p:cNvPr id="20" name="Table 19">
             <a:extLst>
               <a:ext uri="{FF2B5EF4-FFF2-40B4-BE49-F238E27FC236}">
-                <a16:creationId xmlns:a16="http://schemas.microsoft.com/office/drawing/2014/main" id="{4F7D5C41-4403-F8E6-36E8-934F09575587}"/>
+                <a16:creationId xmlns:a16="http://schemas.microsoft.com/office/drawing/2014/main" id="{BBC0CCB4-1918-8EEB-B253-8F530796EFEB}"/>
               </a:ext>
             </a:extLst>
           </p:cNvPr>
           <p:cNvGraphicFramePr>
             <a:graphicFrameLocks noGrp="1"/>
           </p:cNvGraphicFramePr>
-          <p:nvPr/>
+          <p:nvPr>
+            <p:extLst>
+              <p:ext uri="{D42A27DB-BD31-4B8C-83A1-F6EECF244321}">
+                <p14:modId xmlns:p14="http://schemas.microsoft.com/office/powerpoint/2010/main" val="1609673361"/>
+              </p:ext>
+            </p:extLst>
+          </p:nvPr>
         </p:nvGraphicFramePr>
         <p:xfrm>
           <a:off x="810440" y="5354380"/>
@@ -5784,27 +6258,40 @@
                     <a:bodyPr/>
                     <a:lstStyle/>
                     <a:p>
-                      <a:pPr marL="0" marR="0">
+                      <a:pPr marL="0" marR="0" lvl="0" indent="0" algn="l" defTabSz="914400" rtl="0" eaLnBrk="1" fontAlgn="auto" latinLnBrk="0" hangingPunct="1">
                         <a:lnSpc>
                           <a:spcPct val="115000"/>
                         </a:lnSpc>
+                        <a:spcBef>
+                          <a:spcPts val="0"/>
+                        </a:spcBef>
                         <a:spcAft>
                           <a:spcPts val="800"/>
                         </a:spcAft>
+                        <a:buClrTx/>
+                        <a:buSzTx/>
+                        <a:buFontTx/>
                         <a:buNone/>
+                        <a:tabLst/>
+                        <a:defRPr/>
                       </a:pPr>
                       <a:r>
-                        <a:rPr lang="en-US" sz="2300" kern="100" dirty="0">
+                        <a:rPr kumimoji="0" lang="en-US" sz="2300" b="0" i="0" u="none" strike="noStrike" kern="100" cap="none" spc="0" normalizeH="0" baseline="0" noProof="0" dirty="0">
+                          <a:ln>
+                            <a:noFill/>
+                          </a:ln>
+                          <a:solidFill>
+                            <a:prstClr val="black"/>
+                          </a:solidFill>
                           <a:effectLst/>
+                          <a:uLnTx/>
+                          <a:uFillTx/>
+                          <a:latin typeface="Aptos" panose="020B0004020202020204" pitchFamily="34" charset="0"/>
+                          <a:ea typeface="Aptos" panose="020B0004020202020204" pitchFamily="34" charset="0"/>
+                          <a:cs typeface="Times New Roman" panose="02020603050405020304" pitchFamily="18" charset="0"/>
                         </a:rPr>
-                        <a:t>No</a:t>
+                        <a:t>Detected</a:t>
                       </a:r>
-                      <a:endParaRPr lang="en-US" sz="2300" kern="100" dirty="0">
-                        <a:effectLst/>
-                        <a:latin typeface="Aptos" panose="020B0004020202020204" pitchFamily="34" charset="0"/>
-                        <a:ea typeface="Aptos" panose="020B0004020202020204" pitchFamily="34" charset="0"/>
-                        <a:cs typeface="Times New Roman" panose="02020603050405020304" pitchFamily="18" charset="0"/>
-                      </a:endParaRPr>
                     </a:p>
                   </a:txBody>
                   <a:tcPr marL="128992" marR="128992" marT="0" marB="0"/>
@@ -5814,27 +6301,40 @@
                     <a:bodyPr/>
                     <a:lstStyle/>
                     <a:p>
-                      <a:pPr marL="0" marR="0">
+                      <a:pPr marL="0" marR="0" lvl="0" indent="0" algn="l" defTabSz="914400" rtl="0" eaLnBrk="1" fontAlgn="auto" latinLnBrk="0" hangingPunct="1">
                         <a:lnSpc>
                           <a:spcPct val="115000"/>
                         </a:lnSpc>
+                        <a:spcBef>
+                          <a:spcPts val="0"/>
+                        </a:spcBef>
                         <a:spcAft>
                           <a:spcPts val="800"/>
                         </a:spcAft>
+                        <a:buClrTx/>
+                        <a:buSzTx/>
+                        <a:buFontTx/>
                         <a:buNone/>
+                        <a:tabLst/>
+                        <a:defRPr/>
                       </a:pPr>
                       <a:r>
-                        <a:rPr lang="en-US" sz="2300" kern="100" dirty="0">
+                        <a:rPr kumimoji="0" lang="en-US" sz="2300" b="0" i="0" u="none" strike="noStrike" kern="100" cap="none" spc="0" normalizeH="0" baseline="0" noProof="0" dirty="0">
+                          <a:ln>
+                            <a:noFill/>
+                          </a:ln>
+                          <a:solidFill>
+                            <a:prstClr val="black"/>
+                          </a:solidFill>
                           <a:effectLst/>
+                          <a:uLnTx/>
+                          <a:uFillTx/>
+                          <a:latin typeface="Aptos" panose="020B0004020202020204" pitchFamily="34" charset="0"/>
+                          <a:ea typeface="Aptos" panose="020B0004020202020204" pitchFamily="34" charset="0"/>
+                          <a:cs typeface="Times New Roman" panose="02020603050405020304" pitchFamily="18" charset="0"/>
                         </a:rPr>
-                        <a:t>Yes</a:t>
+                        <a:t>Detected</a:t>
                       </a:r>
-                      <a:endParaRPr lang="en-US" sz="2300" kern="100" dirty="0">
-                        <a:effectLst/>
-                        <a:latin typeface="Aptos" panose="020B0004020202020204" pitchFamily="34" charset="0"/>
-                        <a:ea typeface="Aptos" panose="020B0004020202020204" pitchFamily="34" charset="0"/>
-                        <a:cs typeface="Times New Roman" panose="02020603050405020304" pitchFamily="18" charset="0"/>
-                      </a:endParaRPr>
                     </a:p>
                   </a:txBody>
                   <a:tcPr marL="128992" marR="128992" marT="0" marB="0"/>
@@ -5849,38 +6349,46 @@
           </a:graphicData>
         </a:graphic>
       </p:graphicFrame>
-      <p:graphicFrame>
-        <p:nvGraphicFramePr>
-          <p:cNvPr id="5" name="Chart 4" descr="Quiz averages. ">
-            <a:extLst>
-              <a:ext uri="{FF2B5EF4-FFF2-40B4-BE49-F238E27FC236}">
-                <a16:creationId xmlns:a16="http://schemas.microsoft.com/office/drawing/2014/main" id="{67666AA5-9B3A-1028-CB58-09C2F49A3F0C}"/>
-              </a:ext>
-            </a:extLst>
-          </p:cNvPr>
-          <p:cNvGraphicFramePr/>
-          <p:nvPr>
-            <p:extLst>
-              <p:ext uri="{D42A27DB-BD31-4B8C-83A1-F6EECF244321}">
-                <p14:modId xmlns:p14="http://schemas.microsoft.com/office/powerpoint/2010/main" val="479756881"/>
-              </p:ext>
-            </p:extLst>
-          </p:nvPr>
-        </p:nvGraphicFramePr>
-        <p:xfrm>
-          <a:off x="6911957" y="1729155"/>
-          <a:ext cx="4765177" cy="2779687"/>
-        </p:xfrm>
-        <a:graphic>
-          <a:graphicData uri="http://schemas.openxmlformats.org/drawingml/2006/chart">
-            <c:chart xmlns:c="http://schemas.openxmlformats.org/drawingml/2006/chart" xmlns:r="http://schemas.openxmlformats.org/officeDocument/2006/relationships" r:id="rId2"/>
-          </a:graphicData>
-        </a:graphic>
-      </p:graphicFrame>
+      <p:pic>
+        <p:nvPicPr>
+          <p:cNvPr id="4" name="Picture 3" descr="RSUNJ_H_RED_BLACK_RGB.png">
+            <a:extLst>
+              <a:ext uri="{FF2B5EF4-FFF2-40B4-BE49-F238E27FC236}">
+                <a16:creationId xmlns:a16="http://schemas.microsoft.com/office/drawing/2014/main" id="{DAB54F03-51EE-7512-93E2-B437D3B611A2}"/>
+              </a:ext>
+            </a:extLst>
+          </p:cNvPr>
+          <p:cNvPicPr>
+            <a:picLocks noChangeAspect="1"/>
+          </p:cNvPicPr>
+          <p:nvPr/>
+        </p:nvPicPr>
+        <p:blipFill>
+          <a:blip r:embed="rId2" cstate="print">
+            <a:extLst>
+              <a:ext uri="{28A0092B-C50C-407E-A947-70E740481C1C}">
+                <a14:useLocalDpi xmlns:a14="http://schemas.microsoft.com/office/drawing/2010/main" val="0"/>
+              </a:ext>
+            </a:extLst>
+          </a:blip>
+          <a:stretch>
+            <a:fillRect/>
+          </a:stretch>
+        </p:blipFill>
+        <p:spPr>
+          <a:xfrm>
+            <a:off x="6448270" y="1953509"/>
+            <a:ext cx="3872969" cy="1024470"/>
+          </a:xfrm>
+          <a:prstGeom prst="rect">
+            <a:avLst/>
+          </a:prstGeom>
+        </p:spPr>
+      </p:pic>
     </p:spTree>
     <p:extLst>
       <p:ext uri="{BB962C8B-B14F-4D97-AF65-F5344CB8AC3E}">
-        <p14:creationId xmlns:p14="http://schemas.microsoft.com/office/powerpoint/2010/main" val="2892249461"/>
+        <p14:creationId xmlns:p14="http://schemas.microsoft.com/office/powerpoint/2010/main" val="1071637548"/>
       </p:ext>
     </p:extLst>
   </p:cSld>
@@ -5890,7 +6398,7 @@
 </p:sld>
 </file>
 
-<file path=ppt/slides/slide5.xml><?xml version="1.0" encoding="utf-8"?>
+<file path=ppt/slides/slide7.xml><?xml version="1.0" encoding="utf-8"?>
 <p:sld xmlns:a="http://schemas.openxmlformats.org/drawingml/2006/main" xmlns:r="http://schemas.openxmlformats.org/officeDocument/2006/relationships" xmlns:p="http://schemas.openxmlformats.org/presentationml/2006/main">
   <p:cSld>
     <p:spTree>
@@ -5898,7 +6406,7 @@
         <p:cNvPr id="1" name="">
           <a:extLst>
             <a:ext uri="{FF2B5EF4-FFF2-40B4-BE49-F238E27FC236}">
-              <a16:creationId xmlns:a16="http://schemas.microsoft.com/office/drawing/2014/main" id="{94D8EC60-BCC6-F229-D4D8-417BAFC4B3BF}"/>
+              <a16:creationId xmlns:a16="http://schemas.microsoft.com/office/drawing/2014/main" id="{787014D3-5673-933E-A7F8-29C2D795BCFE}"/>
             </a:ext>
           </a:extLst>
         </p:cNvPr>
@@ -5918,7 +6426,7 @@
           <p:cNvPr id="2" name="Title 1">
             <a:extLst>
               <a:ext uri="{FF2B5EF4-FFF2-40B4-BE49-F238E27FC236}">
-                <a16:creationId xmlns:a16="http://schemas.microsoft.com/office/drawing/2014/main" id="{56D95EC3-0380-0BE8-2D67-B206ED8E7869}"/>
+                <a16:creationId xmlns:a16="http://schemas.microsoft.com/office/drawing/2014/main" id="{7A0D2E95-1B0D-B9AF-E31B-87919B3E6227}"/>
               </a:ext>
             </a:extLst>
           </p:cNvPr>
@@ -5938,7 +6446,7 @@
           <a:p>
             <a:r>
               <a:rPr lang="en-US" b="1" dirty="0"/>
-              <a:t>Poorly constructed text alternative: inaccurate</a:t>
+              <a:t>Poorly constructed text alternative: gibberish</a:t>
             </a:r>
           </a:p>
         </p:txBody>
@@ -5948,7 +6456,7 @@
           <p:cNvPr id="3" name="Content Placeholder 2">
             <a:extLst>
               <a:ext uri="{FF2B5EF4-FFF2-40B4-BE49-F238E27FC236}">
-                <a16:creationId xmlns:a16="http://schemas.microsoft.com/office/drawing/2014/main" id="{49B57FA9-A70D-BF22-D514-3E507CC9E212}"/>
+                <a16:creationId xmlns:a16="http://schemas.microsoft.com/office/drawing/2014/main" id="{600EC3BB-0D96-CEEA-4F56-C277DD394C43}"/>
               </a:ext>
             </a:extLst>
           </p:cNvPr>
@@ -5980,7 +6488,7 @@
             </a:r>
             <a:r>
               <a:rPr lang="en-US" dirty="0" err="1"/>
-              <a:t>RSUNJ_H_RED_BLACK_RGB.png</a:t>
+              <a:t>asldkfjasdlfkj</a:t>
             </a:r>
             <a:r>
               <a:rPr lang="en-US" dirty="0"/>
@@ -5994,14 +6502,20 @@
           <p:cNvPr id="20" name="Table 19">
             <a:extLst>
               <a:ext uri="{FF2B5EF4-FFF2-40B4-BE49-F238E27FC236}">
-                <a16:creationId xmlns:a16="http://schemas.microsoft.com/office/drawing/2014/main" id="{BBC0CCB4-1918-8EEB-B253-8F530796EFEB}"/>
+                <a16:creationId xmlns:a16="http://schemas.microsoft.com/office/drawing/2014/main" id="{DF9720D3-9091-55A0-90DD-CEA7A0D2DDA5}"/>
               </a:ext>
             </a:extLst>
           </p:cNvPr>
           <p:cNvGraphicFramePr>
             <a:graphicFrameLocks noGrp="1"/>
           </p:cNvGraphicFramePr>
-          <p:nvPr/>
+          <p:nvPr>
+            <p:extLst>
+              <p:ext uri="{D42A27DB-BD31-4B8C-83A1-F6EECF244321}">
+                <p14:modId xmlns:p14="http://schemas.microsoft.com/office/powerpoint/2010/main" val="3517563960"/>
+              </p:ext>
+            </p:extLst>
+          </p:nvPr>
         </p:nvGraphicFramePr>
         <p:xfrm>
           <a:off x="810440" y="5354380"/>
@@ -6169,6 +6683,344 @@
                     <a:bodyPr/>
                     <a:lstStyle/>
                     <a:p>
+                      <a:pPr marL="0" marR="0" lvl="0" indent="0" algn="l" defTabSz="914400" rtl="0" eaLnBrk="1" fontAlgn="auto" latinLnBrk="0" hangingPunct="1">
+                        <a:lnSpc>
+                          <a:spcPct val="115000"/>
+                        </a:lnSpc>
+                        <a:spcBef>
+                          <a:spcPts val="0"/>
+                        </a:spcBef>
+                        <a:spcAft>
+                          <a:spcPts val="800"/>
+                        </a:spcAft>
+                        <a:buClrTx/>
+                        <a:buSzTx/>
+                        <a:buFontTx/>
+                        <a:buNone/>
+                        <a:tabLst/>
+                        <a:defRPr/>
+                      </a:pPr>
+                      <a:r>
+                        <a:rPr kumimoji="0" lang="en-US" sz="2300" b="0" i="0" u="none" strike="noStrike" kern="100" cap="none" spc="0" normalizeH="0" baseline="0" noProof="0">
+                          <a:ln>
+                            <a:noFill/>
+                          </a:ln>
+                          <a:solidFill>
+                            <a:prstClr val="black"/>
+                          </a:solidFill>
+                          <a:effectLst/>
+                          <a:uLnTx/>
+                          <a:uFillTx/>
+                          <a:latin typeface="Aptos" panose="02110004020202020204"/>
+                          <a:ea typeface="+mn-ea"/>
+                          <a:cs typeface="+mn-cs"/>
+                        </a:rPr>
+                        <a:t>Not </a:t>
+                      </a:r>
+                      <a:r>
+                        <a:rPr kumimoji="0" lang="en-US" sz="2300" b="0" i="0" u="none" strike="noStrike" kern="100" cap="none" spc="0" normalizeH="0" baseline="0" noProof="0">
+                          <a:ln>
+                            <a:noFill/>
+                          </a:ln>
+                          <a:solidFill>
+                            <a:prstClr val="black"/>
+                          </a:solidFill>
+                          <a:effectLst/>
+                          <a:uLnTx/>
+                          <a:uFillTx/>
+                          <a:latin typeface="Aptos" panose="020B0004020202020204" pitchFamily="34" charset="0"/>
+                          <a:ea typeface="Aptos" panose="020B0004020202020204" pitchFamily="34" charset="0"/>
+                          <a:cs typeface="Times New Roman" panose="02020603050405020304" pitchFamily="18" charset="0"/>
+                        </a:rPr>
+                        <a:t>Detected</a:t>
+                      </a:r>
+                      <a:endParaRPr kumimoji="0" lang="en-US" sz="2300" b="0" i="0" u="none" strike="noStrike" kern="100" cap="none" spc="0" normalizeH="0" baseline="0" noProof="0" dirty="0">
+                        <a:ln>
+                          <a:noFill/>
+                        </a:ln>
+                        <a:solidFill>
+                          <a:prstClr val="black"/>
+                        </a:solidFill>
+                        <a:effectLst/>
+                        <a:uLnTx/>
+                        <a:uFillTx/>
+                        <a:latin typeface="Aptos" panose="020B0004020202020204" pitchFamily="34" charset="0"/>
+                        <a:ea typeface="Aptos" panose="020B0004020202020204" pitchFamily="34" charset="0"/>
+                        <a:cs typeface="Times New Roman" panose="02020603050405020304" pitchFamily="18" charset="0"/>
+                      </a:endParaRPr>
+                    </a:p>
+                  </a:txBody>
+                  <a:tcPr marL="128992" marR="128992" marT="0" marB="0"/>
+                </a:tc>
+                <a:tc>
+                  <a:txBody>
+                    <a:bodyPr/>
+                    <a:lstStyle/>
+                    <a:p>
+                      <a:pPr marL="0" marR="0" lvl="0" indent="0" algn="l" defTabSz="914400" rtl="0" eaLnBrk="1" fontAlgn="auto" latinLnBrk="0" hangingPunct="1">
+                        <a:lnSpc>
+                          <a:spcPct val="115000"/>
+                        </a:lnSpc>
+                        <a:spcBef>
+                          <a:spcPts val="0"/>
+                        </a:spcBef>
+                        <a:spcAft>
+                          <a:spcPts val="800"/>
+                        </a:spcAft>
+                        <a:buClrTx/>
+                        <a:buSzTx/>
+                        <a:buFontTx/>
+                        <a:buNone/>
+                        <a:tabLst/>
+                        <a:defRPr/>
+                      </a:pPr>
+                      <a:r>
+                        <a:rPr kumimoji="0" lang="en-US" sz="2300" b="0" i="0" u="none" strike="noStrike" kern="100" cap="none" spc="0" normalizeH="0" baseline="0" noProof="0" dirty="0">
+                          <a:ln>
+                            <a:noFill/>
+                          </a:ln>
+                          <a:solidFill>
+                            <a:prstClr val="black"/>
+                          </a:solidFill>
+                          <a:effectLst/>
+                          <a:uLnTx/>
+                          <a:uFillTx/>
+                          <a:latin typeface="Aptos" panose="02110004020202020204"/>
+                          <a:ea typeface="+mn-ea"/>
+                          <a:cs typeface="+mn-cs"/>
+                        </a:rPr>
+                        <a:t>Not </a:t>
+                      </a:r>
+                      <a:r>
+                        <a:rPr kumimoji="0" lang="en-US" sz="2300" b="0" i="0" u="none" strike="noStrike" kern="100" cap="none" spc="0" normalizeH="0" baseline="0" noProof="0" dirty="0">
+                          <a:ln>
+                            <a:noFill/>
+                          </a:ln>
+                          <a:solidFill>
+                            <a:prstClr val="black"/>
+                          </a:solidFill>
+                          <a:effectLst/>
+                          <a:uLnTx/>
+                          <a:uFillTx/>
+                          <a:latin typeface="Aptos" panose="020B0004020202020204" pitchFamily="34" charset="0"/>
+                          <a:ea typeface="Aptos" panose="020B0004020202020204" pitchFamily="34" charset="0"/>
+                          <a:cs typeface="Times New Roman" panose="02020603050405020304" pitchFamily="18" charset="0"/>
+                        </a:rPr>
+                        <a:t>Detected</a:t>
+                      </a:r>
+                    </a:p>
+                  </a:txBody>
+                  <a:tcPr marL="128992" marR="128992" marT="0" marB="0"/>
+                </a:tc>
+                <a:extLst>
+                  <a:ext uri="{0D108BD9-81ED-4DB2-BD59-A6C34878D82A}">
+                    <a16:rowId xmlns:a16="http://schemas.microsoft.com/office/drawing/2014/main" val="4046348799"/>
+                  </a:ext>
+                </a:extLst>
+              </a:tr>
+            </a:tbl>
+          </a:graphicData>
+        </a:graphic>
+      </p:graphicFrame>
+      <p:pic>
+        <p:nvPicPr>
+          <p:cNvPr id="4" name="Picture 3" descr="asldkfjasdlfkj">
+            <a:extLst>
+              <a:ext uri="{FF2B5EF4-FFF2-40B4-BE49-F238E27FC236}">
+                <a16:creationId xmlns:a16="http://schemas.microsoft.com/office/drawing/2014/main" id="{8745A873-1CBB-7251-F4B5-D2F79AEFA747}"/>
+              </a:ext>
+            </a:extLst>
+          </p:cNvPr>
+          <p:cNvPicPr>
+            <a:picLocks noChangeAspect="1"/>
+          </p:cNvPicPr>
+          <p:nvPr/>
+        </p:nvPicPr>
+        <p:blipFill>
+          <a:blip r:embed="rId2" cstate="print">
+            <a:extLst>
+              <a:ext uri="{28A0092B-C50C-407E-A947-70E740481C1C}">
+                <a14:useLocalDpi xmlns:a14="http://schemas.microsoft.com/office/drawing/2010/main" val="0"/>
+              </a:ext>
+            </a:extLst>
+          </a:blip>
+          <a:stretch>
+            <a:fillRect/>
+          </a:stretch>
+        </p:blipFill>
+        <p:spPr>
+          <a:xfrm>
+            <a:off x="6448270" y="1953509"/>
+            <a:ext cx="3872969" cy="1024470"/>
+          </a:xfrm>
+          <a:prstGeom prst="rect">
+            <a:avLst/>
+          </a:prstGeom>
+        </p:spPr>
+      </p:pic>
+    </p:spTree>
+    <p:extLst>
+      <p:ext uri="{BB962C8B-B14F-4D97-AF65-F5344CB8AC3E}">
+        <p14:creationId xmlns:p14="http://schemas.microsoft.com/office/powerpoint/2010/main" val="245817610"/>
+      </p:ext>
+    </p:extLst>
+  </p:cSld>
+  <p:clrMapOvr>
+    <a:masterClrMapping/>
+  </p:clrMapOvr>
+</p:sld>
+</file>
+
+<file path=ppt/slides/slide8.xml><?xml version="1.0" encoding="utf-8"?>
+<p:sld xmlns:a="http://schemas.openxmlformats.org/drawingml/2006/main" xmlns:r="http://schemas.openxmlformats.org/officeDocument/2006/relationships" xmlns:p="http://schemas.openxmlformats.org/presentationml/2006/main">
+  <p:cSld>
+    <p:spTree>
+      <p:nvGrpSpPr>
+        <p:cNvPr id="1" name="">
+          <a:extLst>
+            <a:ext uri="{FF2B5EF4-FFF2-40B4-BE49-F238E27FC236}">
+              <a16:creationId xmlns:a16="http://schemas.microsoft.com/office/drawing/2014/main" id="{0C29BD07-1D5D-CC42-CBF1-7815B6C63C90}"/>
+            </a:ext>
+          </a:extLst>
+        </p:cNvPr>
+        <p:cNvGrpSpPr/>
+        <p:nvPr/>
+      </p:nvGrpSpPr>
+      <p:grpSpPr>
+        <a:xfrm>
+          <a:off x="0" y="0"/>
+          <a:ext cx="0" cy="0"/>
+          <a:chOff x="0" y="0"/>
+          <a:chExt cx="0" cy="0"/>
+        </a:xfrm>
+      </p:grpSpPr>
+      <p:sp>
+        <p:nvSpPr>
+          <p:cNvPr id="2" name="Title 1">
+            <a:extLst>
+              <a:ext uri="{FF2B5EF4-FFF2-40B4-BE49-F238E27FC236}">
+                <a16:creationId xmlns:a16="http://schemas.microsoft.com/office/drawing/2014/main" id="{C8518AE6-E43F-1DB7-5930-33DD4C9492BE}"/>
+              </a:ext>
+            </a:extLst>
+          </p:cNvPr>
+          <p:cNvSpPr>
+            <a:spLocks noGrp="1"/>
+          </p:cNvSpPr>
+          <p:nvPr>
+            <p:ph type="title"/>
+          </p:nvPr>
+        </p:nvSpPr>
+        <p:spPr/>
+        <p:txBody>
+          <a:bodyPr>
+            <a:normAutofit/>
+          </a:bodyPr>
+          <a:lstStyle/>
+          <a:p>
+            <a:r>
+              <a:rPr lang="en-US" b="1" dirty="0"/>
+              <a:t>Poorly constructed text alternative: placeholder</a:t>
+            </a:r>
+          </a:p>
+        </p:txBody>
+      </p:sp>
+      <p:sp>
+        <p:nvSpPr>
+          <p:cNvPr id="3" name="Content Placeholder 2">
+            <a:extLst>
+              <a:ext uri="{FF2B5EF4-FFF2-40B4-BE49-F238E27FC236}">
+                <a16:creationId xmlns:a16="http://schemas.microsoft.com/office/drawing/2014/main" id="{DC21CECA-525D-2661-F54A-DB2967EFC132}"/>
+              </a:ext>
+            </a:extLst>
+          </p:cNvPr>
+          <p:cNvSpPr>
+            <a:spLocks noGrp="1"/>
+          </p:cNvSpPr>
+          <p:nvPr>
+            <p:ph idx="1"/>
+          </p:nvPr>
+        </p:nvSpPr>
+        <p:spPr>
+          <a:xfrm>
+            <a:off x="838200" y="1825624"/>
+            <a:ext cx="5325094" cy="3253003"/>
+          </a:xfrm>
+        </p:spPr>
+        <p:txBody>
+          <a:bodyPr>
+            <a:normAutofit/>
+          </a:bodyPr>
+          <a:lstStyle/>
+          <a:p>
+            <a:pPr marL="0" indent="0">
+              <a:buNone/>
+            </a:pPr>
+            <a:r>
+              <a:rPr lang="en-US" dirty="0"/>
+              <a:t>The text alternative here is just the file name “image.” </a:t>
+            </a:r>
+          </a:p>
+        </p:txBody>
+      </p:sp>
+      <p:graphicFrame>
+        <p:nvGraphicFramePr>
+          <p:cNvPr id="20" name="Table 19">
+            <a:extLst>
+              <a:ext uri="{FF2B5EF4-FFF2-40B4-BE49-F238E27FC236}">
+                <a16:creationId xmlns:a16="http://schemas.microsoft.com/office/drawing/2014/main" id="{D1C4F358-F2E8-384F-7205-D428023C2636}"/>
+              </a:ext>
+            </a:extLst>
+          </p:cNvPr>
+          <p:cNvGraphicFramePr>
+            <a:graphicFrameLocks noGrp="1"/>
+          </p:cNvGraphicFramePr>
+          <p:nvPr>
+            <p:extLst>
+              <p:ext uri="{D42A27DB-BD31-4B8C-83A1-F6EECF244321}">
+                <p14:modId xmlns:p14="http://schemas.microsoft.com/office/powerpoint/2010/main" val="197830095"/>
+              </p:ext>
+            </p:extLst>
+          </p:nvPr>
+        </p:nvGraphicFramePr>
+        <p:xfrm>
+          <a:off x="810440" y="5354380"/>
+          <a:ext cx="7518573" cy="1169544"/>
+        </p:xfrm>
+        <a:graphic>
+          <a:graphicData uri="http://schemas.openxmlformats.org/drawingml/2006/table">
+            <a:tbl>
+              <a:tblPr firstRow="1" firstCol="1" bandRow="1">
+                <a:tableStyleId>{5C22544A-7EE6-4342-B048-85BDC9FD1C3A}</a:tableStyleId>
+              </a:tblPr>
+              <a:tblGrid>
+                <a:gridCol w="1713924">
+                  <a:extLst>
+                    <a:ext uri="{9D8B030D-6E8A-4147-A177-3AD203B41FA5}">
+                      <a16:colId xmlns:a16="http://schemas.microsoft.com/office/drawing/2014/main" val="2587052964"/>
+                    </a:ext>
+                  </a:extLst>
+                </a:gridCol>
+                <a:gridCol w="2794831">
+                  <a:extLst>
+                    <a:ext uri="{9D8B030D-6E8A-4147-A177-3AD203B41FA5}">
+                      <a16:colId xmlns:a16="http://schemas.microsoft.com/office/drawing/2014/main" val="1997474820"/>
+                    </a:ext>
+                  </a:extLst>
+                </a:gridCol>
+                <a:gridCol w="3009818">
+                  <a:extLst>
+                    <a:ext uri="{9D8B030D-6E8A-4147-A177-3AD203B41FA5}">
+                      <a16:colId xmlns:a16="http://schemas.microsoft.com/office/drawing/2014/main" val="123640046"/>
+                    </a:ext>
+                  </a:extLst>
+                </a:gridCol>
+              </a:tblGrid>
+              <a:tr h="771564">
+                <a:tc>
+                  <a:txBody>
+                    <a:bodyPr/>
+                    <a:lstStyle/>
+                    <a:p>
                       <a:pPr marL="0" marR="0">
                         <a:lnSpc>
                           <a:spcPct val="115000"/>
@@ -6179,12 +7031,42 @@
                         <a:buNone/>
                       </a:pPr>
                       <a:r>
-                        <a:rPr lang="en-US" sz="2300" kern="100" dirty="0">
+                        <a:rPr lang="en-US" sz="2300" kern="100">
                           <a:effectLst/>
                         </a:rPr>
-                        <a:t>No</a:t>
+                        <a:t> </a:t>
                       </a:r>
-                      <a:endParaRPr lang="en-US" sz="2300" kern="100" dirty="0">
+                      <a:endParaRPr lang="en-US" sz="2300" kern="100">
+                        <a:effectLst/>
+                        <a:latin typeface="Aptos" panose="020B0004020202020204" pitchFamily="34" charset="0"/>
+                        <a:ea typeface="Aptos" panose="020B0004020202020204" pitchFamily="34" charset="0"/>
+                        <a:cs typeface="Times New Roman" panose="02020603050405020304" pitchFamily="18" charset="0"/>
+                      </a:endParaRPr>
+                    </a:p>
+                  </a:txBody>
+                  <a:tcPr marL="128992" marR="128992" marT="0" marB="0"/>
+                </a:tc>
+                <a:tc>
+                  <a:txBody>
+                    <a:bodyPr/>
+                    <a:lstStyle/>
+                    <a:p>
+                      <a:pPr marL="0" marR="0">
+                        <a:lnSpc>
+                          <a:spcPct val="115000"/>
+                        </a:lnSpc>
+                        <a:spcAft>
+                          <a:spcPts val="800"/>
+                        </a:spcAft>
+                        <a:buNone/>
+                      </a:pPr>
+                      <a:r>
+                        <a:rPr lang="en-US" sz="2300" kern="100">
+                          <a:effectLst/>
+                        </a:rPr>
+                        <a:t>A11y automated checker</a:t>
+                      </a:r>
+                      <a:endParaRPr lang="en-US" sz="2300" kern="100">
                         <a:effectLst/>
                         <a:latin typeface="Aptos" panose="020B0004020202020204" pitchFamily="34" charset="0"/>
                         <a:ea typeface="Aptos" panose="020B0004020202020204" pitchFamily="34" charset="0"/>
@@ -6212,7 +7094,7 @@
                         <a:rPr lang="en-US" sz="2300" kern="100" dirty="0">
                           <a:effectLst/>
                         </a:rPr>
-                        <a:t>Yes</a:t>
+                        <a:t>MS Accessibility checker</a:t>
                       </a:r>
                       <a:endParaRPr lang="en-US" sz="2300" kern="100" dirty="0">
                         <a:effectLst/>
@@ -6220,6 +7102,177 @@
                         <a:ea typeface="Aptos" panose="020B0004020202020204" pitchFamily="34" charset="0"/>
                         <a:cs typeface="Times New Roman" panose="02020603050405020304" pitchFamily="18" charset="0"/>
                       </a:endParaRPr>
+                    </a:p>
+                  </a:txBody>
+                  <a:tcPr marL="128992" marR="128992" marT="0" marB="0"/>
+                </a:tc>
+                <a:extLst>
+                  <a:ext uri="{0D108BD9-81ED-4DB2-BD59-A6C34878D82A}">
+                    <a16:rowId xmlns:a16="http://schemas.microsoft.com/office/drawing/2014/main" val="2904024515"/>
+                  </a:ext>
+                </a:extLst>
+              </a:tr>
+              <a:tr h="376109">
+                <a:tc>
+                  <a:txBody>
+                    <a:bodyPr/>
+                    <a:lstStyle/>
+                    <a:p>
+                      <a:pPr marL="0" marR="0">
+                        <a:lnSpc>
+                          <a:spcPct val="115000"/>
+                        </a:lnSpc>
+                        <a:spcAft>
+                          <a:spcPts val="800"/>
+                        </a:spcAft>
+                        <a:buNone/>
+                      </a:pPr>
+                      <a:r>
+                        <a:rPr lang="en-US" sz="2300" kern="100">
+                          <a:effectLst/>
+                        </a:rPr>
+                        <a:t>Result</a:t>
+                      </a:r>
+                      <a:endParaRPr lang="en-US" sz="2300" kern="100">
+                        <a:effectLst/>
+                        <a:latin typeface="Aptos" panose="020B0004020202020204" pitchFamily="34" charset="0"/>
+                        <a:ea typeface="Aptos" panose="020B0004020202020204" pitchFamily="34" charset="0"/>
+                        <a:cs typeface="Times New Roman" panose="02020603050405020304" pitchFamily="18" charset="0"/>
+                      </a:endParaRPr>
+                    </a:p>
+                  </a:txBody>
+                  <a:tcPr marL="128992" marR="128992" marT="0" marB="0"/>
+                </a:tc>
+                <a:tc>
+                  <a:txBody>
+                    <a:bodyPr/>
+                    <a:lstStyle/>
+                    <a:p>
+                      <a:pPr marL="0" marR="0" lvl="0" indent="0" algn="l" defTabSz="914400" rtl="0" eaLnBrk="1" fontAlgn="auto" latinLnBrk="0" hangingPunct="1">
+                        <a:lnSpc>
+                          <a:spcPct val="115000"/>
+                        </a:lnSpc>
+                        <a:spcBef>
+                          <a:spcPts val="0"/>
+                        </a:spcBef>
+                        <a:spcAft>
+                          <a:spcPts val="800"/>
+                        </a:spcAft>
+                        <a:buClrTx/>
+                        <a:buSzTx/>
+                        <a:buFontTx/>
+                        <a:buNone/>
+                        <a:tabLst/>
+                        <a:defRPr/>
+                      </a:pPr>
+                      <a:r>
+                        <a:rPr kumimoji="0" lang="en-US" sz="2300" b="0" i="0" u="none" strike="noStrike" kern="100" cap="none" spc="0" normalizeH="0" baseline="0" noProof="0">
+                          <a:ln>
+                            <a:noFill/>
+                          </a:ln>
+                          <a:solidFill>
+                            <a:prstClr val="black"/>
+                          </a:solidFill>
+                          <a:effectLst/>
+                          <a:uLnTx/>
+                          <a:uFillTx/>
+                          <a:latin typeface="Aptos" panose="02110004020202020204"/>
+                          <a:ea typeface="+mn-ea"/>
+                          <a:cs typeface="+mn-cs"/>
+                        </a:rPr>
+                        <a:t>Not </a:t>
+                      </a:r>
+                      <a:r>
+                        <a:rPr kumimoji="0" lang="en-US" sz="2300" b="0" i="0" u="none" strike="noStrike" kern="100" cap="none" spc="0" normalizeH="0" baseline="0" noProof="0">
+                          <a:ln>
+                            <a:noFill/>
+                          </a:ln>
+                          <a:solidFill>
+                            <a:prstClr val="black"/>
+                          </a:solidFill>
+                          <a:effectLst/>
+                          <a:uLnTx/>
+                          <a:uFillTx/>
+                          <a:latin typeface="Aptos" panose="020B0004020202020204" pitchFamily="34" charset="0"/>
+                          <a:ea typeface="Aptos" panose="020B0004020202020204" pitchFamily="34" charset="0"/>
+                          <a:cs typeface="Times New Roman" panose="02020603050405020304" pitchFamily="18" charset="0"/>
+                        </a:rPr>
+                        <a:t>Detected</a:t>
+                      </a:r>
+                      <a:endParaRPr kumimoji="0" lang="en-US" sz="2300" b="0" i="0" u="none" strike="noStrike" kern="100" cap="none" spc="0" normalizeH="0" baseline="0" noProof="0" dirty="0">
+                        <a:ln>
+                          <a:noFill/>
+                        </a:ln>
+                        <a:solidFill>
+                          <a:prstClr val="black"/>
+                        </a:solidFill>
+                        <a:effectLst/>
+                        <a:uLnTx/>
+                        <a:uFillTx/>
+                        <a:latin typeface="Aptos" panose="020B0004020202020204" pitchFamily="34" charset="0"/>
+                        <a:ea typeface="Aptos" panose="020B0004020202020204" pitchFamily="34" charset="0"/>
+                        <a:cs typeface="Times New Roman" panose="02020603050405020304" pitchFamily="18" charset="0"/>
+                      </a:endParaRPr>
+                    </a:p>
+                  </a:txBody>
+                  <a:tcPr marL="128992" marR="128992" marT="0" marB="0"/>
+                </a:tc>
+                <a:tc>
+                  <a:txBody>
+                    <a:bodyPr/>
+                    <a:lstStyle/>
+                    <a:p>
+                      <a:pPr marL="0" marR="0" lvl="0" indent="0" algn="l" defTabSz="914400" rtl="0" eaLnBrk="1" fontAlgn="auto" latinLnBrk="0" hangingPunct="1">
+                        <a:lnSpc>
+                          <a:spcPct val="115000"/>
+                        </a:lnSpc>
+                        <a:spcBef>
+                          <a:spcPts val="0"/>
+                        </a:spcBef>
+                        <a:spcAft>
+                          <a:spcPts val="800"/>
+                        </a:spcAft>
+                        <a:buClrTx/>
+                        <a:buSzTx/>
+                        <a:buFontTx/>
+                        <a:buNone/>
+                        <a:tabLst/>
+                        <a:defRPr/>
+                      </a:pPr>
+                      <a:r>
+                        <a:rPr kumimoji="0" lang="en-US" sz="2300" b="0" i="0" u="none" strike="noStrike" kern="100" cap="none" spc="0" normalizeH="0" baseline="0" noProof="0" dirty="0">
+                          <a:ln>
+                            <a:noFill/>
+                          </a:ln>
+                          <a:solidFill>
+                            <a:prstClr val="black"/>
+                          </a:solidFill>
+                          <a:effectLst/>
+                          <a:uLnTx/>
+                          <a:uFillTx/>
+                          <a:latin typeface="Aptos" panose="02110004020202020204"/>
+                          <a:ea typeface="+mn-ea"/>
+                          <a:cs typeface="+mn-cs"/>
+                        </a:rPr>
+                        <a:t>Not </a:t>
+                      </a:r>
+                      <a:r>
+                        <a:rPr kumimoji="0" lang="en-US" sz="2300" b="0" i="0" u="none" strike="noStrike" kern="100" cap="none" spc="0" normalizeH="0" baseline="0" noProof="0" dirty="0">
+                          <a:ln>
+                            <a:noFill/>
+                          </a:ln>
+                          <a:solidFill>
+                            <a:prstClr val="black"/>
+                          </a:solidFill>
+                          <a:effectLst/>
+                          <a:uLnTx/>
+                          <a:uFillTx/>
+                          <a:latin typeface="Aptos" panose="020B0004020202020204" pitchFamily="34" charset="0"/>
+                          <a:ea typeface="Aptos" panose="020B0004020202020204" pitchFamily="34" charset="0"/>
+                          <a:cs typeface="Times New Roman" panose="02020603050405020304" pitchFamily="18" charset="0"/>
+                        </a:rPr>
+                        <a:t>Detected</a:t>
+                      </a:r>
                     </a:p>
                   </a:txBody>
                   <a:tcPr marL="128992" marR="128992" marT="0" marB="0"/>
@@ -6236,10 +7289,10 @@
       </p:graphicFrame>
       <p:pic>
         <p:nvPicPr>
-          <p:cNvPr id="4" name="Picture 3">
-            <a:extLst>
-              <a:ext uri="{FF2B5EF4-FFF2-40B4-BE49-F238E27FC236}">
-                <a16:creationId xmlns:a16="http://schemas.microsoft.com/office/drawing/2014/main" id="{DAB54F03-51EE-7512-93E2-B437D3B611A2}"/>
+          <p:cNvPr id="4" name="Picture 3" descr="asldkfjasdlfkj">
+            <a:extLst>
+              <a:ext uri="{FF2B5EF4-FFF2-40B4-BE49-F238E27FC236}">
+                <a16:creationId xmlns:a16="http://schemas.microsoft.com/office/drawing/2014/main" id="{614A7864-5CF9-526C-0895-3B0EE86DD34C}"/>
               </a:ext>
             </a:extLst>
           </p:cNvPr>
@@ -6273,7 +7326,7 @@
     </p:spTree>
     <p:extLst>
       <p:ext uri="{BB962C8B-B14F-4D97-AF65-F5344CB8AC3E}">
-        <p14:creationId xmlns:p14="http://schemas.microsoft.com/office/powerpoint/2010/main" val="1071637548"/>
+        <p14:creationId xmlns:p14="http://schemas.microsoft.com/office/powerpoint/2010/main" val="697536447"/>
       </p:ext>
     </p:extLst>
   </p:cSld>
@@ -6596,4 +7649,319 @@
     </a:ext>
   </a:extLst>
 </a:theme>
+</file>
+
+<file path=ppt/theme/theme2.xml><?xml version="1.0" encoding="utf-8"?>
+<a:theme xmlns:a="http://schemas.openxmlformats.org/drawingml/2006/main" name="Office Theme">
+  <a:themeElements>
+    <a:clrScheme name="Office">
+      <a:dk1>
+        <a:sysClr val="windowText" lastClr="000000"/>
+      </a:dk1>
+      <a:lt1>
+        <a:sysClr val="window" lastClr="FFFFFF"/>
+      </a:lt1>
+      <a:dk2>
+        <a:srgbClr val="0E2841"/>
+      </a:dk2>
+      <a:lt2>
+        <a:srgbClr val="E8E8E8"/>
+      </a:lt2>
+      <a:accent1>
+        <a:srgbClr val="156082"/>
+      </a:accent1>
+      <a:accent2>
+        <a:srgbClr val="E97132"/>
+      </a:accent2>
+      <a:accent3>
+        <a:srgbClr val="196B24"/>
+      </a:accent3>
+      <a:accent4>
+        <a:srgbClr val="0F9ED5"/>
+      </a:accent4>
+      <a:accent5>
+        <a:srgbClr val="A02B93"/>
+      </a:accent5>
+      <a:accent6>
+        <a:srgbClr val="4EA72E"/>
+      </a:accent6>
+      <a:hlink>
+        <a:srgbClr val="467886"/>
+      </a:hlink>
+      <a:folHlink>
+        <a:srgbClr val="96607D"/>
+      </a:folHlink>
+    </a:clrScheme>
+    <a:fontScheme name="Office">
+      <a:majorFont>
+        <a:latin typeface="Aptos Display" panose="02110004020202020204"/>
+        <a:ea typeface=""/>
+        <a:cs typeface=""/>
+        <a:font script="Jpan" typeface="游ゴシック Light"/>
+        <a:font script="Hang" typeface="맑은 고딕"/>
+        <a:font script="Hans" typeface="等线 Light"/>
+        <a:font script="Hant" typeface="新細明體"/>
+        <a:font script="Arab" typeface="Times New Roman"/>
+        <a:font script="Hebr" typeface="Times New Roman"/>
+        <a:font script="Thai" typeface="Angsana New"/>
+        <a:font script="Ethi" typeface="Nyala"/>
+        <a:font script="Beng" typeface="Vrinda"/>
+        <a:font script="Gujr" typeface="Shruti"/>
+        <a:font script="Khmr" typeface="MoolBoran"/>
+        <a:font script="Knda" typeface="Tunga"/>
+        <a:font script="Guru" typeface="Raavi"/>
+        <a:font script="Cans" typeface="Euphemia"/>
+        <a:font script="Cher" typeface="Plantagenet Cherokee"/>
+        <a:font script="Yiii" typeface="Microsoft Yi Baiti"/>
+        <a:font script="Tibt" typeface="Microsoft Himalaya"/>
+        <a:font script="Thaa" typeface="MV Boli"/>
+        <a:font script="Deva" typeface="Mangal"/>
+        <a:font script="Telu" typeface="Gautami"/>
+        <a:font script="Taml" typeface="Latha"/>
+        <a:font script="Syrc" typeface="Estrangelo Edessa"/>
+        <a:font script="Orya" typeface="Kalinga"/>
+        <a:font script="Mlym" typeface="Kartika"/>
+        <a:font script="Laoo" typeface="DokChampa"/>
+        <a:font script="Sinh" typeface="Iskoola Pota"/>
+        <a:font script="Mong" typeface="Mongolian Baiti"/>
+        <a:font script="Viet" typeface="Times New Roman"/>
+        <a:font script="Uigh" typeface="Microsoft Uighur"/>
+        <a:font script="Geor" typeface="Sylfaen"/>
+        <a:font script="Armn" typeface="Arial"/>
+        <a:font script="Bugi" typeface="Leelawadee UI"/>
+        <a:font script="Bopo" typeface="Microsoft JhengHei"/>
+        <a:font script="Java" typeface="Javanese Text"/>
+        <a:font script="Lisu" typeface="Segoe UI"/>
+        <a:font script="Mymr" typeface="Myanmar Text"/>
+        <a:font script="Nkoo" typeface="Ebrima"/>
+        <a:font script="Olck" typeface="Nirmala UI"/>
+        <a:font script="Osma" typeface="Ebrima"/>
+        <a:font script="Phag" typeface="Phagspa"/>
+        <a:font script="Syrn" typeface="Estrangelo Edessa"/>
+        <a:font script="Syrj" typeface="Estrangelo Edessa"/>
+        <a:font script="Syre" typeface="Estrangelo Edessa"/>
+        <a:font script="Sora" typeface="Nirmala UI"/>
+        <a:font script="Tale" typeface="Microsoft Tai Le"/>
+        <a:font script="Talu" typeface="Microsoft New Tai Lue"/>
+        <a:font script="Tfng" typeface="Ebrima"/>
+      </a:majorFont>
+      <a:minorFont>
+        <a:latin typeface="Aptos" panose="02110004020202020204"/>
+        <a:ea typeface=""/>
+        <a:cs typeface=""/>
+        <a:font script="Jpan" typeface="游ゴシック"/>
+        <a:font script="Hang" typeface="맑은 고딕"/>
+        <a:font script="Hans" typeface="等线"/>
+        <a:font script="Hant" typeface="新細明體"/>
+        <a:font script="Arab" typeface="Arial"/>
+        <a:font script="Hebr" typeface="Arial"/>
+        <a:font script="Thai" typeface="Cordia New"/>
+        <a:font script="Ethi" typeface="Nyala"/>
+        <a:font script="Beng" typeface="Vrinda"/>
+        <a:font script="Gujr" typeface="Shruti"/>
+        <a:font script="Khmr" typeface="DaunPenh"/>
+        <a:font script="Knda" typeface="Tunga"/>
+        <a:font script="Guru" typeface="Raavi"/>
+        <a:font script="Cans" typeface="Euphemia"/>
+        <a:font script="Cher" typeface="Plantagenet Cherokee"/>
+        <a:font script="Yiii" typeface="Microsoft Yi Baiti"/>
+        <a:font script="Tibt" typeface="Microsoft Himalaya"/>
+        <a:font script="Thaa" typeface="MV Boli"/>
+        <a:font script="Deva" typeface="Mangal"/>
+        <a:font script="Telu" typeface="Gautami"/>
+        <a:font script="Taml" typeface="Latha"/>
+        <a:font script="Syrc" typeface="Estrangelo Edessa"/>
+        <a:font script="Orya" typeface="Kalinga"/>
+        <a:font script="Mlym" typeface="Kartika"/>
+        <a:font script="Laoo" typeface="DokChampa"/>
+        <a:font script="Sinh" typeface="Iskoola Pota"/>
+        <a:font script="Mong" typeface="Mongolian Baiti"/>
+        <a:font script="Viet" typeface="Arial"/>
+        <a:font script="Uigh" typeface="Microsoft Uighur"/>
+        <a:font script="Geor" typeface="Sylfaen"/>
+        <a:font script="Armn" typeface="Arial"/>
+        <a:font script="Bugi" typeface="Leelawadee UI"/>
+        <a:font script="Bopo" typeface="Microsoft JhengHei"/>
+        <a:font script="Java" typeface="Javanese Text"/>
+        <a:font script="Lisu" typeface="Segoe UI"/>
+        <a:font script="Mymr" typeface="Myanmar Text"/>
+        <a:font script="Nkoo" typeface="Ebrima"/>
+        <a:font script="Olck" typeface="Nirmala UI"/>
+        <a:font script="Osma" typeface="Ebrima"/>
+        <a:font script="Phag" typeface="Phagspa"/>
+        <a:font script="Syrn" typeface="Estrangelo Edessa"/>
+        <a:font script="Syrj" typeface="Estrangelo Edessa"/>
+        <a:font script="Syre" typeface="Estrangelo Edessa"/>
+        <a:font script="Sora" typeface="Nirmala UI"/>
+        <a:font script="Tale" typeface="Microsoft Tai Le"/>
+        <a:font script="Talu" typeface="Microsoft New Tai Lue"/>
+        <a:font script="Tfng" typeface="Ebrima"/>
+      </a:minorFont>
+    </a:fontScheme>
+    <a:fmtScheme name="Office">
+      <a:fillStyleLst>
+        <a:solidFill>
+          <a:schemeClr val="phClr"/>
+        </a:solidFill>
+        <a:gradFill rotWithShape="1">
+          <a:gsLst>
+            <a:gs pos="0">
+              <a:schemeClr val="phClr">
+                <a:lumMod val="110000"/>
+                <a:satMod val="105000"/>
+                <a:tint val="67000"/>
+              </a:schemeClr>
+            </a:gs>
+            <a:gs pos="50000">
+              <a:schemeClr val="phClr">
+                <a:lumMod val="105000"/>
+                <a:satMod val="103000"/>
+                <a:tint val="73000"/>
+              </a:schemeClr>
+            </a:gs>
+            <a:gs pos="100000">
+              <a:schemeClr val="phClr">
+                <a:lumMod val="105000"/>
+                <a:satMod val="109000"/>
+                <a:tint val="81000"/>
+              </a:schemeClr>
+            </a:gs>
+          </a:gsLst>
+          <a:lin ang="5400000" scaled="0"/>
+        </a:gradFill>
+        <a:gradFill rotWithShape="1">
+          <a:gsLst>
+            <a:gs pos="0">
+              <a:schemeClr val="phClr">
+                <a:satMod val="103000"/>
+                <a:lumMod val="102000"/>
+                <a:tint val="94000"/>
+              </a:schemeClr>
+            </a:gs>
+            <a:gs pos="50000">
+              <a:schemeClr val="phClr">
+                <a:satMod val="110000"/>
+                <a:lumMod val="100000"/>
+                <a:shade val="100000"/>
+              </a:schemeClr>
+            </a:gs>
+            <a:gs pos="100000">
+              <a:schemeClr val="phClr">
+                <a:lumMod val="99000"/>
+                <a:satMod val="120000"/>
+                <a:shade val="78000"/>
+              </a:schemeClr>
+            </a:gs>
+          </a:gsLst>
+          <a:lin ang="5400000" scaled="0"/>
+        </a:gradFill>
+      </a:fillStyleLst>
+      <a:lnStyleLst>
+        <a:ln w="12700" cap="flat" cmpd="sng" algn="ctr">
+          <a:solidFill>
+            <a:schemeClr val="phClr"/>
+          </a:solidFill>
+          <a:prstDash val="solid"/>
+          <a:miter lim="800000"/>
+        </a:ln>
+        <a:ln w="19050" cap="flat" cmpd="sng" algn="ctr">
+          <a:solidFill>
+            <a:schemeClr val="phClr"/>
+          </a:solidFill>
+          <a:prstDash val="solid"/>
+          <a:miter lim="800000"/>
+        </a:ln>
+        <a:ln w="25400" cap="flat" cmpd="sng" algn="ctr">
+          <a:solidFill>
+            <a:schemeClr val="phClr"/>
+          </a:solidFill>
+          <a:prstDash val="solid"/>
+          <a:miter lim="800000"/>
+        </a:ln>
+      </a:lnStyleLst>
+      <a:effectStyleLst>
+        <a:effectStyle>
+          <a:effectLst/>
+        </a:effectStyle>
+        <a:effectStyle>
+          <a:effectLst/>
+        </a:effectStyle>
+        <a:effectStyle>
+          <a:effectLst>
+            <a:outerShdw blurRad="57150" dist="19050" dir="5400000" algn="ctr" rotWithShape="0">
+              <a:srgbClr val="000000">
+                <a:alpha val="63000"/>
+              </a:srgbClr>
+            </a:outerShdw>
+          </a:effectLst>
+        </a:effectStyle>
+      </a:effectStyleLst>
+      <a:bgFillStyleLst>
+        <a:solidFill>
+          <a:schemeClr val="phClr"/>
+        </a:solidFill>
+        <a:solidFill>
+          <a:schemeClr val="phClr">
+            <a:tint val="95000"/>
+            <a:satMod val="170000"/>
+          </a:schemeClr>
+        </a:solidFill>
+        <a:gradFill rotWithShape="1">
+          <a:gsLst>
+            <a:gs pos="0">
+              <a:schemeClr val="phClr">
+                <a:tint val="93000"/>
+                <a:satMod val="150000"/>
+                <a:shade val="98000"/>
+                <a:lumMod val="102000"/>
+              </a:schemeClr>
+            </a:gs>
+            <a:gs pos="50000">
+              <a:schemeClr val="phClr">
+                <a:tint val="98000"/>
+                <a:satMod val="130000"/>
+                <a:shade val="90000"/>
+                <a:lumMod val="103000"/>
+              </a:schemeClr>
+            </a:gs>
+            <a:gs pos="100000">
+              <a:schemeClr val="phClr">
+                <a:shade val="63000"/>
+                <a:satMod val="120000"/>
+              </a:schemeClr>
+            </a:gs>
+          </a:gsLst>
+          <a:lin ang="5400000" scaled="0"/>
+        </a:gradFill>
+      </a:bgFillStyleLst>
+    </a:fmtScheme>
+  </a:themeElements>
+  <a:objectDefaults>
+    <a:lnDef>
+      <a:spPr/>
+      <a:bodyPr/>
+      <a:lstStyle/>
+      <a:style>
+        <a:lnRef idx="2">
+          <a:schemeClr val="accent1"/>
+        </a:lnRef>
+        <a:fillRef idx="0">
+          <a:schemeClr val="accent1"/>
+        </a:fillRef>
+        <a:effectRef idx="1">
+          <a:schemeClr val="accent1"/>
+        </a:effectRef>
+        <a:fontRef idx="minor">
+          <a:schemeClr val="tx1"/>
+        </a:fontRef>
+      </a:style>
+    </a:lnDef>
+  </a:objectDefaults>
+  <a:extraClrSchemeLst/>
+  <a:extLst>
+    <a:ext uri="{05A4C25C-085E-4340-85A3-A5531E510DB2}">
+      <thm15:themeFamily xmlns:thm15="http://schemas.microsoft.com/office/thememl/2012/main" name="Office Theme" id="{2E142A2C-CD16-42D6-873A-C26D2A0506FA}" vid="{1BDDFF52-6CD6-40A5-AB3C-68EB2F1E4D0A}"/>
+    </a:ext>
+  </a:extLst>
+</a:theme>
 </file>
</xml_diff>

<commit_message>
Rename Text Contrast to Color, update all page components, add tests and project docs
- Replace TextContrast section with Color section (new Color*Page components and routes)
- Update content, layout, and page components across all categories
- Add accessibility tests: focus, keyboard, media-preferences, names, semantics
- Add project documentation (AGENTS.md, CLAUDE.md, PROJECT.md)
- Add course-content-accessibility workshop doc (HTML + Markdown)
- Add public assets, audio files, and presentation deck images
- Update CI workflow, ESLint config, Playwright config, and package.json
- Update presentation deck and README

Made-with: Cursor
</commit_message>
<xml_diff>
--- a/Test files/images/Image-PowerPoint.pptx
+++ b/Test files/images/Image-PowerPoint.pptx
@@ -204,7 +204,7 @@
           <a:p>
             <a:fld id="{12790E82-B582-0F4E-B2B3-2D64CFCFBDC7}" type="datetimeFigureOut">
               <a:rPr lang="en-US" smtClean="0"/>
-              <a:t>2/16/26</a:t>
+              <a:t>3/1/26</a:t>
             </a:fld>
             <a:endParaRPr lang="en-US"/>
           </a:p>
@@ -810,7 +810,7 @@
           <a:p>
             <a:fld id="{A84DC69A-EA2F-A746-8DAA-A22638E842CE}" type="datetimeFigureOut">
               <a:rPr lang="en-US" smtClean="0"/>
-              <a:t>2/16/26</a:t>
+              <a:t>3/1/26</a:t>
             </a:fld>
             <a:endParaRPr lang="en-US"/>
           </a:p>
@@ -1008,7 +1008,7 @@
           <a:p>
             <a:fld id="{A84DC69A-EA2F-A746-8DAA-A22638E842CE}" type="datetimeFigureOut">
               <a:rPr lang="en-US" smtClean="0"/>
-              <a:t>2/16/26</a:t>
+              <a:t>3/1/26</a:t>
             </a:fld>
             <a:endParaRPr lang="en-US"/>
           </a:p>
@@ -1216,7 +1216,7 @@
           <a:p>
             <a:fld id="{A84DC69A-EA2F-A746-8DAA-A22638E842CE}" type="datetimeFigureOut">
               <a:rPr lang="en-US" smtClean="0"/>
-              <a:t>2/16/26</a:t>
+              <a:t>3/1/26</a:t>
             </a:fld>
             <a:endParaRPr lang="en-US"/>
           </a:p>
@@ -1414,7 +1414,7 @@
           <a:p>
             <a:fld id="{A84DC69A-EA2F-A746-8DAA-A22638E842CE}" type="datetimeFigureOut">
               <a:rPr lang="en-US" smtClean="0"/>
-              <a:t>2/16/26</a:t>
+              <a:t>3/1/26</a:t>
             </a:fld>
             <a:endParaRPr lang="en-US"/>
           </a:p>
@@ -1689,7 +1689,7 @@
           <a:p>
             <a:fld id="{A84DC69A-EA2F-A746-8DAA-A22638E842CE}" type="datetimeFigureOut">
               <a:rPr lang="en-US" smtClean="0"/>
-              <a:t>2/16/26</a:t>
+              <a:t>3/1/26</a:t>
             </a:fld>
             <a:endParaRPr lang="en-US"/>
           </a:p>
@@ -1954,7 +1954,7 @@
           <a:p>
             <a:fld id="{A84DC69A-EA2F-A746-8DAA-A22638E842CE}" type="datetimeFigureOut">
               <a:rPr lang="en-US" smtClean="0"/>
-              <a:t>2/16/26</a:t>
+              <a:t>3/1/26</a:t>
             </a:fld>
             <a:endParaRPr lang="en-US"/>
           </a:p>
@@ -2366,7 +2366,7 @@
           <a:p>
             <a:fld id="{A84DC69A-EA2F-A746-8DAA-A22638E842CE}" type="datetimeFigureOut">
               <a:rPr lang="en-US" smtClean="0"/>
-              <a:t>2/16/26</a:t>
+              <a:t>3/1/26</a:t>
             </a:fld>
             <a:endParaRPr lang="en-US"/>
           </a:p>
@@ -2507,7 +2507,7 @@
           <a:p>
             <a:fld id="{A84DC69A-EA2F-A746-8DAA-A22638E842CE}" type="datetimeFigureOut">
               <a:rPr lang="en-US" smtClean="0"/>
-              <a:t>2/16/26</a:t>
+              <a:t>3/1/26</a:t>
             </a:fld>
             <a:endParaRPr lang="en-US"/>
           </a:p>
@@ -2620,7 +2620,7 @@
           <a:p>
             <a:fld id="{A84DC69A-EA2F-A746-8DAA-A22638E842CE}" type="datetimeFigureOut">
               <a:rPr lang="en-US" smtClean="0"/>
-              <a:t>2/16/26</a:t>
+              <a:t>3/1/26</a:t>
             </a:fld>
             <a:endParaRPr lang="en-US"/>
           </a:p>
@@ -2931,7 +2931,7 @@
           <a:p>
             <a:fld id="{A84DC69A-EA2F-A746-8DAA-A22638E842CE}" type="datetimeFigureOut">
               <a:rPr lang="en-US" smtClean="0"/>
-              <a:t>2/16/26</a:t>
+              <a:t>3/1/26</a:t>
             </a:fld>
             <a:endParaRPr lang="en-US"/>
           </a:p>
@@ -3219,7 +3219,7 @@
           <a:p>
             <a:fld id="{A84DC69A-EA2F-A746-8DAA-A22638E842CE}" type="datetimeFigureOut">
               <a:rPr lang="en-US" smtClean="0"/>
-              <a:t>2/16/26</a:t>
+              <a:t>3/1/26</a:t>
             </a:fld>
             <a:endParaRPr lang="en-US"/>
           </a:p>
@@ -3460,7 +3460,7 @@
           <a:p>
             <a:fld id="{A84DC69A-EA2F-A746-8DAA-A22638E842CE}" type="datetimeFigureOut">
               <a:rPr lang="en-US" smtClean="0"/>
-              <a:t>2/16/26</a:t>
+              <a:t>3/1/26</a:t>
             </a:fld>
             <a:endParaRPr lang="en-US"/>
           </a:p>
@@ -5483,7 +5483,7 @@
       </p:graphicFrame>
       <p:pic>
         <p:nvPicPr>
-          <p:cNvPr id="6" name="Picture 5">
+          <p:cNvPr id="6" name="Picture 5" descr="Quiz averages.">
             <a:extLst>
               <a:ext uri="{FF2B5EF4-FFF2-40B4-BE49-F238E27FC236}">
                 <a16:creationId xmlns:a16="http://schemas.microsoft.com/office/drawing/2014/main" id="{693D75F0-3072-772C-6496-08995178996B}"/>

</xml_diff>

<commit_message>
Add color contrast content, workshop doc updates, and project navigation
- Add Color overview page with contrast examples (regular, large, graphic)
- Add contrast-related assets and test files
- Expand workshop HTML doc with contrast, color-sole-means, and table sections
- Even out lab-compare table columns (50/50 fixed width)
- Add "In this section" anchor navigation to PROJECT.md
- Update page components with content refinements across categories

Made-with: Cursor
</commit_message>
<xml_diff>
--- a/Test files/images/Image-PowerPoint.pptx
+++ b/Test files/images/Image-PowerPoint.pptx
@@ -204,7 +204,7 @@
           <a:p>
             <a:fld id="{12790E82-B582-0F4E-B2B3-2D64CFCFBDC7}" type="datetimeFigureOut">
               <a:rPr lang="en-US" smtClean="0"/>
-              <a:t>3/1/26</a:t>
+              <a:t>3/7/26</a:t>
             </a:fld>
             <a:endParaRPr lang="en-US"/>
           </a:p>
@@ -810,7 +810,7 @@
           <a:p>
             <a:fld id="{A84DC69A-EA2F-A746-8DAA-A22638E842CE}" type="datetimeFigureOut">
               <a:rPr lang="en-US" smtClean="0"/>
-              <a:t>3/1/26</a:t>
+              <a:t>3/7/26</a:t>
             </a:fld>
             <a:endParaRPr lang="en-US"/>
           </a:p>
@@ -1008,7 +1008,7 @@
           <a:p>
             <a:fld id="{A84DC69A-EA2F-A746-8DAA-A22638E842CE}" type="datetimeFigureOut">
               <a:rPr lang="en-US" smtClean="0"/>
-              <a:t>3/1/26</a:t>
+              <a:t>3/7/26</a:t>
             </a:fld>
             <a:endParaRPr lang="en-US"/>
           </a:p>
@@ -1216,7 +1216,7 @@
           <a:p>
             <a:fld id="{A84DC69A-EA2F-A746-8DAA-A22638E842CE}" type="datetimeFigureOut">
               <a:rPr lang="en-US" smtClean="0"/>
-              <a:t>3/1/26</a:t>
+              <a:t>3/7/26</a:t>
             </a:fld>
             <a:endParaRPr lang="en-US"/>
           </a:p>
@@ -1414,7 +1414,7 @@
           <a:p>
             <a:fld id="{A84DC69A-EA2F-A746-8DAA-A22638E842CE}" type="datetimeFigureOut">
               <a:rPr lang="en-US" smtClean="0"/>
-              <a:t>3/1/26</a:t>
+              <a:t>3/7/26</a:t>
             </a:fld>
             <a:endParaRPr lang="en-US"/>
           </a:p>
@@ -1689,7 +1689,7 @@
           <a:p>
             <a:fld id="{A84DC69A-EA2F-A746-8DAA-A22638E842CE}" type="datetimeFigureOut">
               <a:rPr lang="en-US" smtClean="0"/>
-              <a:t>3/1/26</a:t>
+              <a:t>3/7/26</a:t>
             </a:fld>
             <a:endParaRPr lang="en-US"/>
           </a:p>
@@ -1954,7 +1954,7 @@
           <a:p>
             <a:fld id="{A84DC69A-EA2F-A746-8DAA-A22638E842CE}" type="datetimeFigureOut">
               <a:rPr lang="en-US" smtClean="0"/>
-              <a:t>3/1/26</a:t>
+              <a:t>3/7/26</a:t>
             </a:fld>
             <a:endParaRPr lang="en-US"/>
           </a:p>
@@ -2366,7 +2366,7 @@
           <a:p>
             <a:fld id="{A84DC69A-EA2F-A746-8DAA-A22638E842CE}" type="datetimeFigureOut">
               <a:rPr lang="en-US" smtClean="0"/>
-              <a:t>3/1/26</a:t>
+              <a:t>3/7/26</a:t>
             </a:fld>
             <a:endParaRPr lang="en-US"/>
           </a:p>
@@ -2507,7 +2507,7 @@
           <a:p>
             <a:fld id="{A84DC69A-EA2F-A746-8DAA-A22638E842CE}" type="datetimeFigureOut">
               <a:rPr lang="en-US" smtClean="0"/>
-              <a:t>3/1/26</a:t>
+              <a:t>3/7/26</a:t>
             </a:fld>
             <a:endParaRPr lang="en-US"/>
           </a:p>
@@ -2620,7 +2620,7 @@
           <a:p>
             <a:fld id="{A84DC69A-EA2F-A746-8DAA-A22638E842CE}" type="datetimeFigureOut">
               <a:rPr lang="en-US" smtClean="0"/>
-              <a:t>3/1/26</a:t>
+              <a:t>3/7/26</a:t>
             </a:fld>
             <a:endParaRPr lang="en-US"/>
           </a:p>
@@ -2931,7 +2931,7 @@
           <a:p>
             <a:fld id="{A84DC69A-EA2F-A746-8DAA-A22638E842CE}" type="datetimeFigureOut">
               <a:rPr lang="en-US" smtClean="0"/>
-              <a:t>3/1/26</a:t>
+              <a:t>3/7/26</a:t>
             </a:fld>
             <a:endParaRPr lang="en-US"/>
           </a:p>
@@ -3219,7 +3219,7 @@
           <a:p>
             <a:fld id="{A84DC69A-EA2F-A746-8DAA-A22638E842CE}" type="datetimeFigureOut">
               <a:rPr lang="en-US" smtClean="0"/>
-              <a:t>3/1/26</a:t>
+              <a:t>3/7/26</a:t>
             </a:fld>
             <a:endParaRPr lang="en-US"/>
           </a:p>
@@ -3460,7 +3460,7 @@
           <a:p>
             <a:fld id="{A84DC69A-EA2F-A746-8DAA-A22638E842CE}" type="datetimeFigureOut">
               <a:rPr lang="en-US" smtClean="0"/>
-              <a:t>3/1/26</a:t>
+              <a:t>3/7/26</a:t>
             </a:fld>
             <a:endParaRPr lang="en-US"/>
           </a:p>
@@ -3996,29 +3996,22 @@
           <p:nvPr>
             <p:extLst>
               <p:ext uri="{D42A27DB-BD31-4B8C-83A1-F6EECF244321}">
-                <p14:modId xmlns:p14="http://schemas.microsoft.com/office/powerpoint/2010/main" val="4130325249"/>
+                <p14:modId xmlns:p14="http://schemas.microsoft.com/office/powerpoint/2010/main" val="2064275393"/>
               </p:ext>
             </p:extLst>
           </p:nvPr>
         </p:nvGraphicFramePr>
         <p:xfrm>
           <a:off x="810440" y="5354380"/>
-          <a:ext cx="7518573" cy="1169544"/>
+          <a:ext cx="5804649" cy="1169480"/>
         </p:xfrm>
         <a:graphic>
           <a:graphicData uri="http://schemas.openxmlformats.org/drawingml/2006/table">
             <a:tbl>
-              <a:tblPr firstRow="1" firstCol="1" bandRow="1">
+              <a:tblPr firstRow="1" bandRow="1">
                 <a:tableStyleId>{5C22544A-7EE6-4342-B048-85BDC9FD1C3A}</a:tableStyleId>
               </a:tblPr>
               <a:tblGrid>
-                <a:gridCol w="1713924">
-                  <a:extLst>
-                    <a:ext uri="{9D8B030D-6E8A-4147-A177-3AD203B41FA5}">
-                      <a16:colId xmlns:a16="http://schemas.microsoft.com/office/drawing/2014/main" val="2587052964"/>
-                    </a:ext>
-                  </a:extLst>
-                </a:gridCol>
                 <a:gridCol w="2794831">
                   <a:extLst>
                     <a:ext uri="{9D8B030D-6E8A-4147-A177-3AD203B41FA5}">
@@ -4050,42 +4043,12 @@
                         <a:buNone/>
                       </a:pPr>
                       <a:r>
-                        <a:rPr lang="en-US" sz="2300" kern="100">
-                          <a:effectLst/>
-                        </a:rPr>
-                        <a:t> </a:t>
-                      </a:r>
-                      <a:endParaRPr lang="en-US" sz="2300" kern="100">
-                        <a:effectLst/>
-                        <a:latin typeface="Aptos" panose="020B0004020202020204" pitchFamily="34" charset="0"/>
-                        <a:ea typeface="Aptos" panose="020B0004020202020204" pitchFamily="34" charset="0"/>
-                        <a:cs typeface="Times New Roman" panose="02020603050405020304" pitchFamily="18" charset="0"/>
-                      </a:endParaRPr>
-                    </a:p>
-                  </a:txBody>
-                  <a:tcPr marL="128992" marR="128992" marT="0" marB="0"/>
-                </a:tc>
-                <a:tc>
-                  <a:txBody>
-                    <a:bodyPr/>
-                    <a:lstStyle/>
-                    <a:p>
-                      <a:pPr marL="0" marR="0">
-                        <a:lnSpc>
-                          <a:spcPct val="115000"/>
-                        </a:lnSpc>
-                        <a:spcAft>
-                          <a:spcPts val="800"/>
-                        </a:spcAft>
-                        <a:buNone/>
-                      </a:pPr>
-                      <a:r>
-                        <a:rPr lang="en-US" sz="2300" kern="100">
+                        <a:rPr lang="en-US" sz="2300" kern="100" dirty="0">
                           <a:effectLst/>
                         </a:rPr>
                         <a:t>A11y automated checker</a:t>
                       </a:r>
-                      <a:endParaRPr lang="en-US" sz="2300" kern="100">
+                      <a:endParaRPr lang="en-US" sz="2300" kern="100" dirty="0">
                         <a:effectLst/>
                         <a:latin typeface="Aptos" panose="020B0004020202020204" pitchFamily="34" charset="0"/>
                         <a:ea typeface="Aptos" panose="020B0004020202020204" pitchFamily="34" charset="0"/>
@@ -4132,36 +4095,6 @@
                 </a:extLst>
               </a:tr>
               <a:tr h="376109">
-                <a:tc>
-                  <a:txBody>
-                    <a:bodyPr/>
-                    <a:lstStyle/>
-                    <a:p>
-                      <a:pPr marL="0" marR="0">
-                        <a:lnSpc>
-                          <a:spcPct val="115000"/>
-                        </a:lnSpc>
-                        <a:spcAft>
-                          <a:spcPts val="800"/>
-                        </a:spcAft>
-                        <a:buNone/>
-                      </a:pPr>
-                      <a:r>
-                        <a:rPr lang="en-US" sz="2300" kern="100">
-                          <a:effectLst/>
-                        </a:rPr>
-                        <a:t>Result</a:t>
-                      </a:r>
-                      <a:endParaRPr lang="en-US" sz="2300" kern="100">
-                        <a:effectLst/>
-                        <a:latin typeface="Aptos" panose="020B0004020202020204" pitchFamily="34" charset="0"/>
-                        <a:ea typeface="Aptos" panose="020B0004020202020204" pitchFamily="34" charset="0"/>
-                        <a:cs typeface="Times New Roman" panose="02020603050405020304" pitchFamily="18" charset="0"/>
-                      </a:endParaRPr>
-                    </a:p>
-                  </a:txBody>
-                  <a:tcPr marL="128992" marR="128992" marT="0" marB="0"/>
-                </a:tc>
                 <a:tc>
                   <a:txBody>
                     <a:bodyPr/>
@@ -4382,29 +4315,22 @@
           <p:nvPr>
             <p:extLst>
               <p:ext uri="{D42A27DB-BD31-4B8C-83A1-F6EECF244321}">
-                <p14:modId xmlns:p14="http://schemas.microsoft.com/office/powerpoint/2010/main" val="3265952587"/>
+                <p14:modId xmlns:p14="http://schemas.microsoft.com/office/powerpoint/2010/main" val="3800704100"/>
               </p:ext>
             </p:extLst>
           </p:nvPr>
         </p:nvGraphicFramePr>
         <p:xfrm>
           <a:off x="810440" y="5354380"/>
-          <a:ext cx="7518573" cy="1169544"/>
+          <a:ext cx="5804649" cy="1169480"/>
         </p:xfrm>
         <a:graphic>
           <a:graphicData uri="http://schemas.openxmlformats.org/drawingml/2006/table">
             <a:tbl>
-              <a:tblPr firstRow="1" firstCol="1" bandRow="1">
+              <a:tblPr firstRow="1" bandRow="1">
                 <a:tableStyleId>{5C22544A-7EE6-4342-B048-85BDC9FD1C3A}</a:tableStyleId>
               </a:tblPr>
               <a:tblGrid>
-                <a:gridCol w="1713924">
-                  <a:extLst>
-                    <a:ext uri="{9D8B030D-6E8A-4147-A177-3AD203B41FA5}">
-                      <a16:colId xmlns:a16="http://schemas.microsoft.com/office/drawing/2014/main" val="2587052964"/>
-                    </a:ext>
-                  </a:extLst>
-                </a:gridCol>
                 <a:gridCol w="2794831">
                   <a:extLst>
                     <a:ext uri="{9D8B030D-6E8A-4147-A177-3AD203B41FA5}">
@@ -4436,42 +4362,12 @@
                         <a:buNone/>
                       </a:pPr>
                       <a:r>
-                        <a:rPr lang="en-US" sz="2300" kern="100">
-                          <a:effectLst/>
-                        </a:rPr>
-                        <a:t> </a:t>
-                      </a:r>
-                      <a:endParaRPr lang="en-US" sz="2300" kern="100">
-                        <a:effectLst/>
-                        <a:latin typeface="Aptos" panose="020B0004020202020204" pitchFamily="34" charset="0"/>
-                        <a:ea typeface="Aptos" panose="020B0004020202020204" pitchFamily="34" charset="0"/>
-                        <a:cs typeface="Times New Roman" panose="02020603050405020304" pitchFamily="18" charset="0"/>
-                      </a:endParaRPr>
-                    </a:p>
-                  </a:txBody>
-                  <a:tcPr marL="128992" marR="128992" marT="0" marB="0"/>
-                </a:tc>
-                <a:tc>
-                  <a:txBody>
-                    <a:bodyPr/>
-                    <a:lstStyle/>
-                    <a:p>
-                      <a:pPr marL="0" marR="0">
-                        <a:lnSpc>
-                          <a:spcPct val="115000"/>
-                        </a:lnSpc>
-                        <a:spcAft>
-                          <a:spcPts val="800"/>
-                        </a:spcAft>
-                        <a:buNone/>
-                      </a:pPr>
-                      <a:r>
-                        <a:rPr lang="en-US" sz="2300" kern="100">
+                        <a:rPr lang="en-US" sz="2300" kern="100" dirty="0">
                           <a:effectLst/>
                         </a:rPr>
                         <a:t>A11y automated checker</a:t>
                       </a:r>
-                      <a:endParaRPr lang="en-US" sz="2300" kern="100">
+                      <a:endParaRPr lang="en-US" sz="2300" kern="100" dirty="0">
                         <a:effectLst/>
                         <a:latin typeface="Aptos" panose="020B0004020202020204" pitchFamily="34" charset="0"/>
                         <a:ea typeface="Aptos" panose="020B0004020202020204" pitchFamily="34" charset="0"/>
@@ -4518,36 +4414,6 @@
                 </a:extLst>
               </a:tr>
               <a:tr h="376109">
-                <a:tc>
-                  <a:txBody>
-                    <a:bodyPr/>
-                    <a:lstStyle/>
-                    <a:p>
-                      <a:pPr marL="0" marR="0">
-                        <a:lnSpc>
-                          <a:spcPct val="115000"/>
-                        </a:lnSpc>
-                        <a:spcAft>
-                          <a:spcPts val="800"/>
-                        </a:spcAft>
-                        <a:buNone/>
-                      </a:pPr>
-                      <a:r>
-                        <a:rPr lang="en-US" sz="2300" kern="100">
-                          <a:effectLst/>
-                        </a:rPr>
-                        <a:t>Result</a:t>
-                      </a:r>
-                      <a:endParaRPr lang="en-US" sz="2300" kern="100">
-                        <a:effectLst/>
-                        <a:latin typeface="Aptos" panose="020B0004020202020204" pitchFamily="34" charset="0"/>
-                        <a:ea typeface="Aptos" panose="020B0004020202020204" pitchFamily="34" charset="0"/>
-                        <a:cs typeface="Times New Roman" panose="02020603050405020304" pitchFamily="18" charset="0"/>
-                      </a:endParaRPr>
-                    </a:p>
-                  </a:txBody>
-                  <a:tcPr marL="128992" marR="128992" marT="0" marB="0"/>
-                </a:tc>
                 <a:tc>
                   <a:txBody>
                     <a:bodyPr/>
@@ -4743,29 +4609,22 @@
           <p:nvPr>
             <p:extLst>
               <p:ext uri="{D42A27DB-BD31-4B8C-83A1-F6EECF244321}">
-                <p14:modId xmlns:p14="http://schemas.microsoft.com/office/powerpoint/2010/main" val="3674814014"/>
+                <p14:modId xmlns:p14="http://schemas.microsoft.com/office/powerpoint/2010/main" val="720174723"/>
               </p:ext>
             </p:extLst>
           </p:nvPr>
         </p:nvGraphicFramePr>
         <p:xfrm>
           <a:off x="810440" y="5354380"/>
-          <a:ext cx="7518573" cy="1169544"/>
+          <a:ext cx="5804649" cy="1169480"/>
         </p:xfrm>
         <a:graphic>
           <a:graphicData uri="http://schemas.openxmlformats.org/drawingml/2006/table">
             <a:tbl>
-              <a:tblPr firstRow="1" firstCol="1" bandRow="1">
+              <a:tblPr firstRow="1" bandRow="1">
                 <a:tableStyleId>{5C22544A-7EE6-4342-B048-85BDC9FD1C3A}</a:tableStyleId>
               </a:tblPr>
               <a:tblGrid>
-                <a:gridCol w="1713924">
-                  <a:extLst>
-                    <a:ext uri="{9D8B030D-6E8A-4147-A177-3AD203B41FA5}">
-                      <a16:colId xmlns:a16="http://schemas.microsoft.com/office/drawing/2014/main" val="2587052964"/>
-                    </a:ext>
-                  </a:extLst>
-                </a:gridCol>
                 <a:gridCol w="2794831">
                   <a:extLst>
                     <a:ext uri="{9D8B030D-6E8A-4147-A177-3AD203B41FA5}">
@@ -4782,36 +4641,6 @@
                 </a:gridCol>
               </a:tblGrid>
               <a:tr h="771564">
-                <a:tc>
-                  <a:txBody>
-                    <a:bodyPr/>
-                    <a:lstStyle/>
-                    <a:p>
-                      <a:pPr marL="0" marR="0">
-                        <a:lnSpc>
-                          <a:spcPct val="115000"/>
-                        </a:lnSpc>
-                        <a:spcAft>
-                          <a:spcPts val="800"/>
-                        </a:spcAft>
-                        <a:buNone/>
-                      </a:pPr>
-                      <a:r>
-                        <a:rPr lang="en-US" sz="2300" kern="100">
-                          <a:effectLst/>
-                        </a:rPr>
-                        <a:t> </a:t>
-                      </a:r>
-                      <a:endParaRPr lang="en-US" sz="2300" kern="100">
-                        <a:effectLst/>
-                        <a:latin typeface="Aptos" panose="020B0004020202020204" pitchFamily="34" charset="0"/>
-                        <a:ea typeface="Aptos" panose="020B0004020202020204" pitchFamily="34" charset="0"/>
-                        <a:cs typeface="Times New Roman" panose="02020603050405020304" pitchFamily="18" charset="0"/>
-                      </a:endParaRPr>
-                    </a:p>
-                  </a:txBody>
-                  <a:tcPr marL="128992" marR="128992" marT="0" marB="0"/>
-                </a:tc>
                 <a:tc>
                   <a:txBody>
                     <a:bodyPr/>
@@ -4879,36 +4708,6 @@
                 </a:extLst>
               </a:tr>
               <a:tr h="376109">
-                <a:tc>
-                  <a:txBody>
-                    <a:bodyPr/>
-                    <a:lstStyle/>
-                    <a:p>
-                      <a:pPr marL="0" marR="0">
-                        <a:lnSpc>
-                          <a:spcPct val="115000"/>
-                        </a:lnSpc>
-                        <a:spcAft>
-                          <a:spcPts val="800"/>
-                        </a:spcAft>
-                        <a:buNone/>
-                      </a:pPr>
-                      <a:r>
-                        <a:rPr lang="en-US" sz="2300" kern="100">
-                          <a:effectLst/>
-                        </a:rPr>
-                        <a:t>Result</a:t>
-                      </a:r>
-                      <a:endParaRPr lang="en-US" sz="2300" kern="100">
-                        <a:effectLst/>
-                        <a:latin typeface="Aptos" panose="020B0004020202020204" pitchFamily="34" charset="0"/>
-                        <a:ea typeface="Aptos" panose="020B0004020202020204" pitchFamily="34" charset="0"/>
-                        <a:cs typeface="Times New Roman" panose="02020603050405020304" pitchFamily="18" charset="0"/>
-                      </a:endParaRPr>
-                    </a:p>
-                  </a:txBody>
-                  <a:tcPr marL="128992" marR="128992" marT="0" marB="0"/>
-                </a:tc>
                 <a:tc>
                   <a:txBody>
                     <a:bodyPr/>
@@ -5171,29 +4970,22 @@
           <p:nvPr>
             <p:extLst>
               <p:ext uri="{D42A27DB-BD31-4B8C-83A1-F6EECF244321}">
-                <p14:modId xmlns:p14="http://schemas.microsoft.com/office/powerpoint/2010/main" val="3559670945"/>
+                <p14:modId xmlns:p14="http://schemas.microsoft.com/office/powerpoint/2010/main" val="2194584042"/>
               </p:ext>
             </p:extLst>
           </p:nvPr>
         </p:nvGraphicFramePr>
         <p:xfrm>
           <a:off x="810440" y="5354380"/>
-          <a:ext cx="7518573" cy="1169544"/>
+          <a:ext cx="5804649" cy="1169480"/>
         </p:xfrm>
         <a:graphic>
           <a:graphicData uri="http://schemas.openxmlformats.org/drawingml/2006/table">
             <a:tbl>
-              <a:tblPr firstRow="1" firstCol="1" bandRow="1">
+              <a:tblPr firstRow="1" bandRow="1">
                 <a:tableStyleId>{5C22544A-7EE6-4342-B048-85BDC9FD1C3A}</a:tableStyleId>
               </a:tblPr>
               <a:tblGrid>
-                <a:gridCol w="1713924">
-                  <a:extLst>
-                    <a:ext uri="{9D8B030D-6E8A-4147-A177-3AD203B41FA5}">
-                      <a16:colId xmlns:a16="http://schemas.microsoft.com/office/drawing/2014/main" val="2587052964"/>
-                    </a:ext>
-                  </a:extLst>
-                </a:gridCol>
                 <a:gridCol w="2794831">
                   <a:extLst>
                     <a:ext uri="{9D8B030D-6E8A-4147-A177-3AD203B41FA5}">
@@ -5225,42 +5017,12 @@
                         <a:buNone/>
                       </a:pPr>
                       <a:r>
-                        <a:rPr lang="en-US" sz="2300" kern="100">
-                          <a:effectLst/>
-                        </a:rPr>
-                        <a:t> </a:t>
-                      </a:r>
-                      <a:endParaRPr lang="en-US" sz="2300" kern="100">
-                        <a:effectLst/>
-                        <a:latin typeface="Aptos" panose="020B0004020202020204" pitchFamily="34" charset="0"/>
-                        <a:ea typeface="Aptos" panose="020B0004020202020204" pitchFamily="34" charset="0"/>
-                        <a:cs typeface="Times New Roman" panose="02020603050405020304" pitchFamily="18" charset="0"/>
-                      </a:endParaRPr>
-                    </a:p>
-                  </a:txBody>
-                  <a:tcPr marL="128992" marR="128992" marT="0" marB="0"/>
-                </a:tc>
-                <a:tc>
-                  <a:txBody>
-                    <a:bodyPr/>
-                    <a:lstStyle/>
-                    <a:p>
-                      <a:pPr marL="0" marR="0">
-                        <a:lnSpc>
-                          <a:spcPct val="115000"/>
-                        </a:lnSpc>
-                        <a:spcAft>
-                          <a:spcPts val="800"/>
-                        </a:spcAft>
-                        <a:buNone/>
-                      </a:pPr>
-                      <a:r>
-                        <a:rPr lang="en-US" sz="2300" kern="100">
+                        <a:rPr lang="en-US" sz="2300" kern="100" dirty="0">
                           <a:effectLst/>
                         </a:rPr>
                         <a:t>A11y automated checker</a:t>
                       </a:r>
-                      <a:endParaRPr lang="en-US" sz="2300" kern="100">
+                      <a:endParaRPr lang="en-US" sz="2300" kern="100" dirty="0">
                         <a:effectLst/>
                         <a:latin typeface="Aptos" panose="020B0004020202020204" pitchFamily="34" charset="0"/>
                         <a:ea typeface="Aptos" panose="020B0004020202020204" pitchFamily="34" charset="0"/>
@@ -5312,36 +5074,6 @@
                     <a:bodyPr/>
                     <a:lstStyle/>
                     <a:p>
-                      <a:pPr marL="0" marR="0">
-                        <a:lnSpc>
-                          <a:spcPct val="115000"/>
-                        </a:lnSpc>
-                        <a:spcAft>
-                          <a:spcPts val="800"/>
-                        </a:spcAft>
-                        <a:buNone/>
-                      </a:pPr>
-                      <a:r>
-                        <a:rPr lang="en-US" sz="2300" kern="100">
-                          <a:effectLst/>
-                        </a:rPr>
-                        <a:t>Result</a:t>
-                      </a:r>
-                      <a:endParaRPr lang="en-US" sz="2300" kern="100">
-                        <a:effectLst/>
-                        <a:latin typeface="Aptos" panose="020B0004020202020204" pitchFamily="34" charset="0"/>
-                        <a:ea typeface="Aptos" panose="020B0004020202020204" pitchFamily="34" charset="0"/>
-                        <a:cs typeface="Times New Roman" panose="02020603050405020304" pitchFamily="18" charset="0"/>
-                      </a:endParaRPr>
-                    </a:p>
-                  </a:txBody>
-                  <a:tcPr marL="128992" marR="128992" marT="0" marB="0"/>
-                </a:tc>
-                <a:tc>
-                  <a:txBody>
-                    <a:bodyPr/>
-                    <a:lstStyle/>
-                    <a:p>
                       <a:pPr marL="0" marR="0" lvl="0" indent="0" algn="l" defTabSz="914400" rtl="0" eaLnBrk="1" fontAlgn="auto" latinLnBrk="0" hangingPunct="1">
                         <a:lnSpc>
                           <a:spcPct val="115000"/>
@@ -5360,7 +5092,7 @@
                         <a:defRPr/>
                       </a:pPr>
                       <a:r>
-                        <a:rPr kumimoji="0" lang="en-US" sz="2300" b="0" i="0" u="none" strike="noStrike" kern="100" cap="none" spc="0" normalizeH="0" baseline="0" noProof="0">
+                        <a:rPr kumimoji="0" lang="en-US" sz="2300" b="0" i="0" u="none" strike="noStrike" kern="100" cap="none" spc="0" normalizeH="0" baseline="0" noProof="0" dirty="0">
                           <a:ln>
                             <a:noFill/>
                           </a:ln>
@@ -5377,7 +5109,7 @@
                         <a:t>Not </a:t>
                       </a:r>
                       <a:r>
-                        <a:rPr kumimoji="0" lang="en-US" sz="2300" b="0" i="0" u="none" strike="noStrike" kern="100" cap="none" spc="0" normalizeH="0" baseline="0" noProof="0">
+                        <a:rPr kumimoji="0" lang="en-US" sz="2300" b="0" i="0" u="none" strike="noStrike" kern="100" cap="none" spc="0" normalizeH="0" baseline="0" noProof="0" dirty="0">
                           <a:ln>
                             <a:noFill/>
                           </a:ln>
@@ -5393,20 +5125,6 @@
                         </a:rPr>
                         <a:t>Detected</a:t>
                       </a:r>
-                      <a:endParaRPr kumimoji="0" lang="en-US" sz="2300" b="0" i="0" u="none" strike="noStrike" kern="100" cap="none" spc="0" normalizeH="0" baseline="0" noProof="0" dirty="0">
-                        <a:ln>
-                          <a:noFill/>
-                        </a:ln>
-                        <a:solidFill>
-                          <a:prstClr val="black"/>
-                        </a:solidFill>
-                        <a:effectLst/>
-                        <a:uLnTx/>
-                        <a:uFillTx/>
-                        <a:latin typeface="Aptos" panose="020B0004020202020204" pitchFamily="34" charset="0"/>
-                        <a:ea typeface="Aptos" panose="020B0004020202020204" pitchFamily="34" charset="0"/>
-                        <a:cs typeface="Times New Roman" panose="02020603050405020304" pitchFamily="18" charset="0"/>
-                      </a:endParaRPr>
                     </a:p>
                   </a:txBody>
                   <a:tcPr marL="128992" marR="128992" marT="0" marB="0"/>
@@ -5624,26 +5342,25 @@
           <p:cNvGraphicFramePr>
             <a:graphicFrameLocks noGrp="1"/>
           </p:cNvGraphicFramePr>
-          <p:nvPr/>
+          <p:nvPr>
+            <p:extLst>
+              <p:ext uri="{D42A27DB-BD31-4B8C-83A1-F6EECF244321}">
+                <p14:modId xmlns:p14="http://schemas.microsoft.com/office/powerpoint/2010/main" val="3774654684"/>
+              </p:ext>
+            </p:extLst>
+          </p:nvPr>
         </p:nvGraphicFramePr>
         <p:xfrm>
           <a:off x="810440" y="5354380"/>
-          <a:ext cx="7518573" cy="1169544"/>
+          <a:ext cx="5804649" cy="1169480"/>
         </p:xfrm>
         <a:graphic>
           <a:graphicData uri="http://schemas.openxmlformats.org/drawingml/2006/table">
             <a:tbl>
-              <a:tblPr firstRow="1" firstCol="1" bandRow="1">
+              <a:tblPr firstRow="1" bandRow="1">
                 <a:tableStyleId>{5C22544A-7EE6-4342-B048-85BDC9FD1C3A}</a:tableStyleId>
               </a:tblPr>
               <a:tblGrid>
-                <a:gridCol w="1713924">
-                  <a:extLst>
-                    <a:ext uri="{9D8B030D-6E8A-4147-A177-3AD203B41FA5}">
-                      <a16:colId xmlns:a16="http://schemas.microsoft.com/office/drawing/2014/main" val="2587052964"/>
-                    </a:ext>
-                  </a:extLst>
-                </a:gridCol>
                 <a:gridCol w="2794831">
                   <a:extLst>
                     <a:ext uri="{9D8B030D-6E8A-4147-A177-3AD203B41FA5}">
@@ -5660,36 +5377,6 @@
                 </a:gridCol>
               </a:tblGrid>
               <a:tr h="771564">
-                <a:tc>
-                  <a:txBody>
-                    <a:bodyPr/>
-                    <a:lstStyle/>
-                    <a:p>
-                      <a:pPr marL="0" marR="0">
-                        <a:lnSpc>
-                          <a:spcPct val="115000"/>
-                        </a:lnSpc>
-                        <a:spcAft>
-                          <a:spcPts val="800"/>
-                        </a:spcAft>
-                        <a:buNone/>
-                      </a:pPr>
-                      <a:r>
-                        <a:rPr lang="en-US" sz="2300" kern="100">
-                          <a:effectLst/>
-                        </a:rPr>
-                        <a:t> </a:t>
-                      </a:r>
-                      <a:endParaRPr lang="en-US" sz="2300" kern="100">
-                        <a:effectLst/>
-                        <a:latin typeface="Aptos" panose="020B0004020202020204" pitchFamily="34" charset="0"/>
-                        <a:ea typeface="Aptos" panose="020B0004020202020204" pitchFamily="34" charset="0"/>
-                        <a:cs typeface="Times New Roman" panose="02020603050405020304" pitchFamily="18" charset="0"/>
-                      </a:endParaRPr>
-                    </a:p>
-                  </a:txBody>
-                  <a:tcPr marL="128992" marR="128992" marT="0" marB="0"/>
-                </a:tc>
                 <a:tc>
                   <a:txBody>
                     <a:bodyPr/>
@@ -5762,36 +5449,6 @@
                     <a:bodyPr/>
                     <a:lstStyle/>
                     <a:p>
-                      <a:pPr marL="0" marR="0">
-                        <a:lnSpc>
-                          <a:spcPct val="115000"/>
-                        </a:lnSpc>
-                        <a:spcAft>
-                          <a:spcPts val="800"/>
-                        </a:spcAft>
-                        <a:buNone/>
-                      </a:pPr>
-                      <a:r>
-                        <a:rPr lang="en-US" sz="2300" kern="100">
-                          <a:effectLst/>
-                        </a:rPr>
-                        <a:t>Result</a:t>
-                      </a:r>
-                      <a:endParaRPr lang="en-US" sz="2300" kern="100">
-                        <a:effectLst/>
-                        <a:latin typeface="Aptos" panose="020B0004020202020204" pitchFamily="34" charset="0"/>
-                        <a:ea typeface="Aptos" panose="020B0004020202020204" pitchFamily="34" charset="0"/>
-                        <a:cs typeface="Times New Roman" panose="02020603050405020304" pitchFamily="18" charset="0"/>
-                      </a:endParaRPr>
-                    </a:p>
-                  </a:txBody>
-                  <a:tcPr marL="128992" marR="128992" marT="0" marB="0"/>
-                </a:tc>
-                <a:tc>
-                  <a:txBody>
-                    <a:bodyPr/>
-                    <a:lstStyle/>
-                    <a:p>
                       <a:pPr marL="0" marR="0" lvl="0" indent="0" algn="l" defTabSz="914400" rtl="0" eaLnBrk="1" fontAlgn="auto" latinLnBrk="0" hangingPunct="1">
                         <a:lnSpc>
                           <a:spcPct val="115000"/>
@@ -5810,7 +5467,7 @@
                         <a:defRPr/>
                       </a:pPr>
                       <a:r>
-                        <a:rPr kumimoji="0" lang="en-US" sz="2300" b="0" i="0" u="none" strike="noStrike" kern="100" cap="none" spc="0" normalizeH="0" baseline="0" noProof="0">
+                        <a:rPr kumimoji="0" lang="en-US" sz="2300" b="0" i="0" u="none" strike="noStrike" kern="100" cap="none" spc="0" normalizeH="0" baseline="0" noProof="0" dirty="0">
                           <a:ln>
                             <a:noFill/>
                           </a:ln>
@@ -5827,7 +5484,7 @@
                         <a:t>Not </a:t>
                       </a:r>
                       <a:r>
-                        <a:rPr kumimoji="0" lang="en-US" sz="2300" b="0" i="0" u="none" strike="noStrike" kern="100" cap="none" spc="0" normalizeH="0" baseline="0" noProof="0">
+                        <a:rPr kumimoji="0" lang="en-US" sz="2300" b="0" i="0" u="none" strike="noStrike" kern="100" cap="none" spc="0" normalizeH="0" baseline="0" noProof="0" dirty="0">
                           <a:ln>
                             <a:noFill/>
                           </a:ln>
@@ -5843,20 +5500,6 @@
                         </a:rPr>
                         <a:t>Detected</a:t>
                       </a:r>
-                      <a:endParaRPr kumimoji="0" lang="en-US" sz="2300" b="0" i="0" u="none" strike="noStrike" kern="100" cap="none" spc="0" normalizeH="0" baseline="0" noProof="0" dirty="0">
-                        <a:ln>
-                          <a:noFill/>
-                        </a:ln>
-                        <a:solidFill>
-                          <a:prstClr val="black"/>
-                        </a:solidFill>
-                        <a:effectLst/>
-                        <a:uLnTx/>
-                        <a:uFillTx/>
-                        <a:latin typeface="Aptos" panose="020B0004020202020204" pitchFamily="34" charset="0"/>
-                        <a:ea typeface="Aptos" panose="020B0004020202020204" pitchFamily="34" charset="0"/>
-                        <a:cs typeface="Times New Roman" panose="02020603050405020304" pitchFamily="18" charset="0"/>
-                      </a:endParaRPr>
                     </a:p>
                   </a:txBody>
                   <a:tcPr marL="128992" marR="128992" marT="0" marB="0"/>
@@ -6087,29 +5730,22 @@
           <p:nvPr>
             <p:extLst>
               <p:ext uri="{D42A27DB-BD31-4B8C-83A1-F6EECF244321}">
-                <p14:modId xmlns:p14="http://schemas.microsoft.com/office/powerpoint/2010/main" val="1609673361"/>
+                <p14:modId xmlns:p14="http://schemas.microsoft.com/office/powerpoint/2010/main" val="2736317000"/>
               </p:ext>
             </p:extLst>
           </p:nvPr>
         </p:nvGraphicFramePr>
         <p:xfrm>
           <a:off x="810440" y="5354380"/>
-          <a:ext cx="7518573" cy="1169544"/>
+          <a:ext cx="5804649" cy="1169480"/>
         </p:xfrm>
         <a:graphic>
           <a:graphicData uri="http://schemas.openxmlformats.org/drawingml/2006/table">
             <a:tbl>
-              <a:tblPr firstRow="1" firstCol="1" bandRow="1">
+              <a:tblPr firstRow="1" bandRow="1">
                 <a:tableStyleId>{5C22544A-7EE6-4342-B048-85BDC9FD1C3A}</a:tableStyleId>
               </a:tblPr>
               <a:tblGrid>
-                <a:gridCol w="1713924">
-                  <a:extLst>
-                    <a:ext uri="{9D8B030D-6E8A-4147-A177-3AD203B41FA5}">
-                      <a16:colId xmlns:a16="http://schemas.microsoft.com/office/drawing/2014/main" val="2587052964"/>
-                    </a:ext>
-                  </a:extLst>
-                </a:gridCol>
                 <a:gridCol w="2794831">
                   <a:extLst>
                     <a:ext uri="{9D8B030D-6E8A-4147-A177-3AD203B41FA5}">
@@ -6126,36 +5762,6 @@
                 </a:gridCol>
               </a:tblGrid>
               <a:tr h="771564">
-                <a:tc>
-                  <a:txBody>
-                    <a:bodyPr/>
-                    <a:lstStyle/>
-                    <a:p>
-                      <a:pPr marL="0" marR="0">
-                        <a:lnSpc>
-                          <a:spcPct val="115000"/>
-                        </a:lnSpc>
-                        <a:spcAft>
-                          <a:spcPts val="800"/>
-                        </a:spcAft>
-                        <a:buNone/>
-                      </a:pPr>
-                      <a:r>
-                        <a:rPr lang="en-US" sz="2300" kern="100">
-                          <a:effectLst/>
-                        </a:rPr>
-                        <a:t> </a:t>
-                      </a:r>
-                      <a:endParaRPr lang="en-US" sz="2300" kern="100">
-                        <a:effectLst/>
-                        <a:latin typeface="Aptos" panose="020B0004020202020204" pitchFamily="34" charset="0"/>
-                        <a:ea typeface="Aptos" panose="020B0004020202020204" pitchFamily="34" charset="0"/>
-                        <a:cs typeface="Times New Roman" panose="02020603050405020304" pitchFamily="18" charset="0"/>
-                      </a:endParaRPr>
-                    </a:p>
-                  </a:txBody>
-                  <a:tcPr marL="128992" marR="128992" marT="0" marB="0"/>
-                </a:tc>
                 <a:tc>
                   <a:txBody>
                     <a:bodyPr/>
@@ -6223,36 +5829,6 @@
                 </a:extLst>
               </a:tr>
               <a:tr h="376109">
-                <a:tc>
-                  <a:txBody>
-                    <a:bodyPr/>
-                    <a:lstStyle/>
-                    <a:p>
-                      <a:pPr marL="0" marR="0">
-                        <a:lnSpc>
-                          <a:spcPct val="115000"/>
-                        </a:lnSpc>
-                        <a:spcAft>
-                          <a:spcPts val="800"/>
-                        </a:spcAft>
-                        <a:buNone/>
-                      </a:pPr>
-                      <a:r>
-                        <a:rPr lang="en-US" sz="2300" kern="100">
-                          <a:effectLst/>
-                        </a:rPr>
-                        <a:t>Result</a:t>
-                      </a:r>
-                      <a:endParaRPr lang="en-US" sz="2300" kern="100">
-                        <a:effectLst/>
-                        <a:latin typeface="Aptos" panose="020B0004020202020204" pitchFamily="34" charset="0"/>
-                        <a:ea typeface="Aptos" panose="020B0004020202020204" pitchFamily="34" charset="0"/>
-                        <a:cs typeface="Times New Roman" panose="02020603050405020304" pitchFamily="18" charset="0"/>
-                      </a:endParaRPr>
-                    </a:p>
-                  </a:txBody>
-                  <a:tcPr marL="128992" marR="128992" marT="0" marB="0"/>
-                </a:tc>
                 <a:tc>
                   <a:txBody>
                     <a:bodyPr/>
@@ -6512,29 +6088,22 @@
           <p:nvPr>
             <p:extLst>
               <p:ext uri="{D42A27DB-BD31-4B8C-83A1-F6EECF244321}">
-                <p14:modId xmlns:p14="http://schemas.microsoft.com/office/powerpoint/2010/main" val="3517563960"/>
+                <p14:modId xmlns:p14="http://schemas.microsoft.com/office/powerpoint/2010/main" val="3738674446"/>
               </p:ext>
             </p:extLst>
           </p:nvPr>
         </p:nvGraphicFramePr>
         <p:xfrm>
           <a:off x="810440" y="5354380"/>
-          <a:ext cx="7518573" cy="1169544"/>
+          <a:ext cx="5804649" cy="1169480"/>
         </p:xfrm>
         <a:graphic>
           <a:graphicData uri="http://schemas.openxmlformats.org/drawingml/2006/table">
             <a:tbl>
-              <a:tblPr firstRow="1" firstCol="1" bandRow="1">
+              <a:tblPr firstRow="1" bandRow="1">
                 <a:tableStyleId>{5C22544A-7EE6-4342-B048-85BDC9FD1C3A}</a:tableStyleId>
               </a:tblPr>
               <a:tblGrid>
-                <a:gridCol w="1713924">
-                  <a:extLst>
-                    <a:ext uri="{9D8B030D-6E8A-4147-A177-3AD203B41FA5}">
-                      <a16:colId xmlns:a16="http://schemas.microsoft.com/office/drawing/2014/main" val="2587052964"/>
-                    </a:ext>
-                  </a:extLst>
-                </a:gridCol>
                 <a:gridCol w="2794831">
                   <a:extLst>
                     <a:ext uri="{9D8B030D-6E8A-4147-A177-3AD203B41FA5}">
@@ -6566,42 +6135,12 @@
                         <a:buNone/>
                       </a:pPr>
                       <a:r>
-                        <a:rPr lang="en-US" sz="2300" kern="100">
-                          <a:effectLst/>
-                        </a:rPr>
-                        <a:t> </a:t>
-                      </a:r>
-                      <a:endParaRPr lang="en-US" sz="2300" kern="100">
-                        <a:effectLst/>
-                        <a:latin typeface="Aptos" panose="020B0004020202020204" pitchFamily="34" charset="0"/>
-                        <a:ea typeface="Aptos" panose="020B0004020202020204" pitchFamily="34" charset="0"/>
-                        <a:cs typeface="Times New Roman" panose="02020603050405020304" pitchFamily="18" charset="0"/>
-                      </a:endParaRPr>
-                    </a:p>
-                  </a:txBody>
-                  <a:tcPr marL="128992" marR="128992" marT="0" marB="0"/>
-                </a:tc>
-                <a:tc>
-                  <a:txBody>
-                    <a:bodyPr/>
-                    <a:lstStyle/>
-                    <a:p>
-                      <a:pPr marL="0" marR="0">
-                        <a:lnSpc>
-                          <a:spcPct val="115000"/>
-                        </a:lnSpc>
-                        <a:spcAft>
-                          <a:spcPts val="800"/>
-                        </a:spcAft>
-                        <a:buNone/>
-                      </a:pPr>
-                      <a:r>
-                        <a:rPr lang="en-US" sz="2300" kern="100">
+                        <a:rPr lang="en-US" sz="2300" kern="100" dirty="0">
                           <a:effectLst/>
                         </a:rPr>
                         <a:t>A11y automated checker</a:t>
                       </a:r>
-                      <a:endParaRPr lang="en-US" sz="2300" kern="100">
+                      <a:endParaRPr lang="en-US" sz="2300" kern="100" dirty="0">
                         <a:effectLst/>
                         <a:latin typeface="Aptos" panose="020B0004020202020204" pitchFamily="34" charset="0"/>
                         <a:ea typeface="Aptos" panose="020B0004020202020204" pitchFamily="34" charset="0"/>
@@ -6653,36 +6192,6 @@
                     <a:bodyPr/>
                     <a:lstStyle/>
                     <a:p>
-                      <a:pPr marL="0" marR="0">
-                        <a:lnSpc>
-                          <a:spcPct val="115000"/>
-                        </a:lnSpc>
-                        <a:spcAft>
-                          <a:spcPts val="800"/>
-                        </a:spcAft>
-                        <a:buNone/>
-                      </a:pPr>
-                      <a:r>
-                        <a:rPr lang="en-US" sz="2300" kern="100">
-                          <a:effectLst/>
-                        </a:rPr>
-                        <a:t>Result</a:t>
-                      </a:r>
-                      <a:endParaRPr lang="en-US" sz="2300" kern="100">
-                        <a:effectLst/>
-                        <a:latin typeface="Aptos" panose="020B0004020202020204" pitchFamily="34" charset="0"/>
-                        <a:ea typeface="Aptos" panose="020B0004020202020204" pitchFamily="34" charset="0"/>
-                        <a:cs typeface="Times New Roman" panose="02020603050405020304" pitchFamily="18" charset="0"/>
-                      </a:endParaRPr>
-                    </a:p>
-                  </a:txBody>
-                  <a:tcPr marL="128992" marR="128992" marT="0" marB="0"/>
-                </a:tc>
-                <a:tc>
-                  <a:txBody>
-                    <a:bodyPr/>
-                    <a:lstStyle/>
-                    <a:p>
                       <a:pPr marL="0" marR="0" lvl="0" indent="0" algn="l" defTabSz="914400" rtl="0" eaLnBrk="1" fontAlgn="auto" latinLnBrk="0" hangingPunct="1">
                         <a:lnSpc>
                           <a:spcPct val="115000"/>
@@ -6701,7 +6210,7 @@
                         <a:defRPr/>
                       </a:pPr>
                       <a:r>
-                        <a:rPr kumimoji="0" lang="en-US" sz="2300" b="0" i="0" u="none" strike="noStrike" kern="100" cap="none" spc="0" normalizeH="0" baseline="0" noProof="0">
+                        <a:rPr kumimoji="0" lang="en-US" sz="2300" b="0" i="0" u="none" strike="noStrike" kern="100" cap="none" spc="0" normalizeH="0" baseline="0" noProof="0" dirty="0">
                           <a:ln>
                             <a:noFill/>
                           </a:ln>
@@ -6718,7 +6227,7 @@
                         <a:t>Not </a:t>
                       </a:r>
                       <a:r>
-                        <a:rPr kumimoji="0" lang="en-US" sz="2300" b="0" i="0" u="none" strike="noStrike" kern="100" cap="none" spc="0" normalizeH="0" baseline="0" noProof="0">
+                        <a:rPr kumimoji="0" lang="en-US" sz="2300" b="0" i="0" u="none" strike="noStrike" kern="100" cap="none" spc="0" normalizeH="0" baseline="0" noProof="0" dirty="0">
                           <a:ln>
                             <a:noFill/>
                           </a:ln>
@@ -6734,20 +6243,6 @@
                         </a:rPr>
                         <a:t>Detected</a:t>
                       </a:r>
-                      <a:endParaRPr kumimoji="0" lang="en-US" sz="2300" b="0" i="0" u="none" strike="noStrike" kern="100" cap="none" spc="0" normalizeH="0" baseline="0" noProof="0" dirty="0">
-                        <a:ln>
-                          <a:noFill/>
-                        </a:ln>
-                        <a:solidFill>
-                          <a:prstClr val="black"/>
-                        </a:solidFill>
-                        <a:effectLst/>
-                        <a:uLnTx/>
-                        <a:uFillTx/>
-                        <a:latin typeface="Aptos" panose="020B0004020202020204" pitchFamily="34" charset="0"/>
-                        <a:ea typeface="Aptos" panose="020B0004020202020204" pitchFamily="34" charset="0"/>
-                        <a:cs typeface="Times New Roman" panose="02020603050405020304" pitchFamily="18" charset="0"/>
-                      </a:endParaRPr>
                     </a:p>
                   </a:txBody>
                   <a:tcPr marL="128992" marR="128992" marT="0" marB="0"/>
@@ -6977,29 +6472,22 @@
           <p:nvPr>
             <p:extLst>
               <p:ext uri="{D42A27DB-BD31-4B8C-83A1-F6EECF244321}">
-                <p14:modId xmlns:p14="http://schemas.microsoft.com/office/powerpoint/2010/main" val="197830095"/>
+                <p14:modId xmlns:p14="http://schemas.microsoft.com/office/powerpoint/2010/main" val="1276533915"/>
               </p:ext>
             </p:extLst>
           </p:nvPr>
         </p:nvGraphicFramePr>
         <p:xfrm>
           <a:off x="810440" y="5354380"/>
-          <a:ext cx="7518573" cy="1169544"/>
+          <a:ext cx="5804649" cy="1169480"/>
         </p:xfrm>
         <a:graphic>
           <a:graphicData uri="http://schemas.openxmlformats.org/drawingml/2006/table">
             <a:tbl>
-              <a:tblPr firstRow="1" firstCol="1" bandRow="1">
+              <a:tblPr firstRow="1" bandRow="1">
                 <a:tableStyleId>{5C22544A-7EE6-4342-B048-85BDC9FD1C3A}</a:tableStyleId>
               </a:tblPr>
               <a:tblGrid>
-                <a:gridCol w="1713924">
-                  <a:extLst>
-                    <a:ext uri="{9D8B030D-6E8A-4147-A177-3AD203B41FA5}">
-                      <a16:colId xmlns:a16="http://schemas.microsoft.com/office/drawing/2014/main" val="2587052964"/>
-                    </a:ext>
-                  </a:extLst>
-                </a:gridCol>
                 <a:gridCol w="2794831">
                   <a:extLst>
                     <a:ext uri="{9D8B030D-6E8A-4147-A177-3AD203B41FA5}">
@@ -7031,42 +6519,12 @@
                         <a:buNone/>
                       </a:pPr>
                       <a:r>
-                        <a:rPr lang="en-US" sz="2300" kern="100">
-                          <a:effectLst/>
-                        </a:rPr>
-                        <a:t> </a:t>
-                      </a:r>
-                      <a:endParaRPr lang="en-US" sz="2300" kern="100">
-                        <a:effectLst/>
-                        <a:latin typeface="Aptos" panose="020B0004020202020204" pitchFamily="34" charset="0"/>
-                        <a:ea typeface="Aptos" panose="020B0004020202020204" pitchFamily="34" charset="0"/>
-                        <a:cs typeface="Times New Roman" panose="02020603050405020304" pitchFamily="18" charset="0"/>
-                      </a:endParaRPr>
-                    </a:p>
-                  </a:txBody>
-                  <a:tcPr marL="128992" marR="128992" marT="0" marB="0"/>
-                </a:tc>
-                <a:tc>
-                  <a:txBody>
-                    <a:bodyPr/>
-                    <a:lstStyle/>
-                    <a:p>
-                      <a:pPr marL="0" marR="0">
-                        <a:lnSpc>
-                          <a:spcPct val="115000"/>
-                        </a:lnSpc>
-                        <a:spcAft>
-                          <a:spcPts val="800"/>
-                        </a:spcAft>
-                        <a:buNone/>
-                      </a:pPr>
-                      <a:r>
-                        <a:rPr lang="en-US" sz="2300" kern="100">
+                        <a:rPr lang="en-US" sz="2300" kern="100" dirty="0">
                           <a:effectLst/>
                         </a:rPr>
                         <a:t>A11y automated checker</a:t>
                       </a:r>
-                      <a:endParaRPr lang="en-US" sz="2300" kern="100">
+                      <a:endParaRPr lang="en-US" sz="2300" kern="100" dirty="0">
                         <a:effectLst/>
                         <a:latin typeface="Aptos" panose="020B0004020202020204" pitchFamily="34" charset="0"/>
                         <a:ea typeface="Aptos" panose="020B0004020202020204" pitchFamily="34" charset="0"/>
@@ -7118,36 +6576,6 @@
                     <a:bodyPr/>
                     <a:lstStyle/>
                     <a:p>
-                      <a:pPr marL="0" marR="0">
-                        <a:lnSpc>
-                          <a:spcPct val="115000"/>
-                        </a:lnSpc>
-                        <a:spcAft>
-                          <a:spcPts val="800"/>
-                        </a:spcAft>
-                        <a:buNone/>
-                      </a:pPr>
-                      <a:r>
-                        <a:rPr lang="en-US" sz="2300" kern="100">
-                          <a:effectLst/>
-                        </a:rPr>
-                        <a:t>Result</a:t>
-                      </a:r>
-                      <a:endParaRPr lang="en-US" sz="2300" kern="100">
-                        <a:effectLst/>
-                        <a:latin typeface="Aptos" panose="020B0004020202020204" pitchFamily="34" charset="0"/>
-                        <a:ea typeface="Aptos" panose="020B0004020202020204" pitchFamily="34" charset="0"/>
-                        <a:cs typeface="Times New Roman" panose="02020603050405020304" pitchFamily="18" charset="0"/>
-                      </a:endParaRPr>
-                    </a:p>
-                  </a:txBody>
-                  <a:tcPr marL="128992" marR="128992" marT="0" marB="0"/>
-                </a:tc>
-                <a:tc>
-                  <a:txBody>
-                    <a:bodyPr/>
-                    <a:lstStyle/>
-                    <a:p>
                       <a:pPr marL="0" marR="0" lvl="0" indent="0" algn="l" defTabSz="914400" rtl="0" eaLnBrk="1" fontAlgn="auto" latinLnBrk="0" hangingPunct="1">
                         <a:lnSpc>
                           <a:spcPct val="115000"/>
@@ -7166,7 +6594,7 @@
                         <a:defRPr/>
                       </a:pPr>
                       <a:r>
-                        <a:rPr kumimoji="0" lang="en-US" sz="2300" b="0" i="0" u="none" strike="noStrike" kern="100" cap="none" spc="0" normalizeH="0" baseline="0" noProof="0">
+                        <a:rPr kumimoji="0" lang="en-US" sz="2300" b="0" i="0" u="none" strike="noStrike" kern="100" cap="none" spc="0" normalizeH="0" baseline="0" noProof="0" dirty="0">
                           <a:ln>
                             <a:noFill/>
                           </a:ln>
@@ -7183,7 +6611,7 @@
                         <a:t>Not </a:t>
                       </a:r>
                       <a:r>
-                        <a:rPr kumimoji="0" lang="en-US" sz="2300" b="0" i="0" u="none" strike="noStrike" kern="100" cap="none" spc="0" normalizeH="0" baseline="0" noProof="0">
+                        <a:rPr kumimoji="0" lang="en-US" sz="2300" b="0" i="0" u="none" strike="noStrike" kern="100" cap="none" spc="0" normalizeH="0" baseline="0" noProof="0" dirty="0">
                           <a:ln>
                             <a:noFill/>
                           </a:ln>
@@ -7199,20 +6627,6 @@
                         </a:rPr>
                         <a:t>Detected</a:t>
                       </a:r>
-                      <a:endParaRPr kumimoji="0" lang="en-US" sz="2300" b="0" i="0" u="none" strike="noStrike" kern="100" cap="none" spc="0" normalizeH="0" baseline="0" noProof="0" dirty="0">
-                        <a:ln>
-                          <a:noFill/>
-                        </a:ln>
-                        <a:solidFill>
-                          <a:prstClr val="black"/>
-                        </a:solidFill>
-                        <a:effectLst/>
-                        <a:uLnTx/>
-                        <a:uFillTx/>
-                        <a:latin typeface="Aptos" panose="020B0004020202020204" pitchFamily="34" charset="0"/>
-                        <a:ea typeface="Aptos" panose="020B0004020202020204" pitchFamily="34" charset="0"/>
-                        <a:cs typeface="Times New Roman" panose="02020603050405020304" pitchFamily="18" charset="0"/>
-                      </a:endParaRPr>
                     </a:p>
                   </a:txBody>
                   <a:tcPr marL="128992" marR="128992" marT="0" marB="0"/>

</xml_diff>